<commit_message>
Update Module 0 slides.
</commit_message>
<xml_diff>
--- a/Slides/Artificial_Intelligence_Module0.pptx
+++ b/Slides/Artificial_Intelligence_Module0.pptx
@@ -209,7 +209,7 @@
           <a:p>
             <a:fld id="{09E66CB0-D60F-4BE5-83D4-0DD72108AD14}" type="datetimeFigureOut">
               <a:rPr lang="en-US" smtClean="0"/>
-              <a:t>6/12/2026</a:t>
+              <a:t>6/19/2026</a:t>
             </a:fld>
             <a:endParaRPr lang="en-US"/>
           </a:p>
@@ -1030,6 +1030,90 @@
 </p:notes>
 </file>
 
+<file path=ppt/notesSlides/notesSlide12.xml><?xml version="1.0" encoding="utf-8"?>
+<p:notes xmlns:a="http://schemas.openxmlformats.org/drawingml/2006/main" xmlns:r="http://schemas.openxmlformats.org/officeDocument/2006/relationships" xmlns:p="http://schemas.openxmlformats.org/presentationml/2006/main">
+  <p:cSld>
+    <p:spTree>
+      <p:nvGrpSpPr>
+        <p:cNvPr id="1" name=""/>
+        <p:cNvGrpSpPr/>
+        <p:nvPr/>
+      </p:nvGrpSpPr>
+      <p:grpSpPr>
+        <a:xfrm>
+          <a:off x="0" y="0"/>
+          <a:ext cx="0" cy="0"/>
+          <a:chOff x="0" y="0"/>
+          <a:chExt cx="0" cy="0"/>
+        </a:xfrm>
+      </p:grpSpPr>
+      <p:sp>
+        <p:nvSpPr>
+          <p:cNvPr id="2" name="Slide Image Placeholder 1"/>
+          <p:cNvSpPr>
+            <a:spLocks noGrp="1" noRot="1" noChangeAspect="1"/>
+          </p:cNvSpPr>
+          <p:nvPr>
+            <p:ph type="sldImg"/>
+          </p:nvPr>
+        </p:nvSpPr>
+        <p:spPr/>
+      </p:sp>
+      <p:sp>
+        <p:nvSpPr>
+          <p:cNvPr id="3" name="Notes Placeholder 2"/>
+          <p:cNvSpPr>
+            <a:spLocks noGrp="1"/>
+          </p:cNvSpPr>
+          <p:nvPr>
+            <p:ph type="body" idx="1"/>
+          </p:nvPr>
+        </p:nvSpPr>
+        <p:spPr/>
+        <p:txBody>
+          <a:bodyPr/>
+          <a:lstStyle/>
+          <a:p>
+            <a:endParaRPr lang="en-US"/>
+          </a:p>
+        </p:txBody>
+      </p:sp>
+      <p:sp>
+        <p:nvSpPr>
+          <p:cNvPr id="4" name="Slide Number Placeholder 3"/>
+          <p:cNvSpPr>
+            <a:spLocks noGrp="1"/>
+          </p:cNvSpPr>
+          <p:nvPr>
+            <p:ph type="sldNum" sz="quarter" idx="5"/>
+          </p:nvPr>
+        </p:nvSpPr>
+        <p:spPr/>
+        <p:txBody>
+          <a:bodyPr/>
+          <a:lstStyle/>
+          <a:p>
+            <a:fld id="{2CCF031E-D17A-4139-B770-A41292C01C8F}" type="slidenum">
+              <a:rPr lang="en-US" smtClean="0"/>
+              <a:t>13</a:t>
+            </a:fld>
+            <a:endParaRPr lang="en-US"/>
+          </a:p>
+        </p:txBody>
+      </p:sp>
+    </p:spTree>
+    <p:extLst>
+      <p:ext uri="{BB962C8B-B14F-4D97-AF65-F5344CB8AC3E}">
+        <p14:creationId xmlns:p14="http://schemas.microsoft.com/office/powerpoint/2010/main" val="229305186"/>
+      </p:ext>
+    </p:extLst>
+  </p:cSld>
+  <p:clrMapOvr>
+    <a:masterClrMapping/>
+  </p:clrMapOvr>
+</p:notes>
+</file>
+
 <file path=ppt/notesSlides/notesSlide2.xml><?xml version="1.0" encoding="utf-8"?>
 <p:notes xmlns:a="http://schemas.openxmlformats.org/drawingml/2006/main" xmlns:r="http://schemas.openxmlformats.org/officeDocument/2006/relationships" xmlns:p="http://schemas.openxmlformats.org/presentationml/2006/main">
   <p:cSld>
@@ -1109,7 +1193,7 @@
                 <a:ea typeface="+mn-ea"/>
                 <a:cs typeface="+mn-cs"/>
               </a:rPr>
-              <a:t>McCarthy points out that we don't have a universal definition of intelligence yet, and this remains true to today. We call things intelligent when they solve tasks that used to require a human brain (like translating languages, playing chess or go, and driving a car), but as soon as a machine masters a task, we often stop calling it true intelligence and just call it software. This is a phenomenon known in computer science as the </a:t>
+              <a:t>McCarthy points out that we don't have a universal definition of intelligence yet, and this remains true to today. We call things intelligent when they solve tasks that used to require a human brain (like translating languages, playing chess or go, or driving a car), but as soon as a machine masters a task, we often stop calling it true intelligence and just call it software. This is a phenomenon known in computer science as the </a:t>
             </a:r>
             <a:r>
               <a:rPr lang="en-US" sz="1200" b="1" kern="1200" dirty="0">
@@ -1639,7 +1723,7 @@
             </a:r>
             <a:r>
               <a:rPr lang="en-US" dirty="0"/>
-              <a:t>we can understand that the founding fathers themselves didn't agree on a single path to intelligence. </a:t>
+              <a:t>we can understand that the founding fathers of AI didn't agree on a single path to intelligence. </a:t>
             </a:r>
             <a:endParaRPr lang="en-US" b="1" dirty="0"/>
           </a:p>
@@ -1738,7 +1822,7 @@
             </a:r>
             <a:r>
               <a:rPr lang="en-US" dirty="0"/>
-              <a:t> It successfully found brilliant, step-by-step logical proofs for 38 theorems from Bertrand Russell’s </a:t>
+              <a:t> It successfully found, step-by-step logical proofs for 38 theorems from Bertrand Russell’s </a:t>
             </a:r>
             <a:r>
               <a:rPr lang="en-US" i="1" dirty="0"/>
@@ -1746,7 +1830,7 @@
             </a:r>
             <a:r>
               <a:rPr lang="en-US" dirty="0"/>
-              <a:t>—even finding a proof for one theorem that was shorter and more elegant than the one Russell had written himself. It was a massive milestone for rule-based, symbolic AI.</a:t>
+              <a:t> and even found a proof for one theorem that was shorter and more elegant than the one Russell had written himself. It was a massive milestone for rule-based, symbolic AI.</a:t>
             </a:r>
           </a:p>
           <a:p>
@@ -1818,7 +1902,7 @@
             </a:r>
             <a:r>
               <a:rPr lang="en-US" dirty="0"/>
-              <a:t> (List Processing) in 1958—the programming language that became the standard for AI research for decades.</a:t>
+              <a:t> (List Processing) in 1958, the programming language that became the standard for AI research for decades.</a:t>
             </a:r>
           </a:p>
           <a:p>
@@ -2786,7 +2870,7 @@
           <a:p>
             <a:r>
               <a:rPr lang="en-US" dirty="0"/>
-              <a:t>– Searle cannot understand any Chinese .</a:t>
+              <a:t>– Searle cannot understand any Chinese.</a:t>
             </a:r>
           </a:p>
           <a:p>
@@ -2975,7 +3059,7 @@
           <a:p>
             <a:r>
               <a:rPr lang="en-US" dirty="0"/>
-              <a:t>This is an interesting fictional test from the 1982 movie Blade Runner. This movie is set in a dystopian, cyberpunk future, the story follows Rick Deckard, a specialize police officer known as a Blade Runner. His job is to track down and "retire" (execute) </a:t>
+              <a:t>This is an interesting fictional test from the 1982 movie Blade Runner. This movie is set in a dystopian, cyberpunk future. The story follows Rick Deckard, a specialized police officer known as a Blade Runner. His job is to track down and "retire" (execute) </a:t>
             </a:r>
             <a:r>
               <a:rPr lang="en-US" b="0" dirty="0"/>
@@ -3497,7 +3581,7 @@
           <a:p>
             <a:fld id="{D7E3ECEC-7E7B-4FB9-BAE8-5C10F12795EA}" type="datetimeFigureOut">
               <a:rPr lang="en-US" smtClean="0"/>
-              <a:t>6/12/2026</a:t>
+              <a:t>6/19/2026</a:t>
             </a:fld>
             <a:endParaRPr lang="en-US"/>
           </a:p>
@@ -3926,7 +4010,7 @@
           <a:p>
             <a:fld id="{D7E3ECEC-7E7B-4FB9-BAE8-5C10F12795EA}" type="datetimeFigureOut">
               <a:rPr lang="en-US" smtClean="0"/>
-              <a:t>6/12/2026</a:t>
+              <a:t>6/19/2026</a:t>
             </a:fld>
             <a:endParaRPr lang="en-US"/>
           </a:p>
@@ -4422,7 +4506,7 @@
           <a:p>
             <a:fld id="{D7E3ECEC-7E7B-4FB9-BAE8-5C10F12795EA}" type="datetimeFigureOut">
               <a:rPr lang="en-US" smtClean="0"/>
-              <a:t>6/12/2026</a:t>
+              <a:t>6/19/2026</a:t>
             </a:fld>
             <a:endParaRPr lang="en-US"/>
           </a:p>
@@ -4800,7 +4884,7 @@
           <a:p>
             <a:fld id="{D7E3ECEC-7E7B-4FB9-BAE8-5C10F12795EA}" type="datetimeFigureOut">
               <a:rPr lang="en-US" smtClean="0"/>
-              <a:t>6/12/2026</a:t>
+              <a:t>6/19/2026</a:t>
             </a:fld>
             <a:endParaRPr lang="en-US"/>
           </a:p>
@@ -5044,7 +5128,7 @@
           <a:p>
             <a:fld id="{D7E3ECEC-7E7B-4FB9-BAE8-5C10F12795EA}" type="datetimeFigureOut">
               <a:rPr lang="en-US" smtClean="0"/>
-              <a:t>6/12/2026</a:t>
+              <a:t>6/19/2026</a:t>
             </a:fld>
             <a:endParaRPr lang="en-US"/>
           </a:p>
@@ -5278,7 +5362,7 @@
           <a:p>
             <a:fld id="{D7E3ECEC-7E7B-4FB9-BAE8-5C10F12795EA}" type="datetimeFigureOut">
               <a:rPr lang="en-US" smtClean="0"/>
-              <a:t>6/12/2026</a:t>
+              <a:t>6/19/2026</a:t>
             </a:fld>
             <a:endParaRPr lang="en-US"/>
           </a:p>
@@ -5512,7 +5596,7 @@
           <a:p>
             <a:fld id="{D7E3ECEC-7E7B-4FB9-BAE8-5C10F12795EA}" type="datetimeFigureOut">
               <a:rPr lang="en-US" smtClean="0"/>
-              <a:t>6/12/2026</a:t>
+              <a:t>6/19/2026</a:t>
             </a:fld>
             <a:endParaRPr lang="en-US"/>
           </a:p>
@@ -5746,7 +5830,7 @@
           <a:p>
             <a:fld id="{D7E3ECEC-7E7B-4FB9-BAE8-5C10F12795EA}" type="datetimeFigureOut">
               <a:rPr lang="en-US" smtClean="0"/>
-              <a:t>6/12/2026</a:t>
+              <a:t>6/19/2026</a:t>
             </a:fld>
             <a:endParaRPr lang="en-US"/>
           </a:p>
@@ -5980,7 +6064,7 @@
           <a:p>
             <a:fld id="{D7E3ECEC-7E7B-4FB9-BAE8-5C10F12795EA}" type="datetimeFigureOut">
               <a:rPr lang="en-US" smtClean="0"/>
-              <a:t>6/12/2026</a:t>
+              <a:t>6/19/2026</a:t>
             </a:fld>
             <a:endParaRPr lang="en-US"/>
           </a:p>
@@ -6304,7 +6388,7 @@
           <a:p>
             <a:fld id="{D7E3ECEC-7E7B-4FB9-BAE8-5C10F12795EA}" type="datetimeFigureOut">
               <a:rPr lang="en-US" smtClean="0"/>
-              <a:t>6/12/2026</a:t>
+              <a:t>6/19/2026</a:t>
             </a:fld>
             <a:endParaRPr lang="en-US"/>
           </a:p>
@@ -6533,7 +6617,7 @@
           <a:p>
             <a:fld id="{D7E3ECEC-7E7B-4FB9-BAE8-5C10F12795EA}" type="datetimeFigureOut">
               <a:rPr lang="en-US" smtClean="0"/>
-              <a:t>6/12/2026</a:t>
+              <a:t>6/19/2026</a:t>
             </a:fld>
             <a:endParaRPr lang="en-US"/>
           </a:p>
@@ -6869,7 +6953,7 @@
           <a:p>
             <a:fld id="{D7E3ECEC-7E7B-4FB9-BAE8-5C10F12795EA}" type="datetimeFigureOut">
               <a:rPr lang="en-US" smtClean="0"/>
-              <a:t>6/12/2026</a:t>
+              <a:t>6/19/2026</a:t>
             </a:fld>
             <a:endParaRPr lang="en-US"/>
           </a:p>
@@ -7202,7 +7286,7 @@
           <a:p>
             <a:fld id="{D7E3ECEC-7E7B-4FB9-BAE8-5C10F12795EA}" type="datetimeFigureOut">
               <a:rPr lang="en-US" smtClean="0"/>
-              <a:t>6/12/2026</a:t>
+              <a:t>6/19/2026</a:t>
             </a:fld>
             <a:endParaRPr lang="en-US"/>
           </a:p>
@@ -7544,7 +7628,7 @@
           <a:p>
             <a:fld id="{D7E3ECEC-7E7B-4FB9-BAE8-5C10F12795EA}" type="datetimeFigureOut">
               <a:rPr lang="en-US" smtClean="0"/>
-              <a:t>6/12/2026</a:t>
+              <a:t>6/19/2026</a:t>
             </a:fld>
             <a:endParaRPr lang="en-US"/>
           </a:p>
@@ -7882,7 +7966,7 @@
           <a:p>
             <a:fld id="{D7E3ECEC-7E7B-4FB9-BAE8-5C10F12795EA}" type="datetimeFigureOut">
               <a:rPr lang="en-US" smtClean="0"/>
-              <a:t>6/12/2026</a:t>
+              <a:t>6/19/2026</a:t>
             </a:fld>
             <a:endParaRPr lang="en-US"/>
           </a:p>
@@ -8197,7 +8281,7 @@
           <a:p>
             <a:fld id="{D7E3ECEC-7E7B-4FB9-BAE8-5C10F12795EA}" type="datetimeFigureOut">
               <a:rPr lang="en-US" smtClean="0"/>
-              <a:t>6/12/2026</a:t>
+              <a:t>6/19/2026</a:t>
             </a:fld>
             <a:endParaRPr lang="en-US"/>
           </a:p>
@@ -8512,7 +8596,7 @@
           <a:p>
             <a:fld id="{D7E3ECEC-7E7B-4FB9-BAE8-5C10F12795EA}" type="datetimeFigureOut">
               <a:rPr lang="en-US" smtClean="0"/>
-              <a:t>6/12/2026</a:t>
+              <a:t>6/19/2026</a:t>
             </a:fld>
             <a:endParaRPr lang="en-US"/>
           </a:p>
@@ -8836,7 +8920,7 @@
           <a:p>
             <a:fld id="{D7E3ECEC-7E7B-4FB9-BAE8-5C10F12795EA}" type="datetimeFigureOut">
               <a:rPr lang="en-US" smtClean="0"/>
-              <a:t>6/12/2026</a:t>
+              <a:t>6/19/2026</a:t>
             </a:fld>
             <a:endParaRPr lang="en-US"/>
           </a:p>
@@ -9178,7 +9262,7 @@
           <a:p>
             <a:fld id="{D7E3ECEC-7E7B-4FB9-BAE8-5C10F12795EA}" type="datetimeFigureOut">
               <a:rPr lang="en-US" smtClean="0"/>
-              <a:t>6/12/2026</a:t>
+              <a:t>6/19/2026</a:t>
             </a:fld>
             <a:endParaRPr lang="en-US"/>
           </a:p>
@@ -9440,7 +9524,7 @@
           <a:p>
             <a:fld id="{D7E3ECEC-7E7B-4FB9-BAE8-5C10F12795EA}" type="datetimeFigureOut">
               <a:rPr lang="en-US" smtClean="0"/>
-              <a:t>6/12/2026</a:t>
+              <a:t>6/19/2026</a:t>
             </a:fld>
             <a:endParaRPr lang="en-US"/>
           </a:p>
@@ -9901,7 +9985,7 @@
           <a:p>
             <a:fld id="{D7E3ECEC-7E7B-4FB9-BAE8-5C10F12795EA}" type="datetimeFigureOut">
               <a:rPr lang="en-US" smtClean="0"/>
-              <a:t>6/12/2026</a:t>
+              <a:t>6/19/2026</a:t>
             </a:fld>
             <a:endParaRPr lang="en-US"/>
           </a:p>
@@ -10240,7 +10324,7 @@
           <a:p>
             <a:fld id="{D7E3ECEC-7E7B-4FB9-BAE8-5C10F12795EA}" type="datetimeFigureOut">
               <a:rPr lang="en-US" smtClean="0"/>
-              <a:t>6/12/2026</a:t>
+              <a:t>6/19/2026</a:t>
             </a:fld>
             <a:endParaRPr lang="en-US"/>
           </a:p>
@@ -10566,7 +10650,7 @@
           <a:p>
             <a:fld id="{D7E3ECEC-7E7B-4FB9-BAE8-5C10F12795EA}" type="datetimeFigureOut">
               <a:rPr lang="en-US" smtClean="0"/>
-              <a:t>6/12/2026</a:t>
+              <a:t>6/19/2026</a:t>
             </a:fld>
             <a:endParaRPr lang="en-US"/>
           </a:p>
@@ -10753,7 +10837,7 @@
           <a:p>
             <a:fld id="{D7E3ECEC-7E7B-4FB9-BAE8-5C10F12795EA}" type="datetimeFigureOut">
               <a:rPr lang="en-US" smtClean="0"/>
-              <a:t>6/12/2026</a:t>
+              <a:t>6/19/2026</a:t>
             </a:fld>
             <a:endParaRPr lang="en-US"/>
           </a:p>
@@ -11282,7 +11366,7 @@
           <a:p>
             <a:fld id="{D7E3ECEC-7E7B-4FB9-BAE8-5C10F12795EA}" type="datetimeFigureOut">
               <a:rPr lang="en-US" smtClean="0"/>
-              <a:t>6/12/2026</a:t>
+              <a:t>6/19/2026</a:t>
             </a:fld>
             <a:endParaRPr lang="en-US"/>
           </a:p>
@@ -11607,7 +11691,7 @@
           <a:p>
             <a:fld id="{D7E3ECEC-7E7B-4FB9-BAE8-5C10F12795EA}" type="datetimeFigureOut">
               <a:rPr lang="en-US" smtClean="0"/>
-              <a:t>6/12/2026</a:t>
+              <a:t>6/19/2026</a:t>
             </a:fld>
             <a:endParaRPr lang="en-US"/>
           </a:p>
@@ -11937,7 +12021,7 @@
           <a:p>
             <a:fld id="{D7E3ECEC-7E7B-4FB9-BAE8-5C10F12795EA}" type="datetimeFigureOut">
               <a:rPr lang="en-US" smtClean="0"/>
-              <a:t>6/12/2026</a:t>
+              <a:t>6/19/2026</a:t>
             </a:fld>
             <a:endParaRPr lang="en-US"/>
           </a:p>
@@ -12273,7 +12357,7 @@
           <a:p>
             <a:fld id="{D7E3ECEC-7E7B-4FB9-BAE8-5C10F12795EA}" type="datetimeFigureOut">
               <a:rPr lang="en-US" smtClean="0"/>
-              <a:t>6/12/2026</a:t>
+              <a:t>6/19/2026</a:t>
             </a:fld>
             <a:endParaRPr lang="en-US"/>
           </a:p>
@@ -12573,7 +12657,7 @@
           <a:p>
             <a:fld id="{D7E3ECEC-7E7B-4FB9-BAE8-5C10F12795EA}" type="datetimeFigureOut">
               <a:rPr lang="en-US" smtClean="0"/>
-              <a:t>6/12/2026</a:t>
+              <a:t>6/19/2026</a:t>
             </a:fld>
             <a:endParaRPr lang="en-US"/>
           </a:p>
@@ -12955,7 +13039,7 @@
           <a:p>
             <a:fld id="{D7E3ECEC-7E7B-4FB9-BAE8-5C10F12795EA}" type="datetimeFigureOut">
               <a:rPr lang="en-US" smtClean="0"/>
-              <a:t>6/12/2026</a:t>
+              <a:t>6/19/2026</a:t>
             </a:fld>
             <a:endParaRPr lang="en-US"/>
           </a:p>
@@ -13418,7 +13502,7 @@
           <a:p>
             <a:fld id="{D7E3ECEC-7E7B-4FB9-BAE8-5C10F12795EA}" type="datetimeFigureOut">
               <a:rPr lang="en-US" smtClean="0"/>
-              <a:t>6/12/2026</a:t>
+              <a:t>6/19/2026</a:t>
             </a:fld>
             <a:endParaRPr lang="en-US"/>
           </a:p>
@@ -13759,7 +13843,7 @@
           <a:p>
             <a:fld id="{D7E3ECEC-7E7B-4FB9-BAE8-5C10F12795EA}" type="datetimeFigureOut">
               <a:rPr lang="en-US" smtClean="0"/>
-              <a:t>6/12/2026</a:t>
+              <a:t>6/19/2026</a:t>
             </a:fld>
             <a:endParaRPr lang="en-US"/>
           </a:p>
@@ -14129,7 +14213,7 @@
           <a:p>
             <a:fld id="{D7E3ECEC-7E7B-4FB9-BAE8-5C10F12795EA}" type="datetimeFigureOut">
               <a:rPr lang="en-US" smtClean="0"/>
-              <a:t>6/12/2026</a:t>
+              <a:t>6/19/2026</a:t>
             </a:fld>
             <a:endParaRPr lang="en-US"/>
           </a:p>
@@ -14468,7 +14552,7 @@
           <a:p>
             <a:fld id="{D7E3ECEC-7E7B-4FB9-BAE8-5C10F12795EA}" type="datetimeFigureOut">
               <a:rPr lang="en-US" smtClean="0"/>
-              <a:t>6/12/2026</a:t>
+              <a:t>6/19/2026</a:t>
             </a:fld>
             <a:endParaRPr lang="en-US"/>
           </a:p>
@@ -14759,7 +14843,7 @@
           <a:p>
             <a:fld id="{D7E3ECEC-7E7B-4FB9-BAE8-5C10F12795EA}" type="datetimeFigureOut">
               <a:rPr lang="en-US" smtClean="0"/>
-              <a:t>6/12/2026</a:t>
+              <a:t>6/19/2026</a:t>
             </a:fld>
             <a:endParaRPr lang="en-US"/>
           </a:p>
@@ -15136,7 +15220,7 @@
           <a:p>
             <a:fld id="{D7E3ECEC-7E7B-4FB9-BAE8-5C10F12795EA}" type="datetimeFigureOut">
               <a:rPr lang="en-US" smtClean="0"/>
-              <a:t>6/12/2026</a:t>
+              <a:t>6/19/2026</a:t>
             </a:fld>
             <a:endParaRPr lang="en-US"/>
           </a:p>
@@ -15536,7 +15620,7 @@
           <a:p>
             <a:fld id="{D7E3ECEC-7E7B-4FB9-BAE8-5C10F12795EA}" type="datetimeFigureOut">
               <a:rPr lang="en-US" smtClean="0"/>
-              <a:t>6/12/2026</a:t>
+              <a:t>6/19/2026</a:t>
             </a:fld>
             <a:endParaRPr lang="en-US"/>
           </a:p>
@@ -15821,7 +15905,7 @@
           <a:p>
             <a:fld id="{D7E3ECEC-7E7B-4FB9-BAE8-5C10F12795EA}" type="datetimeFigureOut">
               <a:rPr lang="en-US" smtClean="0"/>
-              <a:t>6/12/2026</a:t>
+              <a:t>6/19/2026</a:t>
             </a:fld>
             <a:endParaRPr lang="en-US"/>
           </a:p>
@@ -16045,7 +16129,7 @@
           <a:p>
             <a:fld id="{D7E3ECEC-7E7B-4FB9-BAE8-5C10F12795EA}" type="datetimeFigureOut">
               <a:rPr lang="en-US" smtClean="0"/>
-              <a:t>6/12/2026</a:t>
+              <a:t>6/19/2026</a:t>
             </a:fld>
             <a:endParaRPr lang="en-US"/>
           </a:p>
@@ -16259,7 +16343,7 @@
           <a:p>
             <a:fld id="{D7E3ECEC-7E7B-4FB9-BAE8-5C10F12795EA}" type="datetimeFigureOut">
               <a:rPr lang="en-US" smtClean="0"/>
-              <a:t>6/12/2026</a:t>
+              <a:t>6/19/2026</a:t>
             </a:fld>
             <a:endParaRPr lang="en-US"/>
           </a:p>
@@ -16628,7 +16712,7 @@
           <a:p>
             <a:fld id="{D7E3ECEC-7E7B-4FB9-BAE8-5C10F12795EA}" type="datetimeFigureOut">
               <a:rPr lang="en-US" smtClean="0"/>
-              <a:t>6/12/2026</a:t>
+              <a:t>6/19/2026</a:t>
             </a:fld>
             <a:endParaRPr lang="en-US"/>
           </a:p>
@@ -16970,7 +17054,7 @@
           <a:p>
             <a:fld id="{D7E3ECEC-7E7B-4FB9-BAE8-5C10F12795EA}" type="datetimeFigureOut">
               <a:rPr lang="en-US" smtClean="0"/>
-              <a:t>6/12/2026</a:t>
+              <a:t>6/19/2026</a:t>
             </a:fld>
             <a:endParaRPr lang="en-US"/>
           </a:p>
@@ -17333,7 +17417,7 @@
           <a:p>
             <a:fld id="{D7E3ECEC-7E7B-4FB9-BAE8-5C10F12795EA}" type="datetimeFigureOut">
               <a:rPr lang="en-US" smtClean="0"/>
-              <a:t>6/12/2026</a:t>
+              <a:t>6/19/2026</a:t>
             </a:fld>
             <a:endParaRPr lang="en-US"/>
           </a:p>
@@ -17606,7 +17690,7 @@
           <a:p>
             <a:fld id="{D7E3ECEC-7E7B-4FB9-BAE8-5C10F12795EA}" type="datetimeFigureOut">
               <a:rPr lang="en-US" smtClean="0"/>
-              <a:t>6/12/2026</a:t>
+              <a:t>6/19/2026</a:t>
             </a:fld>
             <a:endParaRPr lang="en-US"/>
           </a:p>
@@ -17951,7 +18035,7 @@
           <a:p>
             <a:fld id="{D7E3ECEC-7E7B-4FB9-BAE8-5C10F12795EA}" type="datetimeFigureOut">
               <a:rPr lang="en-US" smtClean="0"/>
-              <a:t>6/12/2026</a:t>
+              <a:t>6/19/2026</a:t>
             </a:fld>
             <a:endParaRPr lang="en-US"/>
           </a:p>
@@ -18405,7 +18489,7 @@
           <a:p>
             <a:fld id="{D7E3ECEC-7E7B-4FB9-BAE8-5C10F12795EA}" type="datetimeFigureOut">
               <a:rPr lang="en-US" smtClean="0"/>
-              <a:t>6/12/2026</a:t>
+              <a:t>6/19/2026</a:t>
             </a:fld>
             <a:endParaRPr lang="en-US"/>
           </a:p>
@@ -18552,7 +18636,7 @@
           <a:p>
             <a:fld id="{D7E3ECEC-7E7B-4FB9-BAE8-5C10F12795EA}" type="datetimeFigureOut">
               <a:rPr lang="en-US" smtClean="0"/>
-              <a:t>6/12/2026</a:t>
+              <a:t>6/19/2026</a:t>
             </a:fld>
             <a:endParaRPr lang="en-US"/>
           </a:p>
@@ -18665,7 +18749,7 @@
           <a:p>
             <a:fld id="{D7E3ECEC-7E7B-4FB9-BAE8-5C10F12795EA}" type="datetimeFigureOut">
               <a:rPr lang="en-US" smtClean="0"/>
-              <a:t>6/12/2026</a:t>
+              <a:t>6/19/2026</a:t>
             </a:fld>
             <a:endParaRPr lang="en-US"/>
           </a:p>
@@ -18972,7 +19056,7 @@
           <a:p>
             <a:fld id="{D7E3ECEC-7E7B-4FB9-BAE8-5C10F12795EA}" type="datetimeFigureOut">
               <a:rPr lang="en-US" smtClean="0"/>
-              <a:t>6/12/2026</a:t>
+              <a:t>6/19/2026</a:t>
             </a:fld>
             <a:endParaRPr lang="en-US"/>
           </a:p>
@@ -19271,7 +19355,7 @@
           <a:p>
             <a:fld id="{D7E3ECEC-7E7B-4FB9-BAE8-5C10F12795EA}" type="datetimeFigureOut">
               <a:rPr lang="en-US" smtClean="0"/>
-              <a:t>6/12/2026</a:t>
+              <a:t>6/19/2026</a:t>
             </a:fld>
             <a:endParaRPr lang="en-US"/>
           </a:p>
@@ -19663,7 +19747,7 @@
           <a:p>
             <a:fld id="{D7E3ECEC-7E7B-4FB9-BAE8-5C10F12795EA}" type="datetimeFigureOut">
               <a:rPr lang="en-US" smtClean="0"/>
-              <a:t>6/12/2026</a:t>
+              <a:t>6/19/2026</a:t>
             </a:fld>
             <a:endParaRPr lang="en-US"/>
           </a:p>
@@ -20050,7 +20134,7 @@
           <a:p>
             <a:fld id="{D7E3ECEC-7E7B-4FB9-BAE8-5C10F12795EA}" type="datetimeFigureOut">
               <a:rPr lang="en-US" smtClean="0"/>
-              <a:t>6/12/2026</a:t>
+              <a:t>6/19/2026</a:t>
             </a:fld>
             <a:endParaRPr lang="en-US"/>
           </a:p>
@@ -20281,7 +20365,7 @@
           <a:p>
             <a:fld id="{D7E3ECEC-7E7B-4FB9-BAE8-5C10F12795EA}" type="datetimeFigureOut">
               <a:rPr lang="en-US" smtClean="0"/>
-              <a:t>6/12/2026</a:t>
+              <a:t>6/19/2026</a:t>
             </a:fld>
             <a:endParaRPr lang="en-US"/>
           </a:p>
@@ -20563,7 +20647,7 @@
           <a:p>
             <a:fld id="{D7E3ECEC-7E7B-4FB9-BAE8-5C10F12795EA}" type="datetimeFigureOut">
               <a:rPr lang="en-US" smtClean="0"/>
-              <a:t>6/12/2026</a:t>
+              <a:t>6/19/2026</a:t>
             </a:fld>
             <a:endParaRPr lang="en-US"/>
           </a:p>
@@ -20818,7 +20902,7 @@
           <a:p>
             <a:fld id="{D7E3ECEC-7E7B-4FB9-BAE8-5C10F12795EA}" type="datetimeFigureOut">
               <a:rPr lang="en-US" smtClean="0"/>
-              <a:t>6/12/2026</a:t>
+              <a:t>6/19/2026</a:t>
             </a:fld>
             <a:endParaRPr lang="en-US"/>
           </a:p>
@@ -21090,7 +21174,7 @@
           <a:p>
             <a:fld id="{D7E3ECEC-7E7B-4FB9-BAE8-5C10F12795EA}" type="datetimeFigureOut">
               <a:rPr lang="en-US" smtClean="0"/>
-              <a:t>6/12/2026</a:t>
+              <a:t>6/19/2026</a:t>
             </a:fld>
             <a:endParaRPr lang="en-US"/>
           </a:p>
@@ -21360,7 +21444,7 @@
           <a:p>
             <a:fld id="{D7E3ECEC-7E7B-4FB9-BAE8-5C10F12795EA}" type="datetimeFigureOut">
               <a:rPr lang="en-US" smtClean="0"/>
-              <a:t>6/12/2026</a:t>
+              <a:t>6/19/2026</a:t>
             </a:fld>
             <a:endParaRPr lang="en-US"/>
           </a:p>
@@ -22375,7 +22459,7 @@
           <p:nvPr/>
         </p:nvPicPr>
         <p:blipFill>
-          <a:blip r:embed="rId2"/>
+          <a:blip r:embed="rId3"/>
           <a:stretch>
             <a:fillRect/>
           </a:stretch>
@@ -22507,7 +22591,7 @@
             </a:br>
             <a:r>
               <a:rPr lang="en-US" sz="1800" cap="none" dirty="0"/>
-              <a:t>A. It is the science and engineering of making intelligent machines, especially intelligent computer programs. it is related to the similar task of using computers to understand human intelligence, but AI does not have to confine itself to methods that are biologically observable. </a:t>
+              <a:t>A. It is the science and engineering of making intelligent machines, especially intelligent computer programs. It is related to the similar task of using computers to understand human intelligence, but AI does not have to confine itself to methods that are biologically observable. </a:t>
             </a:r>
             <a:br>
               <a:rPr lang="en-US" sz="1800" cap="none" dirty="0"/>
@@ -22527,7 +22611,7 @@
             </a:br>
             <a:r>
               <a:rPr lang="en-US" sz="1800" cap="none" dirty="0"/>
-              <a:t>A. Intelligence is the computational part of the ability to achieve goals in the world. varying kinds and degrees of intelligence occur in people, many animals and some machines. </a:t>
+              <a:t>A. Intelligence is the computational part of the ability to achieve goals in the world. Varying kinds and degrees of intelligence occur in people, many animals and some machines. </a:t>
             </a:r>
             <a:br>
               <a:rPr lang="en-US" sz="1800" cap="none" dirty="0"/>
@@ -22875,7 +22959,7 @@
             </a:br>
             <a:r>
               <a:rPr lang="en-US" sz="1800" cap="none" dirty="0"/>
-              <a:t>Human intelligence is, generally speaking, the mental quality that consists of the abilities to learn from experience, adapt to new situations, understand and handle abstract concepts, and use knowledge to control an environment. however, the question of what, exactly, defines human intelligence is contested, particularly among researchers of artificial intelligence, though there is broader agreement that intelligence consists of multiple processes, rather than being a single ability.</a:t>
+              <a:t>Human intelligence is, generally speaking, the mental quality that consists of the abilities to learn from experience, adapt to new situations, understand and handle abstract concepts, and use knowledge to control an environment. However, the question of what, exactly, defines human intelligence is contested, particularly among researchers of artificial intelligence, though there is broader agreement that intelligence consists of multiple processes, rather than being a single ability.</a:t>
             </a:r>
             <a:br>
               <a:rPr lang="en-US" sz="1600" cap="none" dirty="0"/>
@@ -24639,6 +24723,35 @@
 </file>
 
 <file path=customXml/item1.xml><?xml version="1.0" encoding="utf-8"?>
+<p:properties xmlns:p="http://schemas.microsoft.com/office/2006/metadata/properties" xmlns:xsi="http://www.w3.org/2001/XMLSchema-instance" xmlns:pc="http://schemas.microsoft.com/office/infopath/2007/PartnerControls">
+  <documentManagement>
+    <_ip_UnifiedCompliancePolicyUIAction xmlns="http://schemas.microsoft.com/sharepoint/v3" xsi:nil="true"/>
+    <Image xmlns="71af3243-3dd4-4a8d-8c0d-dd76da1f02a5">
+      <Url xsi:nil="true"/>
+      <Description xsi:nil="true"/>
+    </Image>
+    <Status xmlns="71af3243-3dd4-4a8d-8c0d-dd76da1f02a5">Not started</Status>
+    <Background xmlns="71af3243-3dd4-4a8d-8c0d-dd76da1f02a5">false</Background>
+    <_ip_UnifiedCompliancePolicyProperties xmlns="http://schemas.microsoft.com/sharepoint/v3" xsi:nil="true"/>
+    <ImageTagsTaxHTField xmlns="71af3243-3dd4-4a8d-8c0d-dd76da1f02a5">
+      <Terms xmlns="http://schemas.microsoft.com/office/infopath/2007/PartnerControls"/>
+    </ImageTagsTaxHTField>
+    <TaxCatchAll xmlns="230e9df3-be65-4c73-a93b-d1236ebd677e" xsi:nil="true"/>
+    <MediaServiceKeyPoints xmlns="71af3243-3dd4-4a8d-8c0d-dd76da1f02a5" xsi:nil="true"/>
+  </documentManagement>
+</p:properties>
+</file>
+
+<file path=customXml/item2.xml><?xml version="1.0" encoding="utf-8"?>
+<?mso-contentType ?>
+<FormTemplates xmlns="http://schemas.microsoft.com/sharepoint/v3/contenttype/forms">
+  <Display>DocumentLibraryForm</Display>
+  <Edit>DocumentLibraryForm</Edit>
+  <New>DocumentLibraryForm</New>
+</FormTemplates>
+</file>
+
+<file path=customXml/item3.xml><?xml version="1.0" encoding="utf-8"?>
 <ct:contentTypeSchema xmlns:ct="http://schemas.microsoft.com/office/2006/metadata/contentType" xmlns:ma="http://schemas.microsoft.com/office/2006/metadata/properties/metaAttributes" ct:_="" ma:_="" ma:contentTypeName="Document" ma:contentTypeID="0x01010079F111ED35F8CC479449609E8A0923A6" ma:contentTypeVersion="30" ma:contentTypeDescription="Create a new document." ma:contentTypeScope="" ma:versionID="cec0622158e8f13124e9e8fd4de31bd1">
   <xsd:schema xmlns:xsd="http://www.w3.org/2001/XMLSchema" xmlns:xs="http://www.w3.org/2001/XMLSchema" xmlns:p="http://schemas.microsoft.com/office/2006/metadata/properties" xmlns:ns1="http://schemas.microsoft.com/sharepoint/v3" xmlns:ns2="71af3243-3dd4-4a8d-8c0d-dd76da1f02a5" xmlns:ns3="16c05727-aa75-4e4a-9b5f-8a80a1165891" xmlns:ns4="230e9df3-be65-4c73-a93b-d1236ebd677e" targetNamespace="http://schemas.microsoft.com/office/2006/metadata/properties" ma:root="true" ma:fieldsID="3b52f30ab005d15df08657af532e6e38" ns1:_="" ns2:_="" ns3:_="" ns4:_="">
     <xsd:import namespace="http://schemas.microsoft.com/sharepoint/v3"/>
@@ -24956,36 +25069,27 @@
 </ct:contentTypeSchema>
 </file>
 
-<file path=customXml/item2.xml><?xml version="1.0" encoding="utf-8"?>
-<?mso-contentType ?>
-<FormTemplates xmlns="http://schemas.microsoft.com/sharepoint/v3/contenttype/forms">
-  <Display>DocumentLibraryForm</Display>
-  <Edit>DocumentLibraryForm</Edit>
-  <New>DocumentLibraryForm</New>
-</FormTemplates>
+<file path=customXml/itemProps1.xml><?xml version="1.0" encoding="utf-8"?>
+<ds:datastoreItem xmlns:ds="http://schemas.openxmlformats.org/officeDocument/2006/customXml" ds:itemID="{0DA384A2-DC2C-4578-B8CE-512657D68B32}">
+  <ds:schemaRefs>
+    <ds:schemaRef ds:uri="http://schemas.microsoft.com/office/2006/metadata/properties"/>
+    <ds:schemaRef ds:uri="http://schemas.microsoft.com/office/infopath/2007/PartnerControls"/>
+    <ds:schemaRef ds:uri="http://schemas.microsoft.com/sharepoint/v3"/>
+    <ds:schemaRef ds:uri="71af3243-3dd4-4a8d-8c0d-dd76da1f02a5"/>
+    <ds:schemaRef ds:uri="230e9df3-be65-4c73-a93b-d1236ebd677e"/>
+  </ds:schemaRefs>
+</ds:datastoreItem>
 </file>
 
-<file path=customXml/item3.xml><?xml version="1.0" encoding="utf-8"?>
-<p:properties xmlns:p="http://schemas.microsoft.com/office/2006/metadata/properties" xmlns:xsi="http://www.w3.org/2001/XMLSchema-instance" xmlns:pc="http://schemas.microsoft.com/office/infopath/2007/PartnerControls">
-  <documentManagement>
-    <_ip_UnifiedCompliancePolicyUIAction xmlns="http://schemas.microsoft.com/sharepoint/v3" xsi:nil="true"/>
-    <Image xmlns="71af3243-3dd4-4a8d-8c0d-dd76da1f02a5">
-      <Url xsi:nil="true"/>
-      <Description xsi:nil="true"/>
-    </Image>
-    <Status xmlns="71af3243-3dd4-4a8d-8c0d-dd76da1f02a5">Not started</Status>
-    <Background xmlns="71af3243-3dd4-4a8d-8c0d-dd76da1f02a5">false</Background>
-    <_ip_UnifiedCompliancePolicyProperties xmlns="http://schemas.microsoft.com/sharepoint/v3" xsi:nil="true"/>
-    <ImageTagsTaxHTField xmlns="71af3243-3dd4-4a8d-8c0d-dd76da1f02a5">
-      <Terms xmlns="http://schemas.microsoft.com/office/infopath/2007/PartnerControls"/>
-    </ImageTagsTaxHTField>
-    <TaxCatchAll xmlns="230e9df3-be65-4c73-a93b-d1236ebd677e" xsi:nil="true"/>
-    <MediaServiceKeyPoints xmlns="71af3243-3dd4-4a8d-8c0d-dd76da1f02a5" xsi:nil="true"/>
-  </documentManagement>
-</p:properties>
+<file path=customXml/itemProps2.xml><?xml version="1.0" encoding="utf-8"?>
+<ds:datastoreItem xmlns:ds="http://schemas.openxmlformats.org/officeDocument/2006/customXml" ds:itemID="{A533346F-C811-4404-B626-0E7631B21215}">
+  <ds:schemaRefs>
+    <ds:schemaRef ds:uri="http://schemas.microsoft.com/sharepoint/v3/contenttype/forms"/>
+  </ds:schemaRefs>
+</ds:datastoreItem>
 </file>
 
-<file path=customXml/itemProps1.xml><?xml version="1.0" encoding="utf-8"?>
+<file path=customXml/itemProps3.xml><?xml version="1.0" encoding="utf-8"?>
 <ds:datastoreItem xmlns:ds="http://schemas.openxmlformats.org/officeDocument/2006/customXml" ds:itemID="{E2E911A2-2017-41E4-8340-9C55208FC246}">
   <ds:schemaRefs>
     <ds:schemaRef ds:uri="http://schemas.microsoft.com/office/2006/metadata/contentType"/>
@@ -25006,26 +25110,6 @@
 </ds:datastoreItem>
 </file>
 
-<file path=customXml/itemProps2.xml><?xml version="1.0" encoding="utf-8"?>
-<ds:datastoreItem xmlns:ds="http://schemas.openxmlformats.org/officeDocument/2006/customXml" ds:itemID="{A533346F-C811-4404-B626-0E7631B21215}">
-  <ds:schemaRefs>
-    <ds:schemaRef ds:uri="http://schemas.microsoft.com/sharepoint/v3/contenttype/forms"/>
-  </ds:schemaRefs>
-</ds:datastoreItem>
-</file>
-
-<file path=customXml/itemProps3.xml><?xml version="1.0" encoding="utf-8"?>
-<ds:datastoreItem xmlns:ds="http://schemas.openxmlformats.org/officeDocument/2006/customXml" ds:itemID="{0DA384A2-DC2C-4578-B8CE-512657D68B32}">
-  <ds:schemaRefs>
-    <ds:schemaRef ds:uri="http://schemas.microsoft.com/office/2006/metadata/properties"/>
-    <ds:schemaRef ds:uri="http://schemas.microsoft.com/office/infopath/2007/PartnerControls"/>
-    <ds:schemaRef ds:uri="http://schemas.microsoft.com/sharepoint/v3"/>
-    <ds:schemaRef ds:uri="71af3243-3dd4-4a8d-8c0d-dd76da1f02a5"/>
-    <ds:schemaRef ds:uri="230e9df3-be65-4c73-a93b-d1236ebd677e"/>
-  </ds:schemaRefs>
-</ds:datastoreItem>
-</file>
-
 <file path=docMetadata/LabelInfo.xml><?xml version="1.0" encoding="utf-8"?>
 <clbl:labelList xmlns:clbl="http://schemas.microsoft.com/office/2020/mipLabelMetadata"/>
 </file>
</xml_diff>

<commit_message>
Add dataset, split into classes, update slides.
</commit_message>
<xml_diff>
--- a/Slides/Artificial_Intelligence_Module0.pptx
+++ b/Slides/Artificial_Intelligence_Module0.pptx
@@ -22026,7 +22026,7 @@
         <p:spPr>
           <a:xfrm>
             <a:off x="286753" y="2377424"/>
-            <a:ext cx="6284494" cy="830997"/>
+            <a:ext cx="6284494" cy="1323439"/>
           </a:xfrm>
           <a:prstGeom prst="rect">
             <a:avLst/>
@@ -22040,10 +22040,15 @@
           <a:lstStyle/>
           <a:p>
             <a:r>
-              <a:rPr lang="en-US" sz="4800" cap="none" dirty="0"/>
+              <a:rPr lang="en-US" sz="4000" cap="none" dirty="0"/>
               <a:t>Module 0</a:t>
             </a:r>
-            <a:endParaRPr lang="en-US" sz="4800" dirty="0"/>
+          </a:p>
+          <a:p>
+            <a:r>
+              <a:rPr lang="en-US" sz="4000" dirty="0"/>
+              <a:t>Intelligence</a:t>
+            </a:r>
           </a:p>
         </p:txBody>
       </p:sp>
@@ -24743,15 +24748,6 @@
 </file>
 
 <file path=customXml/item2.xml><?xml version="1.0" encoding="utf-8"?>
-<?mso-contentType ?>
-<FormTemplates xmlns="http://schemas.microsoft.com/sharepoint/v3/contenttype/forms">
-  <Display>DocumentLibraryForm</Display>
-  <Edit>DocumentLibraryForm</Edit>
-  <New>DocumentLibraryForm</New>
-</FormTemplates>
-</file>
-
-<file path=customXml/item3.xml><?xml version="1.0" encoding="utf-8"?>
 <ct:contentTypeSchema xmlns:ct="http://schemas.microsoft.com/office/2006/metadata/contentType" xmlns:ma="http://schemas.microsoft.com/office/2006/metadata/properties/metaAttributes" ct:_="" ma:_="" ma:contentTypeName="Document" ma:contentTypeID="0x01010079F111ED35F8CC479449609E8A0923A6" ma:contentTypeVersion="30" ma:contentTypeDescription="Create a new document." ma:contentTypeScope="" ma:versionID="cec0622158e8f13124e9e8fd4de31bd1">
   <xsd:schema xmlns:xsd="http://www.w3.org/2001/XMLSchema" xmlns:xs="http://www.w3.org/2001/XMLSchema" xmlns:p="http://schemas.microsoft.com/office/2006/metadata/properties" xmlns:ns1="http://schemas.microsoft.com/sharepoint/v3" xmlns:ns2="71af3243-3dd4-4a8d-8c0d-dd76da1f02a5" xmlns:ns3="16c05727-aa75-4e4a-9b5f-8a80a1165891" xmlns:ns4="230e9df3-be65-4c73-a93b-d1236ebd677e" targetNamespace="http://schemas.microsoft.com/office/2006/metadata/properties" ma:root="true" ma:fieldsID="3b52f30ab005d15df08657af532e6e38" ns1:_="" ns2:_="" ns3:_="" ns4:_="">
     <xsd:import namespace="http://schemas.microsoft.com/sharepoint/v3"/>
@@ -25069,6 +25065,15 @@
 </ct:contentTypeSchema>
 </file>
 
+<file path=customXml/item3.xml><?xml version="1.0" encoding="utf-8"?>
+<?mso-contentType ?>
+<FormTemplates xmlns="http://schemas.microsoft.com/sharepoint/v3/contenttype/forms">
+  <Display>DocumentLibraryForm</Display>
+  <Edit>DocumentLibraryForm</Edit>
+  <New>DocumentLibraryForm</New>
+</FormTemplates>
+</file>
+
 <file path=customXml/itemProps1.xml><?xml version="1.0" encoding="utf-8"?>
 <ds:datastoreItem xmlns:ds="http://schemas.openxmlformats.org/officeDocument/2006/customXml" ds:itemID="{0DA384A2-DC2C-4578-B8CE-512657D68B32}">
   <ds:schemaRefs>
@@ -25082,14 +25087,6 @@
 </file>
 
 <file path=customXml/itemProps2.xml><?xml version="1.0" encoding="utf-8"?>
-<ds:datastoreItem xmlns:ds="http://schemas.openxmlformats.org/officeDocument/2006/customXml" ds:itemID="{A533346F-C811-4404-B626-0E7631B21215}">
-  <ds:schemaRefs>
-    <ds:schemaRef ds:uri="http://schemas.microsoft.com/sharepoint/v3/contenttype/forms"/>
-  </ds:schemaRefs>
-</ds:datastoreItem>
-</file>
-
-<file path=customXml/itemProps3.xml><?xml version="1.0" encoding="utf-8"?>
 <ds:datastoreItem xmlns:ds="http://schemas.openxmlformats.org/officeDocument/2006/customXml" ds:itemID="{E2E911A2-2017-41E4-8340-9C55208FC246}">
   <ds:schemaRefs>
     <ds:schemaRef ds:uri="http://schemas.microsoft.com/office/2006/metadata/contentType"/>
@@ -25110,6 +25107,14 @@
 </ds:datastoreItem>
 </file>
 
+<file path=customXml/itemProps3.xml><?xml version="1.0" encoding="utf-8"?>
+<ds:datastoreItem xmlns:ds="http://schemas.openxmlformats.org/officeDocument/2006/customXml" ds:itemID="{A533346F-C811-4404-B626-0E7631B21215}">
+  <ds:schemaRefs>
+    <ds:schemaRef ds:uri="http://schemas.microsoft.com/sharepoint/v3/contenttype/forms"/>
+  </ds:schemaRefs>
+</ds:datastoreItem>
+</file>
+
 <file path=docMetadata/LabelInfo.xml><?xml version="1.0" encoding="utf-8"?>
 <clbl:labelList xmlns:clbl="http://schemas.microsoft.com/office/2020/mipLabelMetadata"/>
 </file>
</xml_diff>

<commit_message>
Solidify long-term training plan and cleanup slides.
</commit_message>
<xml_diff>
--- a/Slides/Artificial_Intelligence_Module0.pptx
+++ b/Slides/Artificial_Intelligence_Module0.pptx
@@ -5,22 +5,23 @@
     <p:sldMasterId id="2147483660" r:id="rId4"/>
   </p:sldMasterIdLst>
   <p:notesMasterIdLst>
-    <p:notesMasterId r:id="rId18"/>
+    <p:notesMasterId r:id="rId19"/>
   </p:notesMasterIdLst>
   <p:sldIdLst>
     <p:sldId id="256" r:id="rId5"/>
-    <p:sldId id="257" r:id="rId6"/>
-    <p:sldId id="260" r:id="rId7"/>
-    <p:sldId id="258" r:id="rId8"/>
-    <p:sldId id="262" r:id="rId9"/>
-    <p:sldId id="263" r:id="rId10"/>
-    <p:sldId id="265" r:id="rId11"/>
-    <p:sldId id="266" r:id="rId12"/>
-    <p:sldId id="267" r:id="rId13"/>
-    <p:sldId id="268" r:id="rId14"/>
-    <p:sldId id="259" r:id="rId15"/>
-    <p:sldId id="269" r:id="rId16"/>
-    <p:sldId id="264" r:id="rId17"/>
+    <p:sldId id="264" r:id="rId6"/>
+    <p:sldId id="257" r:id="rId7"/>
+    <p:sldId id="260" r:id="rId8"/>
+    <p:sldId id="258" r:id="rId9"/>
+    <p:sldId id="262" r:id="rId10"/>
+    <p:sldId id="263" r:id="rId11"/>
+    <p:sldId id="265" r:id="rId12"/>
+    <p:sldId id="266" r:id="rId13"/>
+    <p:sldId id="267" r:id="rId14"/>
+    <p:sldId id="268" r:id="rId15"/>
+    <p:sldId id="259" r:id="rId16"/>
+    <p:sldId id="269" r:id="rId17"/>
+    <p:sldId id="270" r:id="rId18"/>
   </p:sldIdLst>
   <p:sldSz cx="12192000" cy="6858000"/>
   <p:notesSz cx="6858000" cy="9144000"/>
@@ -209,7 +210,7 @@
           <a:p>
             <a:fld id="{09E66CB0-D60F-4BE5-83D4-0DD72108AD14}" type="datetimeFigureOut">
               <a:rPr lang="en-US" smtClean="0"/>
-              <a:t>6/19/2026</a:t>
+              <a:t>6/26/2026</a:t>
             </a:fld>
             <a:endParaRPr lang="en-US"/>
           </a:p>
@@ -572,6 +573,31 @@
                 <a:ea typeface="+mn-ea"/>
                 <a:cs typeface="+mn-cs"/>
               </a:rPr>
+              <a:t>This Landsat image of 3 October 2011 shows the Mississippi River Delta, where the largest river in the United States empties into the Gulf of Mexico.</a:t>
+            </a:r>
+          </a:p>
+          <a:p>
+            <a:endParaRPr lang="en-US" sz="1200" b="0" i="0" kern="1200" dirty="0">
+              <a:solidFill>
+                <a:schemeClr val="tx1"/>
+              </a:solidFill>
+              <a:effectLst/>
+              <a:latin typeface="+mn-lt"/>
+              <a:ea typeface="+mn-ea"/>
+              <a:cs typeface="+mn-cs"/>
+            </a:endParaRPr>
+          </a:p>
+          <a:p>
+            <a:r>
+              <a:rPr lang="en-US" sz="1200" b="0" i="0" kern="1200" dirty="0">
+                <a:solidFill>
+                  <a:schemeClr val="tx1"/>
+                </a:solidFill>
+                <a:effectLst/>
+                <a:latin typeface="+mn-lt"/>
+                <a:ea typeface="+mn-ea"/>
+                <a:cs typeface="+mn-cs"/>
+              </a:rPr>
               <a:t>In this false-</a:t>
             </a:r>
             <a:r>
@@ -711,56 +737,6 @@
                 <a:cs typeface="+mn-cs"/>
               </a:rPr>
               <a:t>This area is of significant economic importance, providing about 17% of the oil supply in the US, and 16% of fisheries harvest, such as shrimp, crabs and crayfish. A third of the nation’s oysters come from the Mississippi River Delta.</a:t>
-            </a:r>
-          </a:p>
-          <a:p>
-            <a:endParaRPr lang="en-US" sz="1200" b="0" i="0" kern="1200" dirty="0">
-              <a:solidFill>
-                <a:schemeClr val="tx1"/>
-              </a:solidFill>
-              <a:effectLst/>
-              <a:latin typeface="+mn-lt"/>
-              <a:ea typeface="+mn-ea"/>
-              <a:cs typeface="+mn-cs"/>
-            </a:endParaRPr>
-          </a:p>
-          <a:p>
-            <a:r>
-              <a:rPr lang="en-US" sz="1200" b="0" i="0" kern="1200" dirty="0">
-                <a:solidFill>
-                  <a:schemeClr val="tx1"/>
-                </a:solidFill>
-                <a:effectLst/>
-                <a:latin typeface="+mn-lt"/>
-                <a:ea typeface="+mn-ea"/>
-                <a:cs typeface="+mn-cs"/>
-              </a:rPr>
-              <a:t>The Thematic Mapper on Landsat-5 is jointly managed by NASA and the US Geological Survey. ESA supports the Landsat series as a Third Party Mission, meaning it uses its ground infrastructure and expertise to acquire, process and distribute Landsat data to users.</a:t>
-            </a:r>
-          </a:p>
-          <a:p>
-            <a:endParaRPr lang="en-US" sz="1200" b="0" i="0" kern="1200" dirty="0">
-              <a:solidFill>
-                <a:schemeClr val="tx1"/>
-              </a:solidFill>
-              <a:effectLst/>
-              <a:latin typeface="+mn-lt"/>
-              <a:ea typeface="+mn-ea"/>
-              <a:cs typeface="+mn-cs"/>
-            </a:endParaRPr>
-          </a:p>
-          <a:p>
-            <a:r>
-              <a:rPr lang="en-US" sz="1200" b="0" i="0" kern="1200" dirty="0">
-                <a:solidFill>
-                  <a:schemeClr val="tx1"/>
-                </a:solidFill>
-                <a:effectLst/>
-                <a:latin typeface="+mn-lt"/>
-                <a:ea typeface="+mn-ea"/>
-                <a:cs typeface="+mn-cs"/>
-              </a:rPr>
-              <a:t>ESA has recently opened archived Landsat data for use by the scientific community, free of charge.</a:t>
             </a:r>
           </a:p>
           <a:p>
@@ -902,8 +878,90 @@
           <a:p>
             <a:r>
               <a:rPr lang="en-US" dirty="0"/>
-              <a:t>An example of how intelligent behavior has progressed.</a:t>
-            </a:r>
+              <a:t>This is an interesting fictional test from the 1982 movie Blade Runner. This movie is set in a dystopian, cyberpunk future. The story follows Rick Deckard, a specialized police officer known as a Blade Runner. His job is to track down and "retire" (execute) </a:t>
+            </a:r>
+            <a:r>
+              <a:rPr lang="en-US" b="0" dirty="0"/>
+              <a:t>Replicants. Replicants are </a:t>
+            </a:r>
+            <a:r>
+              <a:rPr lang="en-US" dirty="0"/>
+              <a:t>bioengineered synthetic humans created by the Tyrell Corporation.</a:t>
+            </a:r>
+          </a:p>
+          <a:p>
+            <a:endParaRPr lang="en-US" dirty="0"/>
+          </a:p>
+          <a:p>
+            <a:r>
+              <a:rPr lang="en-US" b="1" dirty="0"/>
+              <a:t>The Conflict:</a:t>
+            </a:r>
+            <a:r>
+              <a:rPr lang="en-US" dirty="0"/>
+              <a:t> Replicants are physically and intellectually superior to humans, built to do dangerous off-world labor. However, they are entirely illegal on Earth.</a:t>
+            </a:r>
+          </a:p>
+          <a:p>
+            <a:endParaRPr lang="en-US" dirty="0"/>
+          </a:p>
+          <a:p>
+            <a:r>
+              <a:rPr lang="en-US" b="1" dirty="0"/>
+              <a:t>The Problem:</a:t>
+            </a:r>
+            <a:r>
+              <a:rPr lang="en-US" dirty="0"/>
+              <a:t> Replicants are so advanced that they develop their own emotions, memories, and a fierce desire for survival. They become virtually indistinguishable from natural-born humans, passing as human in everyday society.</a:t>
+            </a:r>
+          </a:p>
+          <a:p>
+            <a:endParaRPr lang="en-US" dirty="0"/>
+          </a:p>
+          <a:p>
+            <a:pPr marL="0" marR="0" lvl="0" indent="0" algn="l" defTabSz="914400" rtl="0" eaLnBrk="1" fontAlgn="auto" latinLnBrk="0" hangingPunct="1">
+              <a:lnSpc>
+                <a:spcPct val="100000"/>
+              </a:lnSpc>
+              <a:spcBef>
+                <a:spcPts val="0"/>
+              </a:spcBef>
+              <a:spcAft>
+                <a:spcPts val="0"/>
+              </a:spcAft>
+              <a:buClrTx/>
+              <a:buSzTx/>
+              <a:buFontTx/>
+              <a:buNone/>
+              <a:tabLst/>
+              <a:defRPr/>
+            </a:pPr>
+            <a:r>
+              <a:rPr lang="en-US" dirty="0"/>
+              <a:t>This measures subconscious empathy and biology. The test assumes intelligent behavior already exist and tests for emotional authenticity.</a:t>
+            </a:r>
+          </a:p>
+          <a:p>
+            <a:endParaRPr lang="en-US" dirty="0"/>
+          </a:p>
+          <a:p>
+            <a:r>
+              <a:rPr lang="en-US" dirty="0"/>
+              <a:t>This raises an interesting question, </a:t>
+            </a:r>
+            <a:r>
+              <a:rPr lang="en-US" i="0" dirty="0"/>
+              <a:t>if an artificial being acts perfectly human, does it possess a soul, or is it just a sophisticated machine?</a:t>
+            </a:r>
+          </a:p>
+          <a:p>
+            <a:endParaRPr lang="en-US" dirty="0"/>
+          </a:p>
+          <a:p>
+            <a:endParaRPr lang="en-US" dirty="0"/>
+          </a:p>
+          <a:p>
+            <a:endParaRPr lang="en-US" dirty="0"/>
           </a:p>
         </p:txBody>
       </p:sp>
@@ -933,7 +991,7 @@
     </p:spTree>
     <p:extLst>
       <p:ext uri="{BB962C8B-B14F-4D97-AF65-F5344CB8AC3E}">
-        <p14:creationId xmlns:p14="http://schemas.microsoft.com/office/powerpoint/2010/main" val="1661532452"/>
+        <p14:creationId xmlns:p14="http://schemas.microsoft.com/office/powerpoint/2010/main" val="2729791754"/>
       </p:ext>
     </p:extLst>
   </p:cSld>
@@ -989,7 +1047,7 @@
           <a:p>
             <a:r>
               <a:rPr lang="en-US" dirty="0"/>
-              <a:t>Continue.</a:t>
+              <a:t>An example of how intelligent behavior has progressed.</a:t>
             </a:r>
           </a:p>
         </p:txBody>
@@ -1020,7 +1078,7 @@
     </p:spTree>
     <p:extLst>
       <p:ext uri="{BB962C8B-B14F-4D97-AF65-F5344CB8AC3E}">
-        <p14:creationId xmlns:p14="http://schemas.microsoft.com/office/powerpoint/2010/main" val="3150753309"/>
+        <p14:creationId xmlns:p14="http://schemas.microsoft.com/office/powerpoint/2010/main" val="1661532452"/>
       </p:ext>
     </p:extLst>
   </p:cSld>
@@ -1074,7 +1132,10 @@
           <a:bodyPr/>
           <a:lstStyle/>
           <a:p>
-            <a:endParaRPr lang="en-US"/>
+            <a:r>
+              <a:rPr lang="en-US" dirty="0"/>
+              <a:t>Continue.</a:t>
+            </a:r>
           </a:p>
         </p:txBody>
       </p:sp>
@@ -1104,7 +1165,7 @@
     </p:spTree>
     <p:extLst>
       <p:ext uri="{BB962C8B-B14F-4D97-AF65-F5344CB8AC3E}">
-        <p14:creationId xmlns:p14="http://schemas.microsoft.com/office/powerpoint/2010/main" val="229305186"/>
+        <p14:creationId xmlns:p14="http://schemas.microsoft.com/office/powerpoint/2010/main" val="3150753309"/>
       </p:ext>
     </p:extLst>
   </p:cSld>
@@ -1158,6 +1219,90 @@
           <a:bodyPr/>
           <a:lstStyle/>
           <a:p>
+            <a:endParaRPr lang="en-US"/>
+          </a:p>
+        </p:txBody>
+      </p:sp>
+      <p:sp>
+        <p:nvSpPr>
+          <p:cNvPr id="4" name="Slide Number Placeholder 3"/>
+          <p:cNvSpPr>
+            <a:spLocks noGrp="1"/>
+          </p:cNvSpPr>
+          <p:nvPr>
+            <p:ph type="sldNum" sz="quarter" idx="5"/>
+          </p:nvPr>
+        </p:nvSpPr>
+        <p:spPr/>
+        <p:txBody>
+          <a:bodyPr/>
+          <a:lstStyle/>
+          <a:p>
+            <a:fld id="{2CCF031E-D17A-4139-B770-A41292C01C8F}" type="slidenum">
+              <a:rPr lang="en-US" smtClean="0"/>
+              <a:t>2</a:t>
+            </a:fld>
+            <a:endParaRPr lang="en-US"/>
+          </a:p>
+        </p:txBody>
+      </p:sp>
+    </p:spTree>
+    <p:extLst>
+      <p:ext uri="{BB962C8B-B14F-4D97-AF65-F5344CB8AC3E}">
+        <p14:creationId xmlns:p14="http://schemas.microsoft.com/office/powerpoint/2010/main" val="229305186"/>
+      </p:ext>
+    </p:extLst>
+  </p:cSld>
+  <p:clrMapOvr>
+    <a:masterClrMapping/>
+  </p:clrMapOvr>
+</p:notes>
+</file>
+
+<file path=ppt/notesSlides/notesSlide3.xml><?xml version="1.0" encoding="utf-8"?>
+<p:notes xmlns:a="http://schemas.openxmlformats.org/drawingml/2006/main" xmlns:r="http://schemas.openxmlformats.org/officeDocument/2006/relationships" xmlns:p="http://schemas.openxmlformats.org/presentationml/2006/main">
+  <p:cSld>
+    <p:spTree>
+      <p:nvGrpSpPr>
+        <p:cNvPr id="1" name=""/>
+        <p:cNvGrpSpPr/>
+        <p:nvPr/>
+      </p:nvGrpSpPr>
+      <p:grpSpPr>
+        <a:xfrm>
+          <a:off x="0" y="0"/>
+          <a:ext cx="0" cy="0"/>
+          <a:chOff x="0" y="0"/>
+          <a:chExt cx="0" cy="0"/>
+        </a:xfrm>
+      </p:grpSpPr>
+      <p:sp>
+        <p:nvSpPr>
+          <p:cNvPr id="2" name="Slide Image Placeholder 1"/>
+          <p:cNvSpPr>
+            <a:spLocks noGrp="1" noRot="1" noChangeAspect="1"/>
+          </p:cNvSpPr>
+          <p:nvPr>
+            <p:ph type="sldImg"/>
+          </p:nvPr>
+        </p:nvSpPr>
+        <p:spPr/>
+      </p:sp>
+      <p:sp>
+        <p:nvSpPr>
+          <p:cNvPr id="3" name="Notes Placeholder 2"/>
+          <p:cNvSpPr>
+            <a:spLocks noGrp="1"/>
+          </p:cNvSpPr>
+          <p:nvPr>
+            <p:ph type="body" idx="1"/>
+          </p:nvPr>
+        </p:nvSpPr>
+        <p:spPr/>
+        <p:txBody>
+          <a:bodyPr/>
+          <a:lstStyle/>
+          <a:p>
             <a:r>
               <a:rPr lang="en-US" sz="1200" kern="1200" dirty="0">
                 <a:solidFill>
@@ -1308,7 +1453,7 @@
           <a:p>
             <a:fld id="{2CCF031E-D17A-4139-B770-A41292C01C8F}" type="slidenum">
               <a:rPr lang="en-US" smtClean="0"/>
-              <a:t>2</a:t>
+              <a:t>3</a:t>
             </a:fld>
             <a:endParaRPr lang="en-US"/>
           </a:p>
@@ -1327,7 +1472,7 @@
 </p:notes>
 </file>
 
-<file path=ppt/notesSlides/notesSlide3.xml><?xml version="1.0" encoding="utf-8"?>
+<file path=ppt/notesSlides/notesSlide4.xml><?xml version="1.0" encoding="utf-8"?>
 <p:notes xmlns:a="http://schemas.openxmlformats.org/drawingml/2006/main" xmlns:r="http://schemas.openxmlformats.org/officeDocument/2006/relationships" xmlns:p="http://schemas.openxmlformats.org/presentationml/2006/main">
   <p:cSld>
     <p:spTree>
@@ -1433,7 +1578,7 @@
           <a:p>
             <a:fld id="{2CCF031E-D17A-4139-B770-A41292C01C8F}" type="slidenum">
               <a:rPr lang="en-US" smtClean="0"/>
-              <a:t>4</a:t>
+              <a:t>5</a:t>
             </a:fld>
             <a:endParaRPr lang="en-US"/>
           </a:p>
@@ -1452,7 +1597,7 @@
 </p:notes>
 </file>
 
-<file path=ppt/notesSlides/notesSlide4.xml><?xml version="1.0" encoding="utf-8"?>
+<file path=ppt/notesSlides/notesSlide5.xml><?xml version="1.0" encoding="utf-8"?>
 <p:notes xmlns:a="http://schemas.openxmlformats.org/drawingml/2006/main" xmlns:r="http://schemas.openxmlformats.org/officeDocument/2006/relationships" xmlns:p="http://schemas.openxmlformats.org/presentationml/2006/main">
   <p:cSld>
     <p:spTree>
@@ -1650,7 +1795,7 @@
           <a:p>
             <a:fld id="{2CCF031E-D17A-4139-B770-A41292C01C8F}" type="slidenum">
               <a:rPr lang="en-US" smtClean="0"/>
-              <a:t>5</a:t>
+              <a:t>6</a:t>
             </a:fld>
             <a:endParaRPr lang="en-US"/>
           </a:p>
@@ -1660,345 +1805,6 @@
     <p:extLst>
       <p:ext uri="{BB962C8B-B14F-4D97-AF65-F5344CB8AC3E}">
         <p14:creationId xmlns:p14="http://schemas.microsoft.com/office/powerpoint/2010/main" val="2921734860"/>
-      </p:ext>
-    </p:extLst>
-  </p:cSld>
-  <p:clrMapOvr>
-    <a:masterClrMapping/>
-  </p:clrMapOvr>
-</p:notes>
-</file>
-
-<file path=ppt/notesSlides/notesSlide5.xml><?xml version="1.0" encoding="utf-8"?>
-<p:notes xmlns:a="http://schemas.openxmlformats.org/drawingml/2006/main" xmlns:r="http://schemas.openxmlformats.org/officeDocument/2006/relationships" xmlns:p="http://schemas.openxmlformats.org/presentationml/2006/main">
-  <p:cSld>
-    <p:spTree>
-      <p:nvGrpSpPr>
-        <p:cNvPr id="1" name=""/>
-        <p:cNvGrpSpPr/>
-        <p:nvPr/>
-      </p:nvGrpSpPr>
-      <p:grpSpPr>
-        <a:xfrm>
-          <a:off x="0" y="0"/>
-          <a:ext cx="0" cy="0"/>
-          <a:chOff x="0" y="0"/>
-          <a:chExt cx="0" cy="0"/>
-        </a:xfrm>
-      </p:grpSpPr>
-      <p:sp>
-        <p:nvSpPr>
-          <p:cNvPr id="2" name="Slide Image Placeholder 1"/>
-          <p:cNvSpPr>
-            <a:spLocks noGrp="1" noRot="1" noChangeAspect="1"/>
-          </p:cNvSpPr>
-          <p:nvPr>
-            <p:ph type="sldImg"/>
-          </p:nvPr>
-        </p:nvSpPr>
-        <p:spPr/>
-      </p:sp>
-      <p:sp>
-        <p:nvSpPr>
-          <p:cNvPr id="3" name="Notes Placeholder 2"/>
-          <p:cNvSpPr>
-            <a:spLocks noGrp="1"/>
-          </p:cNvSpPr>
-          <p:nvPr>
-            <p:ph type="body" idx="1"/>
-          </p:nvPr>
-        </p:nvSpPr>
-        <p:spPr/>
-        <p:txBody>
-          <a:bodyPr/>
-          <a:lstStyle/>
-          <a:p>
-            <a:r>
-              <a:rPr lang="en-US" dirty="0"/>
-              <a:t>If we look back at the </a:t>
-            </a:r>
-            <a:r>
-              <a:rPr lang="en-US" b="0" dirty="0"/>
-              <a:t>1956 Dartmouth, </a:t>
-            </a:r>
-            <a:r>
-              <a:rPr lang="en-US" dirty="0"/>
-              <a:t>we can understand that the founding fathers of AI didn't agree on a single path to intelligence. </a:t>
-            </a:r>
-            <a:endParaRPr lang="en-US" b="1" dirty="0"/>
-          </a:p>
-          <a:p>
-            <a:endParaRPr lang="en-US" b="1" dirty="0"/>
-          </a:p>
-          <a:p>
-            <a:r>
-              <a:rPr lang="en-US" b="1" dirty="0"/>
-              <a:t>1. Arthur Samuel: The Checkers Player (Machine Learning)</a:t>
-            </a:r>
-          </a:p>
-          <a:p>
-            <a:r>
-              <a:rPr lang="en-US" dirty="0"/>
-              <a:t>Instead of trying to program every possible move and strategy into a computer, Arthur Samuel wrote a program that taught itself how to play checkers.</a:t>
-            </a:r>
-          </a:p>
-          <a:p>
-            <a:endParaRPr lang="en-US" dirty="0"/>
-          </a:p>
-          <a:p>
-            <a:r>
-              <a:rPr lang="en-US" b="1" dirty="0"/>
-              <a:t>How it worked:</a:t>
-            </a:r>
-            <a:r>
-              <a:rPr lang="en-US" dirty="0"/>
-              <a:t> He programmed the computer to play games against itself and keep track of which board positions most frequently led to a win.</a:t>
-            </a:r>
-          </a:p>
-          <a:p>
-            <a:endParaRPr lang="en-US" dirty="0"/>
-          </a:p>
-          <a:p>
-            <a:r>
-              <a:rPr lang="en-US" b="1" dirty="0"/>
-              <a:t>The Significance:</a:t>
-            </a:r>
-            <a:r>
-              <a:rPr lang="en-US" dirty="0"/>
-              <a:t> This was the first operational demonstration of </a:t>
-            </a:r>
-            <a:r>
-              <a:rPr lang="en-US" b="1" dirty="0"/>
-              <a:t>Machine Learning</a:t>
-            </a:r>
-            <a:r>
-              <a:rPr lang="en-US" dirty="0"/>
-              <a:t>. It proved that a machine could dynamically learn from experience and eventually outperform its own creator, laying the exact foundation for how we train modern models via reinforcement learning and behavior cloning.</a:t>
-            </a:r>
-          </a:p>
-          <a:p>
-            <a:endParaRPr lang="en-US" dirty="0"/>
-          </a:p>
-          <a:p>
-            <a:r>
-              <a:rPr lang="en-US" b="1" dirty="0"/>
-              <a:t>2. Allen Newell &amp; Herbert Simon: The Logic Theorist (Symbolic Logic)</a:t>
-            </a:r>
-          </a:p>
-          <a:p>
-            <a:r>
-              <a:rPr lang="en-US" dirty="0"/>
-              <a:t>Newell and Simon wanted to prove that machines could mimic the "Logic Smart" dimension of human thought. They created a program called the </a:t>
-            </a:r>
-            <a:r>
-              <a:rPr lang="en-US" i="1" dirty="0"/>
-              <a:t>Logic Theorist</a:t>
-            </a:r>
-            <a:r>
-              <a:rPr lang="en-US" dirty="0"/>
-              <a:t>.</a:t>
-            </a:r>
-          </a:p>
-          <a:p>
-            <a:endParaRPr lang="en-US" dirty="0"/>
-          </a:p>
-          <a:p>
-            <a:r>
-              <a:rPr lang="en-US" b="1" dirty="0"/>
-              <a:t>How it worked:</a:t>
-            </a:r>
-            <a:r>
-              <a:rPr lang="en-US" dirty="0"/>
-              <a:t> They fed the program the foundational axioms of mathematics and instructed it to find proofs for complex geometric and algebraic theorems.</a:t>
-            </a:r>
-          </a:p>
-          <a:p>
-            <a:endParaRPr lang="en-US" dirty="0"/>
-          </a:p>
-          <a:p>
-            <a:r>
-              <a:rPr lang="en-US" b="1" dirty="0"/>
-              <a:t>The Significance:</a:t>
-            </a:r>
-            <a:r>
-              <a:rPr lang="en-US" dirty="0"/>
-              <a:t> It successfully found, step-by-step logical proofs for 38 theorems from Bertrand Russell’s </a:t>
-            </a:r>
-            <a:r>
-              <a:rPr lang="en-US" i="1" dirty="0"/>
-              <a:t>Principia Mathematica</a:t>
-            </a:r>
-            <a:r>
-              <a:rPr lang="en-US" dirty="0"/>
-              <a:t> and even found a proof for one theorem that was shorter and more elegant than the one Russell had written himself. It was a massive milestone for rule-based, symbolic AI.</a:t>
-            </a:r>
-          </a:p>
-          <a:p>
-            <a:endParaRPr lang="en-US" dirty="0"/>
-          </a:p>
-          <a:p>
-            <a:r>
-              <a:rPr lang="en-US" b="1" dirty="0"/>
-              <a:t>3. Marvin Minsky: The Stochastic Neural-Analog Reinforcement Calculator (SNARC)</a:t>
-            </a:r>
-          </a:p>
-          <a:p>
-            <a:r>
-              <a:rPr lang="en-US" dirty="0"/>
-              <a:t>Before he focused heavily on symbolic cognitive frameworks, a young Marvin Minsky built the world's very first artificial neural network simulator in 1951.</a:t>
-            </a:r>
-          </a:p>
-          <a:p>
-            <a:endParaRPr lang="en-US" dirty="0"/>
-          </a:p>
-          <a:p>
-            <a:r>
-              <a:rPr lang="en-US" b="1" dirty="0"/>
-              <a:t>How it worked:</a:t>
-            </a:r>
-            <a:r>
-              <a:rPr lang="en-US" dirty="0"/>
-              <a:t> Using 3,000 vacuum tubes, motors, and clutches, Minsky built a physical machine that simulated a network of 40 interconnected neurons. He used it to simulate a "rat" navigating through a maze. When the machine made a correct turn toward the exit, it was rewarded with an electrical signal that strengthened those specific physical connections.</a:t>
-            </a:r>
-          </a:p>
-          <a:p>
-            <a:endParaRPr lang="en-US" dirty="0"/>
-          </a:p>
-          <a:p>
-            <a:r>
-              <a:rPr lang="en-US" b="1" dirty="0"/>
-              <a:t>The Significance:</a:t>
-            </a:r>
-            <a:r>
-              <a:rPr lang="en-US" dirty="0"/>
-              <a:t> This was the primitive ancestor to modern </a:t>
-            </a:r>
-            <a:r>
-              <a:rPr lang="en-US" b="1" dirty="0"/>
-              <a:t>Deep Learning</a:t>
-            </a:r>
-            <a:r>
-              <a:rPr lang="en-US" dirty="0"/>
-              <a:t>. Minsky physically demonstrated that a network of simple, non-intelligent components could adjust its internal weights to learn a complex physical behavior.</a:t>
-            </a:r>
-          </a:p>
-          <a:p>
-            <a:endParaRPr lang="en-US" dirty="0"/>
-          </a:p>
-          <a:p>
-            <a:r>
-              <a:rPr lang="en-US" b="1" dirty="0"/>
-              <a:t>4. John McCarthy: Advice Taker &amp; LISP (Goal-Achieving Logic)</a:t>
-            </a:r>
-          </a:p>
-          <a:p>
-            <a:r>
-              <a:rPr lang="en-US" dirty="0"/>
-              <a:t>True to his definition that AI should be free to use non-biological computational methods, John McCarthy created </a:t>
-            </a:r>
-            <a:r>
-              <a:rPr lang="en-US" b="1" dirty="0"/>
-              <a:t>LISP</a:t>
-            </a:r>
-            <a:r>
-              <a:rPr lang="en-US" dirty="0"/>
-              <a:t> (List Processing) in 1958, the programming language that became the standard for AI research for decades.</a:t>
-            </a:r>
-          </a:p>
-          <a:p>
-            <a:endParaRPr lang="en-US" dirty="0"/>
-          </a:p>
-          <a:p>
-            <a:r>
-              <a:rPr lang="en-US" b="1" dirty="0"/>
-              <a:t>How it worked:</a:t>
-            </a:r>
-            <a:r>
-              <a:rPr lang="en-US" dirty="0"/>
-              <a:t> He designed a proposed system called the </a:t>
-            </a:r>
-            <a:r>
-              <a:rPr lang="en-US" i="1" dirty="0"/>
-              <a:t>Advice Taker</a:t>
-            </a:r>
-            <a:r>
-              <a:rPr lang="en-US" dirty="0"/>
-              <a:t>. It was a program designed to search through a database of formal declarations and make logical deductions to achieve a real-world goal (e.g., deducing that to get to the airport, it must drive a car, and to drive a car, it needs keys).</a:t>
-            </a:r>
-          </a:p>
-          <a:p>
-            <a:endParaRPr lang="en-US" dirty="0"/>
-          </a:p>
-          <a:p>
-            <a:r>
-              <a:rPr lang="en-US" b="1" dirty="0"/>
-              <a:t>The Significance:</a:t>
-            </a:r>
-            <a:r>
-              <a:rPr lang="en-US" dirty="0"/>
-              <a:t> McCarthy showed that intelligence could be modeled as a pure search and optimization problem over logical statements, giving birth to classical AI pathfinding and decision-making algorithms.</a:t>
-            </a:r>
-          </a:p>
-          <a:p>
-            <a:endParaRPr lang="en-US" dirty="0"/>
-          </a:p>
-          <a:p>
-            <a:r>
-              <a:rPr lang="en-US" i="1" dirty="0"/>
-              <a:t>Reference: </a:t>
-            </a:r>
-            <a:r>
-              <a:rPr lang="en-US" dirty="0"/>
-              <a:t>Gemini. (2026, June 12). </a:t>
-            </a:r>
-            <a:r>
-              <a:rPr lang="en-US" i="1" dirty="0"/>
-              <a:t>[AI-generated summary of foundational milestones in artificial intelligence history]</a:t>
-            </a:r>
-            <a:r>
-              <a:rPr lang="en-US" dirty="0"/>
-              <a:t> [Large language model]. Google. </a:t>
-            </a:r>
-            <a:r>
-              <a:rPr lang="en-US" dirty="0">
-                <a:hlinkClick r:id="rId3"/>
-              </a:rPr>
-              <a:t>https://gemini.google.com/</a:t>
-            </a:r>
-            <a:endParaRPr lang="en-US" i="1" dirty="0"/>
-          </a:p>
-          <a:p>
-            <a:endParaRPr lang="en-US" dirty="0"/>
-          </a:p>
-        </p:txBody>
-      </p:sp>
-      <p:sp>
-        <p:nvSpPr>
-          <p:cNvPr id="4" name="Slide Number Placeholder 3"/>
-          <p:cNvSpPr>
-            <a:spLocks noGrp="1"/>
-          </p:cNvSpPr>
-          <p:nvPr>
-            <p:ph type="sldNum" sz="quarter" idx="5"/>
-          </p:nvPr>
-        </p:nvSpPr>
-        <p:spPr/>
-        <p:txBody>
-          <a:bodyPr/>
-          <a:lstStyle/>
-          <a:p>
-            <a:fld id="{2CCF031E-D17A-4139-B770-A41292C01C8F}" type="slidenum">
-              <a:rPr lang="en-US" smtClean="0"/>
-              <a:t>6</a:t>
-            </a:fld>
-            <a:endParaRPr lang="en-US"/>
-          </a:p>
-        </p:txBody>
-      </p:sp>
-    </p:spTree>
-    <p:extLst>
-      <p:ext uri="{BB962C8B-B14F-4D97-AF65-F5344CB8AC3E}">
-        <p14:creationId xmlns:p14="http://schemas.microsoft.com/office/powerpoint/2010/main" val="955526280"/>
       </p:ext>
     </p:extLst>
   </p:cSld>
@@ -2052,22 +1858,46 @@
           <a:bodyPr/>
           <a:lstStyle/>
           <a:p>
+            <a:r>
+              <a:rPr lang="en-US" dirty="0"/>
+              <a:t>If we look back at the </a:t>
+            </a:r>
+            <a:r>
+              <a:rPr lang="en-US" b="0" dirty="0"/>
+              <a:t>1956 Dartmouth, </a:t>
+            </a:r>
+            <a:r>
+              <a:rPr lang="en-US" dirty="0"/>
+              <a:t>we can understand that the founding fathers of AI didn't agree on a single path to intelligence. </a:t>
+            </a:r>
             <a:endParaRPr lang="en-US" b="1" dirty="0"/>
           </a:p>
           <a:p>
+            <a:endParaRPr lang="en-US" b="1" dirty="0"/>
+          </a:p>
+          <a:p>
             <a:r>
               <a:rPr lang="en-US" b="1" dirty="0"/>
-              <a:t>Boom 1 (1960s) "GOFAI" (Good Old-Fashioned AI):</a:t>
-            </a:r>
+              <a:t>1. Arthur Samuel: The Checkers Player (Machine Learning)</a:t>
+            </a:r>
+          </a:p>
+          <a:p>
             <a:r>
               <a:rPr lang="en-US" dirty="0"/>
-              <a:t> </a:t>
-            </a:r>
-          </a:p>
-          <a:p>
+              <a:t>Instead of trying to program every possible move and strategy into a computer, Arthur Samuel wrote a program that taught itself how to play checkers.</a:t>
+            </a:r>
+          </a:p>
+          <a:p>
+            <a:endParaRPr lang="en-US" dirty="0"/>
+          </a:p>
+          <a:p>
+            <a:r>
+              <a:rPr lang="en-US" b="1" dirty="0"/>
+              <a:t>How it worked:</a:t>
+            </a:r>
             <a:r>
               <a:rPr lang="en-US" dirty="0"/>
-              <a:t>Centered on heuristic search and early logic programs. This era includes the work of the founders we just discussed.</a:t>
+              <a:t> He programmed the computer to play games against itself and keep track of which board positions most frequently led to a win.</a:t>
             </a:r>
           </a:p>
           <a:p>
@@ -2076,28 +1906,76 @@
           <a:p>
             <a:r>
               <a:rPr lang="en-US" b="1" dirty="0"/>
-              <a:t>Winter 1 (Mid-1970s):</a:t>
-            </a:r>
+              <a:t>The Significance:</a:t>
+            </a:r>
+            <a:r>
+              <a:rPr lang="en-US" dirty="0"/>
+              <a:t> This was the first operational demonstration of </a:t>
+            </a:r>
+            <a:r>
+              <a:rPr lang="en-US" b="1" dirty="0"/>
+              <a:t>Machine Learning</a:t>
+            </a:r>
+            <a:r>
+              <a:rPr lang="en-US" dirty="0"/>
+              <a:t>. It proved that a machine could dynamically learn from experience and eventually outperform its own creator, laying the exact foundation for how we train modern models via reinforcement learning and behavior cloning.</a:t>
+            </a:r>
+          </a:p>
+          <a:p>
             <a:endParaRPr lang="en-US" dirty="0"/>
           </a:p>
           <a:p>
             <a:r>
+              <a:rPr lang="en-US" b="1" dirty="0"/>
+              <a:t>2. Allen Newell &amp; Herbert Simon: The Logic Theorist (Symbolic Logic)</a:t>
+            </a:r>
+          </a:p>
+          <a:p>
+            <a:r>
+              <a:rPr lang="en-US" dirty="0"/>
+              <a:t>Newell and Simon wanted to prove that machines could mimic the "Logic Smart" dimension of human thought. They created a program called the </a:t>
+            </a:r>
+            <a:r>
               <a:rPr lang="en-US" i="1" dirty="0"/>
-              <a:t>Triggers:</a:t>
+              <a:t>Logic Theorist</a:t>
             </a:r>
             <a:r>
               <a:rPr lang="en-US" dirty="0"/>
-              <a:t> Overhyped symbolic AI, disappointing early language translation, slow/expensive hardware, and algorithms failing to handle real-world ambiguity or scale.</a:t>
-            </a:r>
-          </a:p>
-          <a:p>
+              <a:t>.</a:t>
+            </a:r>
+          </a:p>
+          <a:p>
+            <a:endParaRPr lang="en-US" dirty="0"/>
+          </a:p>
+          <a:p>
+            <a:r>
+              <a:rPr lang="en-US" b="1" dirty="0"/>
+              <a:t>How it worked:</a:t>
+            </a:r>
+            <a:r>
+              <a:rPr lang="en-US" dirty="0"/>
+              <a:t> They fed the program the foundational axioms of mathematics and instructed it to find proofs for complex geometric and algebraic theorems.</a:t>
+            </a:r>
+          </a:p>
+          <a:p>
+            <a:endParaRPr lang="en-US" dirty="0"/>
+          </a:p>
+          <a:p>
+            <a:r>
+              <a:rPr lang="en-US" b="1" dirty="0"/>
+              <a:t>The Significance:</a:t>
+            </a:r>
+            <a:r>
+              <a:rPr lang="en-US" dirty="0"/>
+              <a:t> It successfully found, step-by-step logical proofs for 38 theorems from Bertrand Russell’s </a:t>
+            </a:r>
             <a:r>
               <a:rPr lang="en-US" i="1" dirty="0"/>
-              <a:t>Recovery:</a:t>
+              <a:t>Principia Mathematica</a:t>
             </a:r>
             <a:r>
               <a:rPr lang="en-US" dirty="0"/>
-              <a:t> The late 1970s brought specialized expert systems and microprocessors that enabled niche corporate successes.</a:t>
+              <a:t> and even found a proof for one theorem that was shorter and more elegant than the one Russell had written himself. It was a massive milestone for rule-based, symbolic AI.</a:t>
             </a:r>
           </a:p>
           <a:p>
@@ -2106,25 +1984,47 @@
           <a:p>
             <a:r>
               <a:rPr lang="en-US" b="1" dirty="0"/>
-              <a:t>Boom 2 (1980s) "Expert Systems":</a:t>
-            </a:r>
+              <a:t>3. Marvin Minsky: The Stochastic Neural-Analog Reinforcement Calculator (SNARC)</a:t>
+            </a:r>
+          </a:p>
+          <a:p>
             <a:r>
               <a:rPr lang="en-US" dirty="0"/>
-              <a:t> </a:t>
-            </a:r>
-          </a:p>
-          <a:p>
+              <a:t>Before he focused heavily on symbolic cognitive frameworks, a young Marvin Minsky built the world's very first artificial neural network simulator in 1951.</a:t>
+            </a:r>
+          </a:p>
+          <a:p>
+            <a:endParaRPr lang="en-US" dirty="0"/>
+          </a:p>
+          <a:p>
+            <a:r>
+              <a:rPr lang="en-US" b="1" dirty="0"/>
+              <a:t>How it worked:</a:t>
+            </a:r>
             <a:r>
               <a:rPr lang="en-US" dirty="0"/>
-              <a:t>Shifted focus toward </a:t>
-            </a:r>
-            <a:r>
-              <a:rPr lang="en-US" i="0" dirty="0"/>
-              <a:t>knowledge engineering </a:t>
+              <a:t> Using 3,000 vacuum tubes, motors, and clutches, Minsky built a physical machine that simulated a network of 40 interconnected neurons. He used it to simulate a "rat" navigating through a maze. When the machine made a correct turn toward the exit, it was rewarded with an electrical signal that strengthened those specific physical connections.</a:t>
+            </a:r>
+          </a:p>
+          <a:p>
+            <a:endParaRPr lang="en-US" dirty="0"/>
+          </a:p>
+          <a:p>
+            <a:r>
+              <a:rPr lang="en-US" b="1" dirty="0"/>
+              <a:t>The Significance:</a:t>
             </a:r>
             <a:r>
               <a:rPr lang="en-US" dirty="0"/>
-              <a:t>and corporate-focused, rule-based software like DENDRAL and MYCIN, alongside languages like Prolog and Lisp.</a:t>
+              <a:t> This was the primitive ancestor to modern </a:t>
+            </a:r>
+            <a:r>
+              <a:rPr lang="en-US" b="1" dirty="0"/>
+              <a:t>Deep Learning</a:t>
+            </a:r>
+            <a:r>
+              <a:rPr lang="en-US" dirty="0"/>
+              <a:t>. Minsky physically demonstrated that a network of simple, non-intelligent components could adjust its internal weights to learn a complex physical behavior.</a:t>
             </a:r>
           </a:p>
           <a:p>
@@ -2133,141 +2033,84 @@
           <a:p>
             <a:r>
               <a:rPr lang="en-US" b="1" dirty="0"/>
-              <a:t>Winter 2 (Late 1980s – Mid-1990s):</a:t>
-            </a:r>
+              <a:t>4. John McCarthy: Advice Taker &amp; LISP (Goal-Achieving Logic)</a:t>
+            </a:r>
+          </a:p>
+          <a:p>
+            <a:r>
+              <a:rPr lang="en-US" dirty="0"/>
+              <a:t>True to his definition that AI should be free to use non-biological computational methods, John McCarthy created </a:t>
+            </a:r>
+            <a:r>
+              <a:rPr lang="en-US" b="1" dirty="0"/>
+              <a:t>LISP</a:t>
+            </a:r>
+            <a:r>
+              <a:rPr lang="en-US" dirty="0"/>
+              <a:t> (List Processing) in 1958, the programming language that became the standard for AI research for decades.</a:t>
+            </a:r>
+          </a:p>
+          <a:p>
             <a:endParaRPr lang="en-US" dirty="0"/>
           </a:p>
           <a:p>
             <a:r>
+              <a:rPr lang="en-US" b="1" dirty="0"/>
+              <a:t>How it worked:</a:t>
+            </a:r>
+            <a:r>
+              <a:rPr lang="en-US" dirty="0"/>
+              <a:t> He designed a proposed system called the </a:t>
+            </a:r>
+            <a:r>
               <a:rPr lang="en-US" i="1" dirty="0"/>
-              <a:t>Triggers:</a:t>
+              <a:t>Advice Taker</a:t>
             </a:r>
             <a:r>
               <a:rPr lang="en-US" dirty="0"/>
-              <a:t> The expert systems bubble burst because they proved brittle and costly to maintain. Specialized AI hardware (such as "LISP machines") became obsolete, leading to corporate R&amp;D pullbacks and economic downturns.</a:t>
-            </a:r>
+              <a:t>. It was a program designed to search through a database of formal declarations and make logical deductions to achieve a real-world goal (e.g., deducing that to get to the airport, it must drive a car, and to drive a car, it needs keys).</a:t>
+            </a:r>
+          </a:p>
+          <a:p>
+            <a:endParaRPr lang="en-US" dirty="0"/>
+          </a:p>
+          <a:p>
+            <a:r>
+              <a:rPr lang="en-US" b="1" dirty="0"/>
+              <a:t>The Significance:</a:t>
+            </a:r>
+            <a:r>
+              <a:rPr lang="en-US" dirty="0"/>
+              <a:t> McCarthy showed that intelligence could be modeled as a pure search and optimization problem over logical statements, giving birth to classical AI pathfinding and decision-making algorithms.</a:t>
+            </a:r>
+          </a:p>
+          <a:p>
+            <a:endParaRPr lang="en-US" dirty="0"/>
           </a:p>
           <a:p>
             <a:r>
               <a:rPr lang="en-US" i="1" dirty="0"/>
-              <a:t>Recovery:</a:t>
+              <a:t>Reference: </a:t>
             </a:r>
             <a:r>
               <a:rPr lang="en-US" dirty="0"/>
-              <a:t> A shift in the mid-to-late 1990s toward statistical machine learning and data mining, combined with significantly more powerful computers.</a:t>
-            </a:r>
-          </a:p>
-          <a:p>
-            <a:endParaRPr lang="en-US" dirty="0"/>
-          </a:p>
-          <a:p>
-            <a:r>
-              <a:rPr lang="en-US" b="1" dirty="0"/>
-              <a:t>Plateau (Early 2000s):</a:t>
-            </a:r>
-            <a:endParaRPr lang="en-US" dirty="0"/>
-          </a:p>
-          <a:p>
+              <a:t>Gemini. (2026, June 12). </a:t>
+            </a:r>
             <a:r>
               <a:rPr lang="en-US" i="1" dirty="0"/>
-              <a:t>Triggers:</a:t>
+              <a:t>[AI-generated summary of foundational milestones in artificial intelligence history]</a:t>
             </a:r>
             <a:r>
               <a:rPr lang="en-US" dirty="0"/>
-              <a:t> Not always classified as a full winter, this was a plateau where early neural networks stalled due to limited datasets, causing funding to shift elsewhere.</a:t>
-            </a:r>
-          </a:p>
-          <a:p>
-            <a:r>
-              <a:rPr lang="en-US" i="1" dirty="0"/>
-              <a:t>Recovery:</a:t>
-            </a:r>
-            <a:r>
-              <a:rPr lang="en-US" dirty="0"/>
-              <a:t> The breakthrough in Deep Learning architectures, fueled by GPUs and big data.</a:t>
-            </a:r>
-          </a:p>
-          <a:p>
-            <a:endParaRPr lang="en-US" dirty="0"/>
-          </a:p>
-          <a:p>
-            <a:r>
-              <a:rPr lang="en-US" b="1" dirty="0"/>
-              <a:t>Boom 3 (2010s+) "Machine Learning":</a:t>
-            </a:r>
-            <a:r>
-              <a:rPr lang="en-US" dirty="0"/>
-              <a:t> </a:t>
-            </a:r>
-          </a:p>
-          <a:p>
-            <a:r>
-              <a:rPr lang="en-US" dirty="0"/>
-              <a:t>The massive explosion of modern Deep Learning, Autonomous Vehicles, and landmark gaming victories like </a:t>
-            </a:r>
-            <a:r>
-              <a:rPr lang="en-US" i="0" dirty="0"/>
-              <a:t>AlphaGo</a:t>
-            </a:r>
-            <a:r>
-              <a:rPr lang="en-US" dirty="0"/>
-              <a:t> and </a:t>
-            </a:r>
-            <a:r>
-              <a:rPr lang="en-US" i="0" dirty="0" err="1"/>
-              <a:t>Libratus</a:t>
-            </a:r>
-            <a:r>
-              <a:rPr lang="en-US" dirty="0"/>
-              <a:t>, culminating in massive social excitement and concern.</a:t>
-            </a:r>
-          </a:p>
-          <a:p>
-            <a:endParaRPr lang="en-US" dirty="0"/>
-          </a:p>
-          <a:p>
-            <a:pPr marL="0" marR="0" lvl="0" indent="0" algn="l" defTabSz="914400" rtl="0" eaLnBrk="1" fontAlgn="auto" latinLnBrk="0" hangingPunct="1">
-              <a:lnSpc>
-                <a:spcPct val="100000"/>
-              </a:lnSpc>
-              <a:spcBef>
-                <a:spcPts val="0"/>
-              </a:spcBef>
-              <a:spcAft>
-                <a:spcPts val="0"/>
-              </a:spcAft>
-              <a:buClrTx/>
-              <a:buSzTx/>
-              <a:buFontTx/>
-              <a:buNone/>
-              <a:tabLst/>
-              <a:defRPr/>
-            </a:pPr>
-            <a:r>
-              <a:rPr lang="en-US" b="1" dirty="0"/>
-              <a:t>Winter 3 (?):</a:t>
-            </a:r>
-            <a:endParaRPr lang="en-US" dirty="0"/>
-          </a:p>
-          <a:p>
-            <a:r>
-              <a:rPr lang="en-US" b="0" i="1" dirty="0"/>
-              <a:t>Potential Triggers: </a:t>
-            </a:r>
-            <a:r>
-              <a:rPr lang="en-US" dirty="0"/>
-              <a:t>Overpromising near-human capabilities, slower-than-expected return on investment (ROI) for enterprise businesses, and increasing friction from safety, ethics, and regulatory pushback.</a:t>
-            </a:r>
-          </a:p>
-          <a:p>
-            <a:r>
-              <a:rPr lang="en-US" b="0" i="1" dirty="0"/>
-              <a:t>Prescription for Prevention: </a:t>
-            </a:r>
-            <a:r>
-              <a:rPr lang="en-US" dirty="0"/>
-              <a:t>To potentially avoid a massive crash, maybe set realistic goals and timelines, delivering measurable value on actual production use-cases, and invest heavily in system reliability, safety, and interpretability.</a:t>
-            </a:r>
+              <a:t> [Large language model]. Google. </a:t>
+            </a:r>
+            <a:r>
+              <a:rPr lang="en-US" dirty="0">
+                <a:hlinkClick r:id="rId3"/>
+              </a:rPr>
+              <a:t>https://gemini.google.com/</a:t>
+            </a:r>
+            <a:endParaRPr lang="en-US" i="1" dirty="0"/>
           </a:p>
           <a:p>
             <a:endParaRPr lang="en-US" dirty="0"/>
@@ -2300,7 +2143,7 @@
     </p:spTree>
     <p:extLst>
       <p:ext uri="{BB962C8B-B14F-4D97-AF65-F5344CB8AC3E}">
-        <p14:creationId xmlns:p14="http://schemas.microsoft.com/office/powerpoint/2010/main" val="3675656009"/>
+        <p14:creationId xmlns:p14="http://schemas.microsoft.com/office/powerpoint/2010/main" val="955526280"/>
       </p:ext>
     </p:extLst>
   </p:cSld>
@@ -2354,6 +2197,308 @@
           <a:bodyPr/>
           <a:lstStyle/>
           <a:p>
+            <a:endParaRPr lang="en-US" b="1" dirty="0"/>
+          </a:p>
+          <a:p>
+            <a:r>
+              <a:rPr lang="en-US" b="1" dirty="0"/>
+              <a:t>Boom 1 (1960s) "GOFAI" (Good Old-Fashioned AI):</a:t>
+            </a:r>
+            <a:r>
+              <a:rPr lang="en-US" dirty="0"/>
+              <a:t> </a:t>
+            </a:r>
+          </a:p>
+          <a:p>
+            <a:r>
+              <a:rPr lang="en-US" dirty="0"/>
+              <a:t>Centered on heuristic search and early logic programs. This era includes the work of the founders we just discussed.</a:t>
+            </a:r>
+          </a:p>
+          <a:p>
+            <a:endParaRPr lang="en-US" dirty="0"/>
+          </a:p>
+          <a:p>
+            <a:r>
+              <a:rPr lang="en-US" b="1" dirty="0"/>
+              <a:t>Winter 1 (Mid-1970s):</a:t>
+            </a:r>
+            <a:endParaRPr lang="en-US" dirty="0"/>
+          </a:p>
+          <a:p>
+            <a:r>
+              <a:rPr lang="en-US" i="1" dirty="0"/>
+              <a:t>Triggers:</a:t>
+            </a:r>
+            <a:r>
+              <a:rPr lang="en-US" dirty="0"/>
+              <a:t> Overhyped symbolic AI, disappointing early language translation, slow/expensive hardware, and algorithms failing to handle real-world ambiguity or scale.</a:t>
+            </a:r>
+          </a:p>
+          <a:p>
+            <a:r>
+              <a:rPr lang="en-US" i="1" dirty="0"/>
+              <a:t>Recovery:</a:t>
+            </a:r>
+            <a:r>
+              <a:rPr lang="en-US" dirty="0"/>
+              <a:t> The late 1970s brought specialized expert systems and microprocessors that enabled niche corporate successes.</a:t>
+            </a:r>
+          </a:p>
+          <a:p>
+            <a:endParaRPr lang="en-US" dirty="0"/>
+          </a:p>
+          <a:p>
+            <a:r>
+              <a:rPr lang="en-US" b="1" dirty="0"/>
+              <a:t>Boom 2 (1980s) "Expert Systems":</a:t>
+            </a:r>
+            <a:r>
+              <a:rPr lang="en-US" dirty="0"/>
+              <a:t> </a:t>
+            </a:r>
+          </a:p>
+          <a:p>
+            <a:r>
+              <a:rPr lang="en-US" dirty="0"/>
+              <a:t>Shifted focus toward </a:t>
+            </a:r>
+            <a:r>
+              <a:rPr lang="en-US" i="0" dirty="0"/>
+              <a:t>knowledge engineering </a:t>
+            </a:r>
+            <a:r>
+              <a:rPr lang="en-US" dirty="0"/>
+              <a:t>and corporate-focused, rule-based software like DENDRAL and MYCIN, alongside languages like Prolog and Lisp.</a:t>
+            </a:r>
+          </a:p>
+          <a:p>
+            <a:endParaRPr lang="en-US" dirty="0"/>
+          </a:p>
+          <a:p>
+            <a:r>
+              <a:rPr lang="en-US" b="1" dirty="0"/>
+              <a:t>Winter 2 (Late 1980s – Mid-1990s):</a:t>
+            </a:r>
+            <a:endParaRPr lang="en-US" dirty="0"/>
+          </a:p>
+          <a:p>
+            <a:r>
+              <a:rPr lang="en-US" i="1" dirty="0"/>
+              <a:t>Triggers:</a:t>
+            </a:r>
+            <a:r>
+              <a:rPr lang="en-US" dirty="0"/>
+              <a:t> The expert systems bubble burst because they proved brittle and costly to maintain. Specialized AI hardware (such as "LISP machines") became obsolete, leading to corporate R&amp;D pullbacks and economic downturns.</a:t>
+            </a:r>
+          </a:p>
+          <a:p>
+            <a:r>
+              <a:rPr lang="en-US" i="1" dirty="0"/>
+              <a:t>Recovery:</a:t>
+            </a:r>
+            <a:r>
+              <a:rPr lang="en-US" dirty="0"/>
+              <a:t> A shift in the mid-to-late 1990s toward statistical machine learning and data mining, combined with significantly more powerful computers.</a:t>
+            </a:r>
+          </a:p>
+          <a:p>
+            <a:endParaRPr lang="en-US" dirty="0"/>
+          </a:p>
+          <a:p>
+            <a:r>
+              <a:rPr lang="en-US" b="1" dirty="0"/>
+              <a:t>Plateau (Early 2000s):</a:t>
+            </a:r>
+            <a:endParaRPr lang="en-US" dirty="0"/>
+          </a:p>
+          <a:p>
+            <a:r>
+              <a:rPr lang="en-US" i="1" dirty="0"/>
+              <a:t>Triggers:</a:t>
+            </a:r>
+            <a:r>
+              <a:rPr lang="en-US" dirty="0"/>
+              <a:t> Not always classified as a full winter, this was a plateau where early neural networks stalled due to limited datasets, causing funding to shift elsewhere.</a:t>
+            </a:r>
+          </a:p>
+          <a:p>
+            <a:r>
+              <a:rPr lang="en-US" i="1" dirty="0"/>
+              <a:t>Recovery:</a:t>
+            </a:r>
+            <a:r>
+              <a:rPr lang="en-US" dirty="0"/>
+              <a:t> The breakthrough in Deep Learning architectures, fueled by GPUs and big data.</a:t>
+            </a:r>
+          </a:p>
+          <a:p>
+            <a:endParaRPr lang="en-US" dirty="0"/>
+          </a:p>
+          <a:p>
+            <a:r>
+              <a:rPr lang="en-US" b="1" dirty="0"/>
+              <a:t>Boom 3 (2010s+) "Machine Learning":</a:t>
+            </a:r>
+            <a:r>
+              <a:rPr lang="en-US" dirty="0"/>
+              <a:t> </a:t>
+            </a:r>
+          </a:p>
+          <a:p>
+            <a:r>
+              <a:rPr lang="en-US" dirty="0"/>
+              <a:t>The massive explosion of modern Deep Learning, Autonomous Vehicles, and landmark gaming victories like </a:t>
+            </a:r>
+            <a:r>
+              <a:rPr lang="en-US" i="0" dirty="0"/>
+              <a:t>AlphaGo</a:t>
+            </a:r>
+            <a:r>
+              <a:rPr lang="en-US" dirty="0"/>
+              <a:t> and </a:t>
+            </a:r>
+            <a:r>
+              <a:rPr lang="en-US" i="0" dirty="0" err="1"/>
+              <a:t>Libratus</a:t>
+            </a:r>
+            <a:r>
+              <a:rPr lang="en-US" dirty="0"/>
+              <a:t>, culminating in massive social excitement and concern.</a:t>
+            </a:r>
+          </a:p>
+          <a:p>
+            <a:endParaRPr lang="en-US" dirty="0"/>
+          </a:p>
+          <a:p>
+            <a:pPr marL="0" marR="0" lvl="0" indent="0" algn="l" defTabSz="914400" rtl="0" eaLnBrk="1" fontAlgn="auto" latinLnBrk="0" hangingPunct="1">
+              <a:lnSpc>
+                <a:spcPct val="100000"/>
+              </a:lnSpc>
+              <a:spcBef>
+                <a:spcPts val="0"/>
+              </a:spcBef>
+              <a:spcAft>
+                <a:spcPts val="0"/>
+              </a:spcAft>
+              <a:buClrTx/>
+              <a:buSzTx/>
+              <a:buFontTx/>
+              <a:buNone/>
+              <a:tabLst/>
+              <a:defRPr/>
+            </a:pPr>
+            <a:r>
+              <a:rPr lang="en-US" b="1" dirty="0"/>
+              <a:t>Winter 3 (?):</a:t>
+            </a:r>
+            <a:endParaRPr lang="en-US" dirty="0"/>
+          </a:p>
+          <a:p>
+            <a:r>
+              <a:rPr lang="en-US" b="0" i="1" dirty="0"/>
+              <a:t>Potential Triggers: </a:t>
+            </a:r>
+            <a:r>
+              <a:rPr lang="en-US" dirty="0"/>
+              <a:t>Overpromising near-human capabilities, slower-than-expected return on investment (ROI) for enterprise businesses, and increasing friction from safety, ethics, and regulatory pushback.</a:t>
+            </a:r>
+          </a:p>
+          <a:p>
+            <a:r>
+              <a:rPr lang="en-US" b="0" i="1" dirty="0"/>
+              <a:t>Prescription for Prevention: </a:t>
+            </a:r>
+            <a:r>
+              <a:rPr lang="en-US" dirty="0"/>
+              <a:t>To potentially avoid a massive crash, maybe set realistic goals and timelines, delivering measurable value on actual production use-cases, and invest heavily in system reliability, safety, and interpretability.</a:t>
+            </a:r>
+          </a:p>
+          <a:p>
+            <a:endParaRPr lang="en-US" dirty="0"/>
+          </a:p>
+        </p:txBody>
+      </p:sp>
+      <p:sp>
+        <p:nvSpPr>
+          <p:cNvPr id="4" name="Slide Number Placeholder 3"/>
+          <p:cNvSpPr>
+            <a:spLocks noGrp="1"/>
+          </p:cNvSpPr>
+          <p:nvPr>
+            <p:ph type="sldNum" sz="quarter" idx="5"/>
+          </p:nvPr>
+        </p:nvSpPr>
+        <p:spPr/>
+        <p:txBody>
+          <a:bodyPr/>
+          <a:lstStyle/>
+          <a:p>
+            <a:fld id="{2CCF031E-D17A-4139-B770-A41292C01C8F}" type="slidenum">
+              <a:rPr lang="en-US" smtClean="0"/>
+              <a:t>8</a:t>
+            </a:fld>
+            <a:endParaRPr lang="en-US"/>
+          </a:p>
+        </p:txBody>
+      </p:sp>
+    </p:spTree>
+    <p:extLst>
+      <p:ext uri="{BB962C8B-B14F-4D97-AF65-F5344CB8AC3E}">
+        <p14:creationId xmlns:p14="http://schemas.microsoft.com/office/powerpoint/2010/main" val="3675656009"/>
+      </p:ext>
+    </p:extLst>
+  </p:cSld>
+  <p:clrMapOvr>
+    <a:masterClrMapping/>
+  </p:clrMapOvr>
+</p:notes>
+</file>
+
+<file path=ppt/notesSlides/notesSlide8.xml><?xml version="1.0" encoding="utf-8"?>
+<p:notes xmlns:a="http://schemas.openxmlformats.org/drawingml/2006/main" xmlns:r="http://schemas.openxmlformats.org/officeDocument/2006/relationships" xmlns:p="http://schemas.openxmlformats.org/presentationml/2006/main">
+  <p:cSld>
+    <p:spTree>
+      <p:nvGrpSpPr>
+        <p:cNvPr id="1" name=""/>
+        <p:cNvGrpSpPr/>
+        <p:nvPr/>
+      </p:nvGrpSpPr>
+      <p:grpSpPr>
+        <a:xfrm>
+          <a:off x="0" y="0"/>
+          <a:ext cx="0" cy="0"/>
+          <a:chOff x="0" y="0"/>
+          <a:chExt cx="0" cy="0"/>
+        </a:xfrm>
+      </p:grpSpPr>
+      <p:sp>
+        <p:nvSpPr>
+          <p:cNvPr id="2" name="Slide Image Placeholder 1"/>
+          <p:cNvSpPr>
+            <a:spLocks noGrp="1" noRot="1" noChangeAspect="1"/>
+          </p:cNvSpPr>
+          <p:nvPr>
+            <p:ph type="sldImg"/>
+          </p:nvPr>
+        </p:nvSpPr>
+        <p:spPr/>
+      </p:sp>
+      <p:sp>
+        <p:nvSpPr>
+          <p:cNvPr id="3" name="Notes Placeholder 2"/>
+          <p:cNvSpPr>
+            <a:spLocks noGrp="1"/>
+          </p:cNvSpPr>
+          <p:nvPr>
+            <p:ph type="body" idx="1"/>
+          </p:nvPr>
+        </p:nvSpPr>
+        <p:spPr/>
+        <p:txBody>
+          <a:bodyPr/>
+          <a:lstStyle/>
+          <a:p>
             <a:r>
               <a:rPr lang="en-US" sz="1200" b="0" i="0" kern="1200" dirty="0">
                 <a:solidFill>
@@ -2710,7 +2855,7 @@
           <a:p>
             <a:fld id="{2CCF031E-D17A-4139-B770-A41292C01C8F}" type="slidenum">
               <a:rPr lang="en-US" smtClean="0"/>
-              <a:t>8</a:t>
+              <a:t>9</a:t>
             </a:fld>
             <a:endParaRPr lang="en-US"/>
           </a:p>
@@ -2720,290 +2865,6 @@
     <p:extLst>
       <p:ext uri="{BB962C8B-B14F-4D97-AF65-F5344CB8AC3E}">
         <p14:creationId xmlns:p14="http://schemas.microsoft.com/office/powerpoint/2010/main" val="3499842375"/>
-      </p:ext>
-    </p:extLst>
-  </p:cSld>
-  <p:clrMapOvr>
-    <a:masterClrMapping/>
-  </p:clrMapOvr>
-</p:notes>
-</file>
-
-<file path=ppt/notesSlides/notesSlide8.xml><?xml version="1.0" encoding="utf-8"?>
-<p:notes xmlns:a="http://schemas.openxmlformats.org/drawingml/2006/main" xmlns:r="http://schemas.openxmlformats.org/officeDocument/2006/relationships" xmlns:p="http://schemas.openxmlformats.org/presentationml/2006/main">
-  <p:cSld>
-    <p:spTree>
-      <p:nvGrpSpPr>
-        <p:cNvPr id="1" name=""/>
-        <p:cNvGrpSpPr/>
-        <p:nvPr/>
-      </p:nvGrpSpPr>
-      <p:grpSpPr>
-        <a:xfrm>
-          <a:off x="0" y="0"/>
-          <a:ext cx="0" cy="0"/>
-          <a:chOff x="0" y="0"/>
-          <a:chExt cx="0" cy="0"/>
-        </a:xfrm>
-      </p:grpSpPr>
-      <p:sp>
-        <p:nvSpPr>
-          <p:cNvPr id="2" name="Slide Image Placeholder 1"/>
-          <p:cNvSpPr>
-            <a:spLocks noGrp="1" noRot="1" noChangeAspect="1"/>
-          </p:cNvSpPr>
-          <p:nvPr>
-            <p:ph type="sldImg"/>
-          </p:nvPr>
-        </p:nvSpPr>
-        <p:spPr/>
-      </p:sp>
-      <p:sp>
-        <p:nvSpPr>
-          <p:cNvPr id="3" name="Notes Placeholder 2"/>
-          <p:cNvSpPr>
-            <a:spLocks noGrp="1"/>
-          </p:cNvSpPr>
-          <p:nvPr>
-            <p:ph type="body" idx="1"/>
-          </p:nvPr>
-        </p:nvSpPr>
-        <p:spPr/>
-        <p:txBody>
-          <a:bodyPr/>
-          <a:lstStyle/>
-          <a:p>
-            <a:r>
-              <a:rPr lang="en-US" sz="1200" b="0" i="0" kern="1200" dirty="0">
-                <a:solidFill>
-                  <a:schemeClr val="tx1"/>
-                </a:solidFill>
-                <a:effectLst/>
-                <a:latin typeface="+mn-lt"/>
-                <a:ea typeface="+mn-ea"/>
-                <a:cs typeface="+mn-cs"/>
-              </a:rPr>
-              <a:t>John Searle was an American philosopher widely noted for contributions to the </a:t>
-            </a:r>
-            <a:r>
-              <a:rPr lang="en-US" sz="1200" b="0" i="0" u="none" strike="noStrike" kern="1200" dirty="0">
-                <a:solidFill>
-                  <a:schemeClr val="tx1"/>
-                </a:solidFill>
-                <a:effectLst/>
-                <a:latin typeface="+mn-lt"/>
-                <a:ea typeface="+mn-ea"/>
-                <a:cs typeface="+mn-cs"/>
-              </a:rPr>
-              <a:t>philosophy of language</a:t>
-            </a:r>
-            <a:r>
-              <a:rPr lang="en-US" sz="1200" b="0" i="0" kern="1200" dirty="0">
-                <a:solidFill>
-                  <a:schemeClr val="tx1"/>
-                </a:solidFill>
-                <a:effectLst/>
-                <a:latin typeface="+mn-lt"/>
-                <a:ea typeface="+mn-ea"/>
-                <a:cs typeface="+mn-cs"/>
-              </a:rPr>
-              <a:t>, </a:t>
-            </a:r>
-            <a:r>
-              <a:rPr lang="en-US" sz="1200" b="0" i="0" u="none" strike="noStrike" kern="1200" dirty="0">
-                <a:solidFill>
-                  <a:schemeClr val="tx1"/>
-                </a:solidFill>
-                <a:effectLst/>
-                <a:latin typeface="+mn-lt"/>
-                <a:ea typeface="+mn-ea"/>
-                <a:cs typeface="+mn-cs"/>
-              </a:rPr>
-              <a:t>philosophy of mind</a:t>
-            </a:r>
-            <a:r>
-              <a:rPr lang="en-US" sz="1200" b="0" i="0" kern="1200" dirty="0">
-                <a:solidFill>
-                  <a:schemeClr val="tx1"/>
-                </a:solidFill>
-                <a:effectLst/>
-                <a:latin typeface="+mn-lt"/>
-                <a:ea typeface="+mn-ea"/>
-                <a:cs typeface="+mn-cs"/>
-              </a:rPr>
-              <a:t>, and </a:t>
-            </a:r>
-            <a:r>
-              <a:rPr lang="en-US" sz="1200" b="0" i="0" u="none" strike="noStrike" kern="1200" dirty="0">
-                <a:solidFill>
-                  <a:schemeClr val="tx1"/>
-                </a:solidFill>
-                <a:effectLst/>
-                <a:latin typeface="+mn-lt"/>
-                <a:ea typeface="+mn-ea"/>
-                <a:cs typeface="+mn-cs"/>
-              </a:rPr>
-              <a:t>social philosophy</a:t>
-            </a:r>
-            <a:r>
-              <a:rPr lang="en-US" sz="1200" b="0" i="0" kern="1200" dirty="0">
-                <a:solidFill>
-                  <a:schemeClr val="tx1"/>
-                </a:solidFill>
-                <a:effectLst/>
-                <a:latin typeface="+mn-lt"/>
-                <a:ea typeface="+mn-ea"/>
-                <a:cs typeface="+mn-cs"/>
-              </a:rPr>
-              <a:t>.</a:t>
-            </a:r>
-          </a:p>
-          <a:p>
-            <a:endParaRPr lang="en-US" dirty="0"/>
-          </a:p>
-          <a:p>
-            <a:r>
-              <a:rPr lang="en-US" dirty="0"/>
-              <a:t>The Thought Experiment:</a:t>
-            </a:r>
-          </a:p>
-          <a:p>
-            <a:r>
-              <a:rPr lang="en-US" dirty="0"/>
-              <a:t>– Searle cannot understand any Chinese.</a:t>
-            </a:r>
-          </a:p>
-          <a:p>
-            <a:r>
-              <a:rPr lang="en-US" dirty="0"/>
-              <a:t>– He is in a room with input/output windows, and a comprehensive list of rules about manipulating Chinese characters.</a:t>
-            </a:r>
-          </a:p>
-          <a:p>
-            <a:r>
-              <a:rPr lang="en-US" dirty="0"/>
-              <a:t>– Chinese questions come in from the input window, Searle manipulates the characters and produces an answer by following rules, then the answers are sent out via the output window. </a:t>
-            </a:r>
-          </a:p>
-          <a:p>
-            <a:r>
-              <a:rPr lang="en-US" dirty="0"/>
-              <a:t>– The answers that Searle produces are very good, no one can tell that he is not a native Chinese speaker!</a:t>
-            </a:r>
-          </a:p>
-          <a:p>
-            <a:endParaRPr lang="en-US" dirty="0"/>
-          </a:p>
-          <a:p>
-            <a:r>
-              <a:rPr lang="en-US" dirty="0"/>
-              <a:t>Consequences:</a:t>
-            </a:r>
-          </a:p>
-          <a:p>
-            <a:r>
-              <a:rPr lang="en-US" dirty="0"/>
-              <a:t>Searle’s Chinese Room passes the Turing Test. It functions like an intelligent person. But Searle does not understand the Chinese symbols in the question, the answer, or the rules, so Searle has only conducted symbol manipulation. Therefore, passing the Turing Test does not ensure understanding. In other words, although Searle’s Chinese Room functions like a mind, it is not a mind. By analogy, computers only manipulate the symbols that it interacts with (input, output, program code, data), so computers passing the Turing Test does not ensure understanding, it only demonstrates intelligent behavior.</a:t>
-            </a:r>
-          </a:p>
-          <a:p>
-            <a:endParaRPr lang="en-US" dirty="0"/>
-          </a:p>
-          <a:p>
-            <a:r>
-              <a:rPr lang="en-US" dirty="0"/>
-              <a:t>Strong AI (also known as AGI): A theoretical form of machine intelligence that possesses the ability to understand, learn, and apply knowledge across any intellectual task just like a human being. So, something that doesn’t just simulate a mind but literally is a mind.</a:t>
-            </a:r>
-          </a:p>
-          <a:p>
-            <a:endParaRPr lang="en-US" dirty="0"/>
-          </a:p>
-          <a:p>
-            <a:r>
-              <a:rPr lang="en-US" dirty="0"/>
-              <a:t>Searle’s Conclusion Against Strong AI: Real understanding “is a biological phenomenon” and “only something with the same causal powers as brains can have [understanding]”.</a:t>
-            </a:r>
-          </a:p>
-          <a:p>
-            <a:endParaRPr lang="en-US" dirty="0"/>
-          </a:p>
-          <a:p>
-            <a:r>
-              <a:rPr lang="en-US" i="1" dirty="0"/>
-              <a:t>Reference: </a:t>
-            </a:r>
-            <a:r>
-              <a:rPr lang="en-US" dirty="0"/>
-              <a:t>Searle, J. R. (1980). Minds, brains, and programs.</a:t>
-            </a:r>
-          </a:p>
-          <a:p>
-            <a:endParaRPr lang="en-US" dirty="0"/>
-          </a:p>
-          <a:p>
-            <a:pPr marL="0" marR="0" lvl="0" indent="0" algn="l" defTabSz="914400" rtl="0" eaLnBrk="1" fontAlgn="auto" latinLnBrk="0" hangingPunct="1">
-              <a:lnSpc>
-                <a:spcPct val="100000"/>
-              </a:lnSpc>
-              <a:spcBef>
-                <a:spcPts val="0"/>
-              </a:spcBef>
-              <a:spcAft>
-                <a:spcPts val="0"/>
-              </a:spcAft>
-              <a:buClrTx/>
-              <a:buSzTx/>
-              <a:buFontTx/>
-              <a:buNone/>
-              <a:tabLst/>
-              <a:defRPr/>
-            </a:pPr>
-            <a:r>
-              <a:rPr lang="en-US" dirty="0"/>
-              <a:t>This measures functional output vs internal meaning proves that intelligent behavior can exist without understanding.</a:t>
-            </a:r>
-          </a:p>
-          <a:p>
-            <a:endParaRPr lang="en-US" dirty="0"/>
-          </a:p>
-          <a:p>
-            <a:r>
-              <a:rPr lang="en-US" dirty="0"/>
-              <a:t>This raises the question, how does intelligent behavior emerge without understanding?</a:t>
-            </a:r>
-          </a:p>
-          <a:p>
-            <a:endParaRPr lang="en-US" dirty="0"/>
-          </a:p>
-        </p:txBody>
-      </p:sp>
-      <p:sp>
-        <p:nvSpPr>
-          <p:cNvPr id="4" name="Slide Number Placeholder 3"/>
-          <p:cNvSpPr>
-            <a:spLocks noGrp="1"/>
-          </p:cNvSpPr>
-          <p:nvPr>
-            <p:ph type="sldNum" sz="quarter" idx="5"/>
-          </p:nvPr>
-        </p:nvSpPr>
-        <p:spPr/>
-        <p:txBody>
-          <a:bodyPr/>
-          <a:lstStyle/>
-          <a:p>
-            <a:fld id="{2CCF031E-D17A-4139-B770-A41292C01C8F}" type="slidenum">
-              <a:rPr lang="en-US" smtClean="0"/>
-              <a:t>9</a:t>
-            </a:fld>
-            <a:endParaRPr lang="en-US"/>
-          </a:p>
-        </p:txBody>
-      </p:sp>
-    </p:spTree>
-    <p:extLst>
-      <p:ext uri="{BB962C8B-B14F-4D97-AF65-F5344CB8AC3E}">
-        <p14:creationId xmlns:p14="http://schemas.microsoft.com/office/powerpoint/2010/main" val="432677860"/>
       </p:ext>
     </p:extLst>
   </p:cSld>
@@ -3058,16 +2919,121 @@
           <a:lstStyle/>
           <a:p>
             <a:r>
+              <a:rPr lang="en-US" sz="1200" b="0" i="0" kern="1200" dirty="0">
+                <a:solidFill>
+                  <a:schemeClr val="tx1"/>
+                </a:solidFill>
+                <a:effectLst/>
+                <a:latin typeface="+mn-lt"/>
+                <a:ea typeface="+mn-ea"/>
+                <a:cs typeface="+mn-cs"/>
+              </a:rPr>
+              <a:t>John Searle was an American philosopher widely noted for contributions to the </a:t>
+            </a:r>
+            <a:r>
+              <a:rPr lang="en-US" sz="1200" b="0" i="0" u="none" strike="noStrike" kern="1200" dirty="0">
+                <a:solidFill>
+                  <a:schemeClr val="tx1"/>
+                </a:solidFill>
+                <a:effectLst/>
+                <a:latin typeface="+mn-lt"/>
+                <a:ea typeface="+mn-ea"/>
+                <a:cs typeface="+mn-cs"/>
+              </a:rPr>
+              <a:t>philosophy of language</a:t>
+            </a:r>
+            <a:r>
+              <a:rPr lang="en-US" sz="1200" b="0" i="0" kern="1200" dirty="0">
+                <a:solidFill>
+                  <a:schemeClr val="tx1"/>
+                </a:solidFill>
+                <a:effectLst/>
+                <a:latin typeface="+mn-lt"/>
+                <a:ea typeface="+mn-ea"/>
+                <a:cs typeface="+mn-cs"/>
+              </a:rPr>
+              <a:t>, </a:t>
+            </a:r>
+            <a:r>
+              <a:rPr lang="en-US" sz="1200" b="0" i="0" u="none" strike="noStrike" kern="1200" dirty="0">
+                <a:solidFill>
+                  <a:schemeClr val="tx1"/>
+                </a:solidFill>
+                <a:effectLst/>
+                <a:latin typeface="+mn-lt"/>
+                <a:ea typeface="+mn-ea"/>
+                <a:cs typeface="+mn-cs"/>
+              </a:rPr>
+              <a:t>philosophy of mind</a:t>
+            </a:r>
+            <a:r>
+              <a:rPr lang="en-US" sz="1200" b="0" i="0" kern="1200" dirty="0">
+                <a:solidFill>
+                  <a:schemeClr val="tx1"/>
+                </a:solidFill>
+                <a:effectLst/>
+                <a:latin typeface="+mn-lt"/>
+                <a:ea typeface="+mn-ea"/>
+                <a:cs typeface="+mn-cs"/>
+              </a:rPr>
+              <a:t>, and </a:t>
+            </a:r>
+            <a:r>
+              <a:rPr lang="en-US" sz="1200" b="0" i="0" u="none" strike="noStrike" kern="1200" dirty="0">
+                <a:solidFill>
+                  <a:schemeClr val="tx1"/>
+                </a:solidFill>
+                <a:effectLst/>
+                <a:latin typeface="+mn-lt"/>
+                <a:ea typeface="+mn-ea"/>
+                <a:cs typeface="+mn-cs"/>
+              </a:rPr>
+              <a:t>social philosophy</a:t>
+            </a:r>
+            <a:r>
+              <a:rPr lang="en-US" sz="1200" b="0" i="0" kern="1200" dirty="0">
+                <a:solidFill>
+                  <a:schemeClr val="tx1"/>
+                </a:solidFill>
+                <a:effectLst/>
+                <a:latin typeface="+mn-lt"/>
+                <a:ea typeface="+mn-ea"/>
+                <a:cs typeface="+mn-cs"/>
+              </a:rPr>
+              <a:t>.</a:t>
+            </a:r>
+          </a:p>
+          <a:p>
+            <a:endParaRPr lang="en-US" dirty="0"/>
+          </a:p>
+          <a:p>
+            <a:r>
               <a:rPr lang="en-US" dirty="0"/>
-              <a:t>This is an interesting fictional test from the 1982 movie Blade Runner. This movie is set in a dystopian, cyberpunk future. The story follows Rick Deckard, a specialized police officer known as a Blade Runner. His job is to track down and "retire" (execute) </a:t>
-            </a:r>
-            <a:r>
-              <a:rPr lang="en-US" b="0" dirty="0"/>
-              <a:t>Replicants. Replicants are </a:t>
-            </a:r>
+              <a:t>The Thought Experiment:</a:t>
+            </a:r>
+          </a:p>
+          <a:p>
             <a:r>
               <a:rPr lang="en-US" dirty="0"/>
-              <a:t>bioengineered synthetic humans created by the Tyrell Corporation.</a:t>
+              <a:t>– Searle cannot understand any Chinese.</a:t>
+            </a:r>
+          </a:p>
+          <a:p>
+            <a:r>
+              <a:rPr lang="en-US" dirty="0"/>
+              <a:t>– He is in a room with input/output windows, and a comprehensive list of rules about manipulating Chinese characters.</a:t>
+            </a:r>
+          </a:p>
+          <a:p>
+            <a:r>
+              <a:rPr lang="en-US" dirty="0"/>
+              <a:t>– Chinese questions come in from the input window, Searle manipulates the characters and produces an answer by following rules, then the answers are sent out via the output window. </a:t>
+            </a:r>
+          </a:p>
+          <a:p>
+            <a:r>
+              <a:rPr lang="en-US" dirty="0"/>
+              <a:t>– The answers that Searle produces are very good, no one can tell that he is not a native Chinese speaker!</a:t>
             </a:r>
           </a:p>
           <a:p>
@@ -3075,12 +3041,14 @@
           </a:p>
           <a:p>
             <a:r>
-              <a:rPr lang="en-US" b="1" dirty="0"/>
-              <a:t>The Conflict:</a:t>
-            </a:r>
-            <a:r>
               <a:rPr lang="en-US" dirty="0"/>
-              <a:t> Replicants are physically and intellectually superior to humans, built to do dangerous off-world labor. However, they are entirely illegal on Earth.</a:t>
+              <a:t>Consequences:</a:t>
+            </a:r>
+          </a:p>
+          <a:p>
+            <a:r>
+              <a:rPr lang="en-US" dirty="0"/>
+              <a:t>Searle’s Chinese Room passes the Turing Test. It functions like an intelligent person. But Searle does not understand the Chinese symbols in the question, the answer, or the rules, so Searle has only conducted symbol manipulation. Therefore, passing the Turing Test does not ensure understanding. In other words, although Searle’s Chinese Room functions like a mind, it is not a mind. By analogy, computers only manipulate the symbols that it interacts with (input, output, program code, data), so computers passing the Turing Test does not ensure understanding, it only demonstrates intelligent behavior.</a:t>
             </a:r>
           </a:p>
           <a:p>
@@ -3088,12 +3056,30 @@
           </a:p>
           <a:p>
             <a:r>
-              <a:rPr lang="en-US" b="1" dirty="0"/>
-              <a:t>The Problem:</a:t>
-            </a:r>
-            <a:r>
               <a:rPr lang="en-US" dirty="0"/>
-              <a:t> Replicants are so advanced that they develop their own emotions, memories, and a fierce desire for survival. They become virtually indistinguishable from natural-born humans, passing as human in everyday society.</a:t>
+              <a:t>Strong AI (also known as AGI): A theoretical form of machine intelligence that possesses the ability to understand, learn, and apply knowledge across any intellectual task just like a human being. So, something that doesn’t just simulate a mind but literally is a mind.</a:t>
+            </a:r>
+          </a:p>
+          <a:p>
+            <a:endParaRPr lang="en-US" dirty="0"/>
+          </a:p>
+          <a:p>
+            <a:r>
+              <a:rPr lang="en-US" dirty="0"/>
+              <a:t>Searle’s Conclusion Against Strong AI: Real understanding “is a biological phenomenon” and “only something with the same causal powers as brains can have [understanding]”.</a:t>
+            </a:r>
+          </a:p>
+          <a:p>
+            <a:endParaRPr lang="en-US" dirty="0"/>
+          </a:p>
+          <a:p>
+            <a:r>
+              <a:rPr lang="en-US" i="1" dirty="0"/>
+              <a:t>Reference: </a:t>
+            </a:r>
+            <a:r>
+              <a:rPr lang="en-US" dirty="0"/>
+              <a:t>Searle, J. R. (1980). Minds, brains, and programs.</a:t>
             </a:r>
           </a:p>
           <a:p>
@@ -3119,7 +3105,7 @@
             </a:pPr>
             <a:r>
               <a:rPr lang="en-US" dirty="0"/>
-              <a:t>This measures subconscious empathy and biology. The test assumes intelligent behavior already exist and tests for emotional authenticity.</a:t>
+              <a:t>This measures functional output vs internal meaning proves that intelligent behavior can exist without understanding.</a:t>
             </a:r>
           </a:p>
           <a:p>
@@ -3128,18 +3114,8 @@
           <a:p>
             <a:r>
               <a:rPr lang="en-US" dirty="0"/>
-              <a:t>This raises an interesting question, </a:t>
-            </a:r>
-            <a:r>
-              <a:rPr lang="en-US" i="0" dirty="0"/>
-              <a:t>if an artificial being acts perfectly human, does it possess a soul, or is it just a sophisticated machine?</a:t>
-            </a:r>
-          </a:p>
-          <a:p>
-            <a:endParaRPr lang="en-US" dirty="0"/>
-          </a:p>
-          <a:p>
-            <a:endParaRPr lang="en-US" dirty="0"/>
+              <a:t>This raises the question, how does intelligent behavior emerge without understanding?</a:t>
+            </a:r>
           </a:p>
           <a:p>
             <a:endParaRPr lang="en-US" dirty="0"/>
@@ -3172,7 +3148,7 @@
     </p:spTree>
     <p:extLst>
       <p:ext uri="{BB962C8B-B14F-4D97-AF65-F5344CB8AC3E}">
-        <p14:creationId xmlns:p14="http://schemas.microsoft.com/office/powerpoint/2010/main" val="2729791754"/>
+        <p14:creationId xmlns:p14="http://schemas.microsoft.com/office/powerpoint/2010/main" val="432677860"/>
       </p:ext>
     </p:extLst>
   </p:cSld>
@@ -3581,7 +3557,7 @@
           <a:p>
             <a:fld id="{D7E3ECEC-7E7B-4FB9-BAE8-5C10F12795EA}" type="datetimeFigureOut">
               <a:rPr lang="en-US" smtClean="0"/>
-              <a:t>6/19/2026</a:t>
+              <a:t>6/26/2026</a:t>
             </a:fld>
             <a:endParaRPr lang="en-US"/>
           </a:p>
@@ -4010,7 +3986,7 @@
           <a:p>
             <a:fld id="{D7E3ECEC-7E7B-4FB9-BAE8-5C10F12795EA}" type="datetimeFigureOut">
               <a:rPr lang="en-US" smtClean="0"/>
-              <a:t>6/19/2026</a:t>
+              <a:t>6/26/2026</a:t>
             </a:fld>
             <a:endParaRPr lang="en-US"/>
           </a:p>
@@ -4506,7 +4482,7 @@
           <a:p>
             <a:fld id="{D7E3ECEC-7E7B-4FB9-BAE8-5C10F12795EA}" type="datetimeFigureOut">
               <a:rPr lang="en-US" smtClean="0"/>
-              <a:t>6/19/2026</a:t>
+              <a:t>6/26/2026</a:t>
             </a:fld>
             <a:endParaRPr lang="en-US"/>
           </a:p>
@@ -4884,7 +4860,7 @@
           <a:p>
             <a:fld id="{D7E3ECEC-7E7B-4FB9-BAE8-5C10F12795EA}" type="datetimeFigureOut">
               <a:rPr lang="en-US" smtClean="0"/>
-              <a:t>6/19/2026</a:t>
+              <a:t>6/26/2026</a:t>
             </a:fld>
             <a:endParaRPr lang="en-US"/>
           </a:p>
@@ -5128,7 +5104,7 @@
           <a:p>
             <a:fld id="{D7E3ECEC-7E7B-4FB9-BAE8-5C10F12795EA}" type="datetimeFigureOut">
               <a:rPr lang="en-US" smtClean="0"/>
-              <a:t>6/19/2026</a:t>
+              <a:t>6/26/2026</a:t>
             </a:fld>
             <a:endParaRPr lang="en-US"/>
           </a:p>
@@ -5362,7 +5338,7 @@
           <a:p>
             <a:fld id="{D7E3ECEC-7E7B-4FB9-BAE8-5C10F12795EA}" type="datetimeFigureOut">
               <a:rPr lang="en-US" smtClean="0"/>
-              <a:t>6/19/2026</a:t>
+              <a:t>6/26/2026</a:t>
             </a:fld>
             <a:endParaRPr lang="en-US"/>
           </a:p>
@@ -5596,7 +5572,7 @@
           <a:p>
             <a:fld id="{D7E3ECEC-7E7B-4FB9-BAE8-5C10F12795EA}" type="datetimeFigureOut">
               <a:rPr lang="en-US" smtClean="0"/>
-              <a:t>6/19/2026</a:t>
+              <a:t>6/26/2026</a:t>
             </a:fld>
             <a:endParaRPr lang="en-US"/>
           </a:p>
@@ -5830,7 +5806,7 @@
           <a:p>
             <a:fld id="{D7E3ECEC-7E7B-4FB9-BAE8-5C10F12795EA}" type="datetimeFigureOut">
               <a:rPr lang="en-US" smtClean="0"/>
-              <a:t>6/19/2026</a:t>
+              <a:t>6/26/2026</a:t>
             </a:fld>
             <a:endParaRPr lang="en-US"/>
           </a:p>
@@ -6064,7 +6040,7 @@
           <a:p>
             <a:fld id="{D7E3ECEC-7E7B-4FB9-BAE8-5C10F12795EA}" type="datetimeFigureOut">
               <a:rPr lang="en-US" smtClean="0"/>
-              <a:t>6/19/2026</a:t>
+              <a:t>6/26/2026</a:t>
             </a:fld>
             <a:endParaRPr lang="en-US"/>
           </a:p>
@@ -6388,7 +6364,7 @@
           <a:p>
             <a:fld id="{D7E3ECEC-7E7B-4FB9-BAE8-5C10F12795EA}" type="datetimeFigureOut">
               <a:rPr lang="en-US" smtClean="0"/>
-              <a:t>6/19/2026</a:t>
+              <a:t>6/26/2026</a:t>
             </a:fld>
             <a:endParaRPr lang="en-US"/>
           </a:p>
@@ -6617,7 +6593,7 @@
           <a:p>
             <a:fld id="{D7E3ECEC-7E7B-4FB9-BAE8-5C10F12795EA}" type="datetimeFigureOut">
               <a:rPr lang="en-US" smtClean="0"/>
-              <a:t>6/19/2026</a:t>
+              <a:t>6/26/2026</a:t>
             </a:fld>
             <a:endParaRPr lang="en-US"/>
           </a:p>
@@ -6953,7 +6929,7 @@
           <a:p>
             <a:fld id="{D7E3ECEC-7E7B-4FB9-BAE8-5C10F12795EA}" type="datetimeFigureOut">
               <a:rPr lang="en-US" smtClean="0"/>
-              <a:t>6/19/2026</a:t>
+              <a:t>6/26/2026</a:t>
             </a:fld>
             <a:endParaRPr lang="en-US"/>
           </a:p>
@@ -7286,7 +7262,7 @@
           <a:p>
             <a:fld id="{D7E3ECEC-7E7B-4FB9-BAE8-5C10F12795EA}" type="datetimeFigureOut">
               <a:rPr lang="en-US" smtClean="0"/>
-              <a:t>6/19/2026</a:t>
+              <a:t>6/26/2026</a:t>
             </a:fld>
             <a:endParaRPr lang="en-US"/>
           </a:p>
@@ -7628,7 +7604,7 @@
           <a:p>
             <a:fld id="{D7E3ECEC-7E7B-4FB9-BAE8-5C10F12795EA}" type="datetimeFigureOut">
               <a:rPr lang="en-US" smtClean="0"/>
-              <a:t>6/19/2026</a:t>
+              <a:t>6/26/2026</a:t>
             </a:fld>
             <a:endParaRPr lang="en-US"/>
           </a:p>
@@ -7966,7 +7942,7 @@
           <a:p>
             <a:fld id="{D7E3ECEC-7E7B-4FB9-BAE8-5C10F12795EA}" type="datetimeFigureOut">
               <a:rPr lang="en-US" smtClean="0"/>
-              <a:t>6/19/2026</a:t>
+              <a:t>6/26/2026</a:t>
             </a:fld>
             <a:endParaRPr lang="en-US"/>
           </a:p>
@@ -8281,7 +8257,7 @@
           <a:p>
             <a:fld id="{D7E3ECEC-7E7B-4FB9-BAE8-5C10F12795EA}" type="datetimeFigureOut">
               <a:rPr lang="en-US" smtClean="0"/>
-              <a:t>6/19/2026</a:t>
+              <a:t>6/26/2026</a:t>
             </a:fld>
             <a:endParaRPr lang="en-US"/>
           </a:p>
@@ -8596,7 +8572,7 @@
           <a:p>
             <a:fld id="{D7E3ECEC-7E7B-4FB9-BAE8-5C10F12795EA}" type="datetimeFigureOut">
               <a:rPr lang="en-US" smtClean="0"/>
-              <a:t>6/19/2026</a:t>
+              <a:t>6/26/2026</a:t>
             </a:fld>
             <a:endParaRPr lang="en-US"/>
           </a:p>
@@ -8920,7 +8896,7 @@
           <a:p>
             <a:fld id="{D7E3ECEC-7E7B-4FB9-BAE8-5C10F12795EA}" type="datetimeFigureOut">
               <a:rPr lang="en-US" smtClean="0"/>
-              <a:t>6/19/2026</a:t>
+              <a:t>6/26/2026</a:t>
             </a:fld>
             <a:endParaRPr lang="en-US"/>
           </a:p>
@@ -9262,7 +9238,7 @@
           <a:p>
             <a:fld id="{D7E3ECEC-7E7B-4FB9-BAE8-5C10F12795EA}" type="datetimeFigureOut">
               <a:rPr lang="en-US" smtClean="0"/>
-              <a:t>6/19/2026</a:t>
+              <a:t>6/26/2026</a:t>
             </a:fld>
             <a:endParaRPr lang="en-US"/>
           </a:p>
@@ -9524,7 +9500,7 @@
           <a:p>
             <a:fld id="{D7E3ECEC-7E7B-4FB9-BAE8-5C10F12795EA}" type="datetimeFigureOut">
               <a:rPr lang="en-US" smtClean="0"/>
-              <a:t>6/19/2026</a:t>
+              <a:t>6/26/2026</a:t>
             </a:fld>
             <a:endParaRPr lang="en-US"/>
           </a:p>
@@ -9985,7 +9961,7 @@
           <a:p>
             <a:fld id="{D7E3ECEC-7E7B-4FB9-BAE8-5C10F12795EA}" type="datetimeFigureOut">
               <a:rPr lang="en-US" smtClean="0"/>
-              <a:t>6/19/2026</a:t>
+              <a:t>6/26/2026</a:t>
             </a:fld>
             <a:endParaRPr lang="en-US"/>
           </a:p>
@@ -10324,7 +10300,7 @@
           <a:p>
             <a:fld id="{D7E3ECEC-7E7B-4FB9-BAE8-5C10F12795EA}" type="datetimeFigureOut">
               <a:rPr lang="en-US" smtClean="0"/>
-              <a:t>6/19/2026</a:t>
+              <a:t>6/26/2026</a:t>
             </a:fld>
             <a:endParaRPr lang="en-US"/>
           </a:p>
@@ -10650,7 +10626,7 @@
           <a:p>
             <a:fld id="{D7E3ECEC-7E7B-4FB9-BAE8-5C10F12795EA}" type="datetimeFigureOut">
               <a:rPr lang="en-US" smtClean="0"/>
-              <a:t>6/19/2026</a:t>
+              <a:t>6/26/2026</a:t>
             </a:fld>
             <a:endParaRPr lang="en-US"/>
           </a:p>
@@ -10837,7 +10813,7 @@
           <a:p>
             <a:fld id="{D7E3ECEC-7E7B-4FB9-BAE8-5C10F12795EA}" type="datetimeFigureOut">
               <a:rPr lang="en-US" smtClean="0"/>
-              <a:t>6/19/2026</a:t>
+              <a:t>6/26/2026</a:t>
             </a:fld>
             <a:endParaRPr lang="en-US"/>
           </a:p>
@@ -11366,7 +11342,7 @@
           <a:p>
             <a:fld id="{D7E3ECEC-7E7B-4FB9-BAE8-5C10F12795EA}" type="datetimeFigureOut">
               <a:rPr lang="en-US" smtClean="0"/>
-              <a:t>6/19/2026</a:t>
+              <a:t>6/26/2026</a:t>
             </a:fld>
             <a:endParaRPr lang="en-US"/>
           </a:p>
@@ -11691,7 +11667,7 @@
           <a:p>
             <a:fld id="{D7E3ECEC-7E7B-4FB9-BAE8-5C10F12795EA}" type="datetimeFigureOut">
               <a:rPr lang="en-US" smtClean="0"/>
-              <a:t>6/19/2026</a:t>
+              <a:t>6/26/2026</a:t>
             </a:fld>
             <a:endParaRPr lang="en-US"/>
           </a:p>
@@ -12021,7 +11997,7 @@
           <a:p>
             <a:fld id="{D7E3ECEC-7E7B-4FB9-BAE8-5C10F12795EA}" type="datetimeFigureOut">
               <a:rPr lang="en-US" smtClean="0"/>
-              <a:t>6/19/2026</a:t>
+              <a:t>6/26/2026</a:t>
             </a:fld>
             <a:endParaRPr lang="en-US"/>
           </a:p>
@@ -12357,7 +12333,7 @@
           <a:p>
             <a:fld id="{D7E3ECEC-7E7B-4FB9-BAE8-5C10F12795EA}" type="datetimeFigureOut">
               <a:rPr lang="en-US" smtClean="0"/>
-              <a:t>6/19/2026</a:t>
+              <a:t>6/26/2026</a:t>
             </a:fld>
             <a:endParaRPr lang="en-US"/>
           </a:p>
@@ -12657,7 +12633,7 @@
           <a:p>
             <a:fld id="{D7E3ECEC-7E7B-4FB9-BAE8-5C10F12795EA}" type="datetimeFigureOut">
               <a:rPr lang="en-US" smtClean="0"/>
-              <a:t>6/19/2026</a:t>
+              <a:t>6/26/2026</a:t>
             </a:fld>
             <a:endParaRPr lang="en-US"/>
           </a:p>
@@ -13039,7 +13015,7 @@
           <a:p>
             <a:fld id="{D7E3ECEC-7E7B-4FB9-BAE8-5C10F12795EA}" type="datetimeFigureOut">
               <a:rPr lang="en-US" smtClean="0"/>
-              <a:t>6/19/2026</a:t>
+              <a:t>6/26/2026</a:t>
             </a:fld>
             <a:endParaRPr lang="en-US"/>
           </a:p>
@@ -13502,7 +13478,7 @@
           <a:p>
             <a:fld id="{D7E3ECEC-7E7B-4FB9-BAE8-5C10F12795EA}" type="datetimeFigureOut">
               <a:rPr lang="en-US" smtClean="0"/>
-              <a:t>6/19/2026</a:t>
+              <a:t>6/26/2026</a:t>
             </a:fld>
             <a:endParaRPr lang="en-US"/>
           </a:p>
@@ -13843,7 +13819,7 @@
           <a:p>
             <a:fld id="{D7E3ECEC-7E7B-4FB9-BAE8-5C10F12795EA}" type="datetimeFigureOut">
               <a:rPr lang="en-US" smtClean="0"/>
-              <a:t>6/19/2026</a:t>
+              <a:t>6/26/2026</a:t>
             </a:fld>
             <a:endParaRPr lang="en-US"/>
           </a:p>
@@ -14213,7 +14189,7 @@
           <a:p>
             <a:fld id="{D7E3ECEC-7E7B-4FB9-BAE8-5C10F12795EA}" type="datetimeFigureOut">
               <a:rPr lang="en-US" smtClean="0"/>
-              <a:t>6/19/2026</a:t>
+              <a:t>6/26/2026</a:t>
             </a:fld>
             <a:endParaRPr lang="en-US"/>
           </a:p>
@@ -14552,7 +14528,7 @@
           <a:p>
             <a:fld id="{D7E3ECEC-7E7B-4FB9-BAE8-5C10F12795EA}" type="datetimeFigureOut">
               <a:rPr lang="en-US" smtClean="0"/>
-              <a:t>6/19/2026</a:t>
+              <a:t>6/26/2026</a:t>
             </a:fld>
             <a:endParaRPr lang="en-US"/>
           </a:p>
@@ -14843,7 +14819,7 @@
           <a:p>
             <a:fld id="{D7E3ECEC-7E7B-4FB9-BAE8-5C10F12795EA}" type="datetimeFigureOut">
               <a:rPr lang="en-US" smtClean="0"/>
-              <a:t>6/19/2026</a:t>
+              <a:t>6/26/2026</a:t>
             </a:fld>
             <a:endParaRPr lang="en-US"/>
           </a:p>
@@ -15220,7 +15196,7 @@
           <a:p>
             <a:fld id="{D7E3ECEC-7E7B-4FB9-BAE8-5C10F12795EA}" type="datetimeFigureOut">
               <a:rPr lang="en-US" smtClean="0"/>
-              <a:t>6/19/2026</a:t>
+              <a:t>6/26/2026</a:t>
             </a:fld>
             <a:endParaRPr lang="en-US"/>
           </a:p>
@@ -15620,7 +15596,7 @@
           <a:p>
             <a:fld id="{D7E3ECEC-7E7B-4FB9-BAE8-5C10F12795EA}" type="datetimeFigureOut">
               <a:rPr lang="en-US" smtClean="0"/>
-              <a:t>6/19/2026</a:t>
+              <a:t>6/26/2026</a:t>
             </a:fld>
             <a:endParaRPr lang="en-US"/>
           </a:p>
@@ -15905,7 +15881,7 @@
           <a:p>
             <a:fld id="{D7E3ECEC-7E7B-4FB9-BAE8-5C10F12795EA}" type="datetimeFigureOut">
               <a:rPr lang="en-US" smtClean="0"/>
-              <a:t>6/19/2026</a:t>
+              <a:t>6/26/2026</a:t>
             </a:fld>
             <a:endParaRPr lang="en-US"/>
           </a:p>
@@ -16129,7 +16105,7 @@
           <a:p>
             <a:fld id="{D7E3ECEC-7E7B-4FB9-BAE8-5C10F12795EA}" type="datetimeFigureOut">
               <a:rPr lang="en-US" smtClean="0"/>
-              <a:t>6/19/2026</a:t>
+              <a:t>6/26/2026</a:t>
             </a:fld>
             <a:endParaRPr lang="en-US"/>
           </a:p>
@@ -16343,7 +16319,7 @@
           <a:p>
             <a:fld id="{D7E3ECEC-7E7B-4FB9-BAE8-5C10F12795EA}" type="datetimeFigureOut">
               <a:rPr lang="en-US" smtClean="0"/>
-              <a:t>6/19/2026</a:t>
+              <a:t>6/26/2026</a:t>
             </a:fld>
             <a:endParaRPr lang="en-US"/>
           </a:p>
@@ -16712,7 +16688,7 @@
           <a:p>
             <a:fld id="{D7E3ECEC-7E7B-4FB9-BAE8-5C10F12795EA}" type="datetimeFigureOut">
               <a:rPr lang="en-US" smtClean="0"/>
-              <a:t>6/19/2026</a:t>
+              <a:t>6/26/2026</a:t>
             </a:fld>
             <a:endParaRPr lang="en-US"/>
           </a:p>
@@ -17054,7 +17030,7 @@
           <a:p>
             <a:fld id="{D7E3ECEC-7E7B-4FB9-BAE8-5C10F12795EA}" type="datetimeFigureOut">
               <a:rPr lang="en-US" smtClean="0"/>
-              <a:t>6/19/2026</a:t>
+              <a:t>6/26/2026</a:t>
             </a:fld>
             <a:endParaRPr lang="en-US"/>
           </a:p>
@@ -17417,7 +17393,7 @@
           <a:p>
             <a:fld id="{D7E3ECEC-7E7B-4FB9-BAE8-5C10F12795EA}" type="datetimeFigureOut">
               <a:rPr lang="en-US" smtClean="0"/>
-              <a:t>6/19/2026</a:t>
+              <a:t>6/26/2026</a:t>
             </a:fld>
             <a:endParaRPr lang="en-US"/>
           </a:p>
@@ -17690,7 +17666,7 @@
           <a:p>
             <a:fld id="{D7E3ECEC-7E7B-4FB9-BAE8-5C10F12795EA}" type="datetimeFigureOut">
               <a:rPr lang="en-US" smtClean="0"/>
-              <a:t>6/19/2026</a:t>
+              <a:t>6/26/2026</a:t>
             </a:fld>
             <a:endParaRPr lang="en-US"/>
           </a:p>
@@ -18035,7 +18011,7 @@
           <a:p>
             <a:fld id="{D7E3ECEC-7E7B-4FB9-BAE8-5C10F12795EA}" type="datetimeFigureOut">
               <a:rPr lang="en-US" smtClean="0"/>
-              <a:t>6/19/2026</a:t>
+              <a:t>6/26/2026</a:t>
             </a:fld>
             <a:endParaRPr lang="en-US"/>
           </a:p>
@@ -18489,7 +18465,7 @@
           <a:p>
             <a:fld id="{D7E3ECEC-7E7B-4FB9-BAE8-5C10F12795EA}" type="datetimeFigureOut">
               <a:rPr lang="en-US" smtClean="0"/>
-              <a:t>6/19/2026</a:t>
+              <a:t>6/26/2026</a:t>
             </a:fld>
             <a:endParaRPr lang="en-US"/>
           </a:p>
@@ -18636,7 +18612,7 @@
           <a:p>
             <a:fld id="{D7E3ECEC-7E7B-4FB9-BAE8-5C10F12795EA}" type="datetimeFigureOut">
               <a:rPr lang="en-US" smtClean="0"/>
-              <a:t>6/19/2026</a:t>
+              <a:t>6/26/2026</a:t>
             </a:fld>
             <a:endParaRPr lang="en-US"/>
           </a:p>
@@ -18749,7 +18725,7 @@
           <a:p>
             <a:fld id="{D7E3ECEC-7E7B-4FB9-BAE8-5C10F12795EA}" type="datetimeFigureOut">
               <a:rPr lang="en-US" smtClean="0"/>
-              <a:t>6/19/2026</a:t>
+              <a:t>6/26/2026</a:t>
             </a:fld>
             <a:endParaRPr lang="en-US"/>
           </a:p>
@@ -19056,7 +19032,7 @@
           <a:p>
             <a:fld id="{D7E3ECEC-7E7B-4FB9-BAE8-5C10F12795EA}" type="datetimeFigureOut">
               <a:rPr lang="en-US" smtClean="0"/>
-              <a:t>6/19/2026</a:t>
+              <a:t>6/26/2026</a:t>
             </a:fld>
             <a:endParaRPr lang="en-US"/>
           </a:p>
@@ -19355,7 +19331,7 @@
           <a:p>
             <a:fld id="{D7E3ECEC-7E7B-4FB9-BAE8-5C10F12795EA}" type="datetimeFigureOut">
               <a:rPr lang="en-US" smtClean="0"/>
-              <a:t>6/19/2026</a:t>
+              <a:t>6/26/2026</a:t>
             </a:fld>
             <a:endParaRPr lang="en-US"/>
           </a:p>
@@ -19747,7 +19723,7 @@
           <a:p>
             <a:fld id="{D7E3ECEC-7E7B-4FB9-BAE8-5C10F12795EA}" type="datetimeFigureOut">
               <a:rPr lang="en-US" smtClean="0"/>
-              <a:t>6/19/2026</a:t>
+              <a:t>6/26/2026</a:t>
             </a:fld>
             <a:endParaRPr lang="en-US"/>
           </a:p>
@@ -20134,7 +20110,7 @@
           <a:p>
             <a:fld id="{D7E3ECEC-7E7B-4FB9-BAE8-5C10F12795EA}" type="datetimeFigureOut">
               <a:rPr lang="en-US" smtClean="0"/>
-              <a:t>6/19/2026</a:t>
+              <a:t>6/26/2026</a:t>
             </a:fld>
             <a:endParaRPr lang="en-US"/>
           </a:p>
@@ -20365,7 +20341,7 @@
           <a:p>
             <a:fld id="{D7E3ECEC-7E7B-4FB9-BAE8-5C10F12795EA}" type="datetimeFigureOut">
               <a:rPr lang="en-US" smtClean="0"/>
-              <a:t>6/19/2026</a:t>
+              <a:t>6/26/2026</a:t>
             </a:fld>
             <a:endParaRPr lang="en-US"/>
           </a:p>
@@ -20647,7 +20623,7 @@
           <a:p>
             <a:fld id="{D7E3ECEC-7E7B-4FB9-BAE8-5C10F12795EA}" type="datetimeFigureOut">
               <a:rPr lang="en-US" smtClean="0"/>
-              <a:t>6/19/2026</a:t>
+              <a:t>6/26/2026</a:t>
             </a:fld>
             <a:endParaRPr lang="en-US"/>
           </a:p>
@@ -20902,7 +20878,7 @@
           <a:p>
             <a:fld id="{D7E3ECEC-7E7B-4FB9-BAE8-5C10F12795EA}" type="datetimeFigureOut">
               <a:rPr lang="en-US" smtClean="0"/>
-              <a:t>6/19/2026</a:t>
+              <a:t>6/26/2026</a:t>
             </a:fld>
             <a:endParaRPr lang="en-US"/>
           </a:p>
@@ -21174,7 +21150,7 @@
           <a:p>
             <a:fld id="{D7E3ECEC-7E7B-4FB9-BAE8-5C10F12795EA}" type="datetimeFigureOut">
               <a:rPr lang="en-US" smtClean="0"/>
-              <a:t>6/19/2026</a:t>
+              <a:t>6/26/2026</a:t>
             </a:fld>
             <a:endParaRPr lang="en-US"/>
           </a:p>
@@ -21444,7 +21420,7 @@
           <a:p>
             <a:fld id="{D7E3ECEC-7E7B-4FB9-BAE8-5C10F12795EA}" type="datetimeFigureOut">
               <a:rPr lang="en-US" smtClean="0"/>
-              <a:t>6/19/2026</a:t>
+              <a:t>6/26/2026</a:t>
             </a:fld>
             <a:endParaRPr lang="en-US"/>
           </a:p>
@@ -22073,6 +22049,218 @@
         <p:cNvPr id="1" name="">
           <a:extLst>
             <a:ext uri="{FF2B5EF4-FFF2-40B4-BE49-F238E27FC236}">
+              <a16:creationId xmlns:a16="http://schemas.microsoft.com/office/drawing/2014/main" id="{E7773EAD-3AFA-9B70-8C05-AC647EF05AA7}"/>
+            </a:ext>
+          </a:extLst>
+        </p:cNvPr>
+        <p:cNvGrpSpPr/>
+        <p:nvPr/>
+      </p:nvGrpSpPr>
+      <p:grpSpPr>
+        <a:xfrm>
+          <a:off x="0" y="0"/>
+          <a:ext cx="0" cy="0"/>
+          <a:chOff x="0" y="0"/>
+          <a:chExt cx="0" cy="0"/>
+        </a:xfrm>
+      </p:grpSpPr>
+      <p:sp>
+        <p:nvSpPr>
+          <p:cNvPr id="5" name="TextBox 4">
+            <a:extLst>
+              <a:ext uri="{FF2B5EF4-FFF2-40B4-BE49-F238E27FC236}">
+                <a16:creationId xmlns:a16="http://schemas.microsoft.com/office/drawing/2014/main" id="{9B8B78FF-72F1-DBB8-91DD-E133A00152F9}"/>
+              </a:ext>
+            </a:extLst>
+          </p:cNvPr>
+          <p:cNvSpPr txBox="1"/>
+          <p:nvPr/>
+        </p:nvSpPr>
+        <p:spPr>
+          <a:xfrm>
+            <a:off x="1062037" y="228600"/>
+            <a:ext cx="10067926" cy="1600438"/>
+          </a:xfrm>
+          <a:prstGeom prst="rect">
+            <a:avLst/>
+          </a:prstGeom>
+          <a:noFill/>
+        </p:spPr>
+        <p:txBody>
+          <a:bodyPr wrap="square" rtlCol="0">
+            <a:spAutoFit/>
+          </a:bodyPr>
+          <a:lstStyle/>
+          <a:p>
+            <a:pPr algn="ctr"/>
+            <a:r>
+              <a:rPr lang="en-US" sz="4000" dirty="0"/>
+              <a:t>An Attack on Intelligent Behavior</a:t>
+            </a:r>
+          </a:p>
+          <a:p>
+            <a:pPr algn="ctr"/>
+            <a:r>
+              <a:rPr lang="en-US" sz="4000" dirty="0"/>
+              <a:t>The Chinese Room</a:t>
+            </a:r>
+            <a:br>
+              <a:rPr lang="en-US" dirty="0"/>
+            </a:br>
+            <a:endParaRPr lang="en-US" dirty="0"/>
+          </a:p>
+        </p:txBody>
+      </p:sp>
+      <p:pic>
+        <p:nvPicPr>
+          <p:cNvPr id="5122" name="Picture 2" descr="A Chinese Speaker's take on the Chinese Room | by Alan Tan | TDS Archive |  Medium">
+            <a:extLst>
+              <a:ext uri="{FF2B5EF4-FFF2-40B4-BE49-F238E27FC236}">
+                <a16:creationId xmlns:a16="http://schemas.microsoft.com/office/drawing/2014/main" id="{74B692B4-0DC0-7407-5E4F-663A1BC06792}"/>
+              </a:ext>
+            </a:extLst>
+          </p:cNvPr>
+          <p:cNvPicPr>
+            <a:picLocks noChangeAspect="1" noChangeArrowheads="1"/>
+          </p:cNvPicPr>
+          <p:nvPr/>
+        </p:nvPicPr>
+        <p:blipFill>
+          <a:blip r:embed="rId3">
+            <a:extLst>
+              <a:ext uri="{28A0092B-C50C-407E-A947-70E740481C1C}">
+                <a14:useLocalDpi xmlns:a14="http://schemas.microsoft.com/office/drawing/2010/main" val="0"/>
+              </a:ext>
+            </a:extLst>
+          </a:blip>
+          <a:srcRect/>
+          <a:stretch>
+            <a:fillRect/>
+          </a:stretch>
+        </p:blipFill>
+        <p:spPr bwMode="auto">
+          <a:xfrm>
+            <a:off x="685800" y="1665397"/>
+            <a:ext cx="6096000" cy="3781425"/>
+          </a:xfrm>
+          <a:prstGeom prst="rect">
+            <a:avLst/>
+          </a:prstGeom>
+          <a:noFill/>
+          <a:extLst>
+            <a:ext uri="{909E8E84-426E-40DD-AFC4-6F175D3DCCD1}">
+              <a14:hiddenFill xmlns:a14="http://schemas.microsoft.com/office/drawing/2010/main">
+                <a:solidFill>
+                  <a:srgbClr val="FFFFFF"/>
+                </a:solidFill>
+              </a14:hiddenFill>
+            </a:ext>
+          </a:extLst>
+        </p:spPr>
+      </p:pic>
+      <p:pic>
+        <p:nvPicPr>
+          <p:cNvPr id="5124" name="Picture 4">
+            <a:extLst>
+              <a:ext uri="{FF2B5EF4-FFF2-40B4-BE49-F238E27FC236}">
+                <a16:creationId xmlns:a16="http://schemas.microsoft.com/office/drawing/2014/main" id="{80B13551-E15E-DF10-B70F-494BBDCD6160}"/>
+              </a:ext>
+            </a:extLst>
+          </p:cNvPr>
+          <p:cNvPicPr>
+            <a:picLocks noChangeAspect="1" noChangeArrowheads="1"/>
+          </p:cNvPicPr>
+          <p:nvPr/>
+        </p:nvPicPr>
+        <p:blipFill>
+          <a:blip r:embed="rId4">
+            <a:extLst>
+              <a:ext uri="{28A0092B-C50C-407E-A947-70E740481C1C}">
+                <a14:useLocalDpi xmlns:a14="http://schemas.microsoft.com/office/drawing/2010/main" val="0"/>
+              </a:ext>
+            </a:extLst>
+          </a:blip>
+          <a:srcRect/>
+          <a:stretch>
+            <a:fillRect/>
+          </a:stretch>
+        </p:blipFill>
+        <p:spPr bwMode="auto">
+          <a:xfrm>
+            <a:off x="8712618" y="1798747"/>
+            <a:ext cx="2381250" cy="3571875"/>
+          </a:xfrm>
+          <a:prstGeom prst="rect">
+            <a:avLst/>
+          </a:prstGeom>
+          <a:noFill/>
+          <a:extLst>
+            <a:ext uri="{909E8E84-426E-40DD-AFC4-6F175D3DCCD1}">
+              <a14:hiddenFill xmlns:a14="http://schemas.microsoft.com/office/drawing/2010/main">
+                <a:solidFill>
+                  <a:srgbClr val="FFFFFF"/>
+                </a:solidFill>
+              </a14:hiddenFill>
+            </a:ext>
+          </a:extLst>
+        </p:spPr>
+      </p:pic>
+      <p:sp>
+        <p:nvSpPr>
+          <p:cNvPr id="7" name="TextBox 6">
+            <a:extLst>
+              <a:ext uri="{FF2B5EF4-FFF2-40B4-BE49-F238E27FC236}">
+                <a16:creationId xmlns:a16="http://schemas.microsoft.com/office/drawing/2014/main" id="{DE3DFAF6-ED0D-36CD-2B7C-2D37A81BFE39}"/>
+              </a:ext>
+            </a:extLst>
+          </p:cNvPr>
+          <p:cNvSpPr txBox="1"/>
+          <p:nvPr/>
+        </p:nvSpPr>
+        <p:spPr>
+          <a:xfrm>
+            <a:off x="9195320" y="5370622"/>
+            <a:ext cx="1472680" cy="369332"/>
+          </a:xfrm>
+          <a:prstGeom prst="rect">
+            <a:avLst/>
+          </a:prstGeom>
+          <a:noFill/>
+        </p:spPr>
+        <p:txBody>
+          <a:bodyPr wrap="square">
+            <a:spAutoFit/>
+          </a:bodyPr>
+          <a:lstStyle/>
+          <a:p>
+            <a:r>
+              <a:rPr lang="en-US" dirty="0"/>
+              <a:t>John Searle</a:t>
+            </a:r>
+          </a:p>
+        </p:txBody>
+      </p:sp>
+    </p:spTree>
+    <p:extLst>
+      <p:ext uri="{BB962C8B-B14F-4D97-AF65-F5344CB8AC3E}">
+        <p14:creationId xmlns:p14="http://schemas.microsoft.com/office/powerpoint/2010/main" val="3664725273"/>
+      </p:ext>
+    </p:extLst>
+  </p:cSld>
+  <p:clrMapOvr>
+    <a:masterClrMapping/>
+  </p:clrMapOvr>
+</p:sld>
+</file>
+
+<file path=ppt/slides/slide11.xml><?xml version="1.0" encoding="utf-8"?>
+<p:sld xmlns:a="http://schemas.openxmlformats.org/drawingml/2006/main" xmlns:r="http://schemas.openxmlformats.org/officeDocument/2006/relationships" xmlns:p="http://schemas.openxmlformats.org/presentationml/2006/main">
+  <p:cSld>
+    <p:spTree>
+      <p:nvGrpSpPr>
+        <p:cNvPr id="1" name="">
+          <a:extLst>
+            <a:ext uri="{FF2B5EF4-FFF2-40B4-BE49-F238E27FC236}">
               <a16:creationId xmlns:a16="http://schemas.microsoft.com/office/drawing/2014/main" id="{025A325B-5D16-7564-561E-004A248A9A09}"/>
             </a:ext>
           </a:extLst>
@@ -22268,66 +22456,6 @@
     <p:extLst>
       <p:ext uri="{BB962C8B-B14F-4D97-AF65-F5344CB8AC3E}">
         <p14:creationId xmlns:p14="http://schemas.microsoft.com/office/powerpoint/2010/main" val="4145057731"/>
-      </p:ext>
-    </p:extLst>
-  </p:cSld>
-  <p:clrMapOvr>
-    <a:masterClrMapping/>
-  </p:clrMapOvr>
-</p:sld>
-</file>
-
-<file path=ppt/slides/slide11.xml><?xml version="1.0" encoding="utf-8"?>
-<p:sld xmlns:a="http://schemas.openxmlformats.org/drawingml/2006/main" xmlns:r="http://schemas.openxmlformats.org/officeDocument/2006/relationships" xmlns:p="http://schemas.openxmlformats.org/presentationml/2006/main">
-  <p:cSld>
-    <p:spTree>
-      <p:nvGrpSpPr>
-        <p:cNvPr id="1" name=""/>
-        <p:cNvGrpSpPr/>
-        <p:nvPr/>
-      </p:nvGrpSpPr>
-      <p:grpSpPr>
-        <a:xfrm>
-          <a:off x="0" y="0"/>
-          <a:ext cx="0" cy="0"/>
-          <a:chOff x="0" y="0"/>
-          <a:chExt cx="0" cy="0"/>
-        </a:xfrm>
-      </p:grpSpPr>
-      <p:pic>
-        <p:nvPicPr>
-          <p:cNvPr id="5" name="Picture 4">
-            <a:extLst>
-              <a:ext uri="{FF2B5EF4-FFF2-40B4-BE49-F238E27FC236}">
-                <a16:creationId xmlns:a16="http://schemas.microsoft.com/office/drawing/2014/main" id="{BD35D1C2-AC40-0F0F-DF06-98EE3EDAD5BE}"/>
-              </a:ext>
-            </a:extLst>
-          </p:cNvPr>
-          <p:cNvPicPr>
-            <a:picLocks noChangeAspect="1"/>
-          </p:cNvPicPr>
-          <p:nvPr/>
-        </p:nvPicPr>
-        <p:blipFill>
-          <a:blip r:embed="rId3"/>
-          <a:stretch>
-            <a:fillRect/>
-          </a:stretch>
-        </p:blipFill>
-        <p:spPr>
-          <a:xfrm>
-            <a:off x="352552" y="228599"/>
-            <a:ext cx="11458447" cy="6384949"/>
-          </a:xfrm>
-          <a:prstGeom prst="rect">
-            <a:avLst/>
-          </a:prstGeom>
-        </p:spPr>
-      </p:pic>
-    </p:spTree>
-    <p:extLst>
-      <p:ext uri="{BB962C8B-B14F-4D97-AF65-F5344CB8AC3E}">
-        <p14:creationId xmlns:p14="http://schemas.microsoft.com/office/powerpoint/2010/main" val="3500708445"/>
       </p:ext>
     </p:extLst>
   </p:cSld>
@@ -22359,7 +22487,7 @@
           <p:cNvPr id="5" name="Picture 4">
             <a:extLst>
               <a:ext uri="{FF2B5EF4-FFF2-40B4-BE49-F238E27FC236}">
-                <a16:creationId xmlns:a16="http://schemas.microsoft.com/office/drawing/2014/main" id="{F58401CF-4AD6-ED20-3429-3C6C69605BF9}"/>
+                <a16:creationId xmlns:a16="http://schemas.microsoft.com/office/drawing/2014/main" id="{BD35D1C2-AC40-0F0F-DF06-98EE3EDAD5BE}"/>
               </a:ext>
             </a:extLst>
           </p:cNvPr>
@@ -22376,53 +22504,18 @@
         </p:blipFill>
         <p:spPr>
           <a:xfrm>
-            <a:off x="2209800" y="91151"/>
-            <a:ext cx="9655377" cy="6675698"/>
+            <a:off x="352552" y="228599"/>
+            <a:ext cx="11458447" cy="6384949"/>
           </a:xfrm>
           <a:prstGeom prst="rect">
             <a:avLst/>
           </a:prstGeom>
         </p:spPr>
       </p:pic>
-      <p:sp>
-        <p:nvSpPr>
-          <p:cNvPr id="6" name="TextBox 5">
-            <a:extLst>
-              <a:ext uri="{FF2B5EF4-FFF2-40B4-BE49-F238E27FC236}">
-                <a16:creationId xmlns:a16="http://schemas.microsoft.com/office/drawing/2014/main" id="{05EDA79D-0453-262E-892A-E1F435C2FB20}"/>
-              </a:ext>
-            </a:extLst>
-          </p:cNvPr>
-          <p:cNvSpPr txBox="1"/>
-          <p:nvPr/>
-        </p:nvSpPr>
-        <p:spPr>
-          <a:xfrm>
-            <a:off x="533400" y="2967335"/>
-            <a:ext cx="1066800" cy="461665"/>
-          </a:xfrm>
-          <a:prstGeom prst="rect">
-            <a:avLst/>
-          </a:prstGeom>
-          <a:noFill/>
-        </p:spPr>
-        <p:txBody>
-          <a:bodyPr wrap="square" rtlCol="0">
-            <a:spAutoFit/>
-          </a:bodyPr>
-          <a:lstStyle/>
-          <a:p>
-            <a:r>
-              <a:rPr lang="en-US" sz="2400" dirty="0"/>
-              <a:t>2026</a:t>
-            </a:r>
-          </a:p>
-        </p:txBody>
-      </p:sp>
     </p:spTree>
     <p:extLst>
       <p:ext uri="{BB962C8B-B14F-4D97-AF65-F5344CB8AC3E}">
-        <p14:creationId xmlns:p14="http://schemas.microsoft.com/office/powerpoint/2010/main" val="2376163577"/>
+        <p14:creationId xmlns:p14="http://schemas.microsoft.com/office/powerpoint/2010/main" val="3500708445"/>
       </p:ext>
     </p:extLst>
   </p:cSld>
@@ -22451,10 +22544,10 @@
       </p:grpSpPr>
       <p:pic>
         <p:nvPicPr>
-          <p:cNvPr id="7" name="Picture 6">
-            <a:extLst>
-              <a:ext uri="{FF2B5EF4-FFF2-40B4-BE49-F238E27FC236}">
-                <a16:creationId xmlns:a16="http://schemas.microsoft.com/office/drawing/2014/main" id="{AA9E793C-F88B-E986-C191-718AB9E7DBEA}"/>
+          <p:cNvPr id="5" name="Picture 4">
+            <a:extLst>
+              <a:ext uri="{FF2B5EF4-FFF2-40B4-BE49-F238E27FC236}">
+                <a16:creationId xmlns:a16="http://schemas.microsoft.com/office/drawing/2014/main" id="{F58401CF-4AD6-ED20-3429-3C6C69605BF9}"/>
               </a:ext>
             </a:extLst>
           </p:cNvPr>
@@ -22471,8 +22564,8 @@
         </p:blipFill>
         <p:spPr>
           <a:xfrm>
-            <a:off x="547970" y="1213485"/>
-            <a:ext cx="11096059" cy="5263515"/>
+            <a:off x="2209800" y="91151"/>
+            <a:ext cx="9655377" cy="6675698"/>
           </a:xfrm>
           <a:prstGeom prst="rect">
             <a:avLst/>
@@ -22481,10 +22574,10 @@
       </p:pic>
       <p:sp>
         <p:nvSpPr>
-          <p:cNvPr id="9" name="TextBox 8">
-            <a:extLst>
-              <a:ext uri="{FF2B5EF4-FFF2-40B4-BE49-F238E27FC236}">
-                <a16:creationId xmlns:a16="http://schemas.microsoft.com/office/drawing/2014/main" id="{660F8B7C-CE5B-2277-10C6-FD4A18ABA4D9}"/>
+          <p:cNvPr id="6" name="TextBox 5">
+            <a:extLst>
+              <a:ext uri="{FF2B5EF4-FFF2-40B4-BE49-F238E27FC236}">
+                <a16:creationId xmlns:a16="http://schemas.microsoft.com/office/drawing/2014/main" id="{05EDA79D-0453-262E-892A-E1F435C2FB20}"/>
               </a:ext>
             </a:extLst>
           </p:cNvPr>
@@ -22493,8 +22586,8 @@
         </p:nvSpPr>
         <p:spPr>
           <a:xfrm>
-            <a:off x="3749090" y="228600"/>
-            <a:ext cx="4693818" cy="984885"/>
+            <a:off x="533400" y="2967335"/>
+            <a:ext cx="1066800" cy="461665"/>
           </a:xfrm>
           <a:prstGeom prst="rect">
             <a:avLst/>
@@ -22507,22 +22600,80 @@
           </a:bodyPr>
           <a:lstStyle/>
           <a:p>
-            <a:pPr algn="ctr"/>
-            <a:r>
-              <a:rPr lang="en-US" sz="4000" dirty="0"/>
-              <a:t>Future Modules</a:t>
-            </a:r>
-            <a:br>
-              <a:rPr lang="en-US" dirty="0"/>
-            </a:br>
-            <a:endParaRPr lang="en-US" dirty="0"/>
+            <a:r>
+              <a:rPr lang="en-US" sz="2400" dirty="0"/>
+              <a:t>2026</a:t>
+            </a:r>
           </a:p>
         </p:txBody>
       </p:sp>
     </p:spTree>
     <p:extLst>
       <p:ext uri="{BB962C8B-B14F-4D97-AF65-F5344CB8AC3E}">
-        <p14:creationId xmlns:p14="http://schemas.microsoft.com/office/powerpoint/2010/main" val="571981106"/>
+        <p14:creationId xmlns:p14="http://schemas.microsoft.com/office/powerpoint/2010/main" val="2376163577"/>
+      </p:ext>
+    </p:extLst>
+  </p:cSld>
+  <p:clrMapOvr>
+    <a:masterClrMapping/>
+  </p:clrMapOvr>
+</p:sld>
+</file>
+
+<file path=ppt/slides/slide14.xml><?xml version="1.0" encoding="utf-8"?>
+<p:sld xmlns:a="http://schemas.openxmlformats.org/drawingml/2006/main" xmlns:r="http://schemas.openxmlformats.org/officeDocument/2006/relationships" xmlns:p="http://schemas.openxmlformats.org/presentationml/2006/main">
+  <p:cSld>
+    <p:spTree>
+      <p:nvGrpSpPr>
+        <p:cNvPr id="1" name=""/>
+        <p:cNvGrpSpPr/>
+        <p:nvPr/>
+      </p:nvGrpSpPr>
+      <p:grpSpPr>
+        <a:xfrm>
+          <a:off x="0" y="0"/>
+          <a:ext cx="0" cy="0"/>
+          <a:chOff x="0" y="0"/>
+          <a:chExt cx="0" cy="0"/>
+        </a:xfrm>
+      </p:grpSpPr>
+      <p:sp>
+        <p:nvSpPr>
+          <p:cNvPr id="2" name="Title 1">
+            <a:extLst>
+              <a:ext uri="{FF2B5EF4-FFF2-40B4-BE49-F238E27FC236}">
+                <a16:creationId xmlns:a16="http://schemas.microsoft.com/office/drawing/2014/main" id="{E3FF5D4B-65DC-EC76-90AD-3C218033D3BC}"/>
+              </a:ext>
+            </a:extLst>
+          </p:cNvPr>
+          <p:cNvSpPr>
+            <a:spLocks noGrp="1"/>
+          </p:cNvSpPr>
+          <p:nvPr>
+            <p:ph type="title"/>
+          </p:nvPr>
+        </p:nvSpPr>
+        <p:spPr>
+          <a:xfrm>
+            <a:off x="4752300" y="2762250"/>
+            <a:ext cx="2687400" cy="1333500"/>
+          </a:xfrm>
+        </p:spPr>
+        <p:txBody>
+          <a:bodyPr/>
+          <a:lstStyle/>
+          <a:p>
+            <a:r>
+              <a:rPr lang="en-US" dirty="0"/>
+              <a:t>End</a:t>
+            </a:r>
+          </a:p>
+        </p:txBody>
+      </p:sp>
+    </p:spTree>
+    <p:extLst>
+      <p:ext uri="{BB962C8B-B14F-4D97-AF65-F5344CB8AC3E}">
+        <p14:creationId xmlns:p14="http://schemas.microsoft.com/office/powerpoint/2010/main" val="3830981560"/>
       </p:ext>
     </p:extLst>
   </p:cSld>
@@ -22551,164 +22702,10 @@
       </p:grpSpPr>
       <p:sp>
         <p:nvSpPr>
-          <p:cNvPr id="15" name="Title 1">
-            <a:extLst>
-              <a:ext uri="{FF2B5EF4-FFF2-40B4-BE49-F238E27FC236}">
-                <a16:creationId xmlns:a16="http://schemas.microsoft.com/office/drawing/2014/main" id="{C2047053-05A7-1928-D857-D87CA5F24DF6}"/>
-              </a:ext>
-            </a:extLst>
-          </p:cNvPr>
-          <p:cNvSpPr>
-            <a:spLocks noGrp="1"/>
-          </p:cNvSpPr>
-          <p:nvPr>
-            <p:ph type="ctrTitle"/>
-          </p:nvPr>
-        </p:nvSpPr>
-        <p:spPr>
-          <a:xfrm>
-            <a:off x="169606" y="1562100"/>
-            <a:ext cx="9296400" cy="4800600"/>
-          </a:xfrm>
-        </p:spPr>
-        <p:txBody>
-          <a:bodyPr>
-            <a:normAutofit fontScale="90000"/>
-          </a:bodyPr>
-          <a:lstStyle/>
-          <a:p>
-            <a:br>
-              <a:rPr lang="en-US" sz="1600" dirty="0"/>
-            </a:br>
-            <a:r>
-              <a:rPr lang="en-US" sz="1800" dirty="0"/>
-              <a:t>Q. w</a:t>
-            </a:r>
-            <a:r>
-              <a:rPr lang="en-US" sz="1800" cap="none" dirty="0"/>
-              <a:t>hat is artificial intelligence? </a:t>
-            </a:r>
-            <a:br>
-              <a:rPr lang="en-US" sz="1800" cap="none" dirty="0"/>
-            </a:br>
-            <a:br>
-              <a:rPr lang="en-US" sz="1800" cap="none" dirty="0"/>
-            </a:br>
-            <a:r>
-              <a:rPr lang="en-US" sz="1800" cap="none" dirty="0"/>
-              <a:t>A. It is the science and engineering of making intelligent machines, especially intelligent computer programs. It is related to the similar task of using computers to understand human intelligence, but AI does not have to confine itself to methods that are biologically observable. </a:t>
-            </a:r>
-            <a:br>
-              <a:rPr lang="en-US" sz="1800" cap="none" dirty="0"/>
-            </a:br>
-            <a:br>
-              <a:rPr lang="en-US" sz="1800" cap="none" dirty="0"/>
-            </a:br>
-            <a:r>
-              <a:rPr lang="en-US" sz="1800" cap="none" dirty="0"/>
-              <a:t>Q. What is intelligence? </a:t>
-            </a:r>
-            <a:br>
-              <a:rPr lang="en-US" sz="1800" cap="none" dirty="0"/>
-            </a:br>
-            <a:br>
-              <a:rPr lang="en-US" sz="1800" cap="none" dirty="0"/>
-            </a:br>
-            <a:r>
-              <a:rPr lang="en-US" sz="1800" cap="none" dirty="0"/>
-              <a:t>A. Intelligence is the computational part of the ability to achieve goals in the world. Varying kinds and degrees of intelligence occur in people, many animals and some machines. </a:t>
-            </a:r>
-            <a:br>
-              <a:rPr lang="en-US" sz="1800" cap="none" dirty="0"/>
-            </a:br>
-            <a:br>
-              <a:rPr lang="en-US" sz="1800" cap="none" dirty="0"/>
-            </a:br>
-            <a:r>
-              <a:rPr lang="en-US" sz="1800" cap="none" dirty="0"/>
-              <a:t>Q. Isn't there a solid definition of intelligence that doesn't depend on relating it to human intelligence? </a:t>
-            </a:r>
-            <a:br>
-              <a:rPr lang="en-US" sz="1800" cap="none" dirty="0"/>
-            </a:br>
-            <a:br>
-              <a:rPr lang="en-US" sz="1800" cap="none" dirty="0"/>
-            </a:br>
-            <a:r>
-              <a:rPr lang="en-US" sz="1800" cap="none" dirty="0"/>
-              <a:t>A. Not yet. The problem is that we cannot yet characterize in general what kinds of computational procedures we want to call intelligent. We understand some of the mechanisms of intelligence and not others. </a:t>
-            </a:r>
-            <a:br>
-              <a:rPr lang="en-US" sz="1600" cap="none" dirty="0"/>
-            </a:br>
-            <a:br>
-              <a:rPr lang="en-US" sz="1600" cap="none" dirty="0">
-                <a:solidFill>
-                  <a:schemeClr val="tx1"/>
-                </a:solidFill>
-              </a:rPr>
-            </a:br>
-            <a:r>
-              <a:rPr lang="en-US" sz="1600" i="1" cap="none" dirty="0">
-                <a:solidFill>
-                  <a:schemeClr val="tx1"/>
-                </a:solidFill>
-              </a:rPr>
-              <a:t>Reference: </a:t>
-            </a:r>
-            <a:r>
-              <a:rPr lang="en-US" sz="1600" cap="none" dirty="0">
-                <a:solidFill>
-                  <a:schemeClr val="tx1"/>
-                </a:solidFill>
-              </a:rPr>
-              <a:t>McCarthy, J. (2007, November 12). </a:t>
-            </a:r>
-            <a:r>
-              <a:rPr lang="en-US" sz="1600" i="1" cap="none" dirty="0">
-                <a:solidFill>
-                  <a:schemeClr val="tx1"/>
-                </a:solidFill>
-              </a:rPr>
-              <a:t>What is artificial intelligence? Basic questions</a:t>
-            </a:r>
-            <a:r>
-              <a:rPr lang="en-US" sz="1600" cap="none" dirty="0">
-                <a:solidFill>
-                  <a:schemeClr val="tx1"/>
-                </a:solidFill>
-              </a:rPr>
-              <a:t>. Formal Reasoning Group, Stanford University. </a:t>
-            </a:r>
-            <a:r>
-              <a:rPr lang="en-US" sz="1600" cap="none" dirty="0">
-                <a:solidFill>
-                  <a:schemeClr val="tx1"/>
-                </a:solidFill>
-                <a:hlinkClick r:id="rId3">
-                  <a:extLst>
-                    <a:ext uri="{A12FA001-AC4F-418D-AE19-62706E023703}">
-                      <ahyp:hlinkClr xmlns:ahyp="http://schemas.microsoft.com/office/drawing/2018/hyperlinkcolor" val="tx"/>
-                    </a:ext>
-                  </a:extLst>
-                </a:hlinkClick>
-              </a:rPr>
-              <a:t>http://www-formal.stanford.edu/jmc/whatisai/node1.html</a:t>
-            </a:r>
-            <a:endParaRPr lang="en-US" sz="1600" cap="none" dirty="0">
-              <a:solidFill>
-                <a:schemeClr val="tx1"/>
-              </a:solidFill>
-            </a:endParaRPr>
-          </a:p>
-        </p:txBody>
-      </p:sp>
-      <p:sp>
-        <p:nvSpPr>
-          <p:cNvPr id="4" name="TextBox 3">
-            <a:extLst>
-              <a:ext uri="{FF2B5EF4-FFF2-40B4-BE49-F238E27FC236}">
-                <a16:creationId xmlns:a16="http://schemas.microsoft.com/office/drawing/2014/main" id="{8EC45BDA-E5A1-6364-E6B8-5765B24FF469}"/>
+          <p:cNvPr id="9" name="TextBox 8">
+            <a:extLst>
+              <a:ext uri="{FF2B5EF4-FFF2-40B4-BE49-F238E27FC236}">
+                <a16:creationId xmlns:a16="http://schemas.microsoft.com/office/drawing/2014/main" id="{660F8B7C-CE5B-2277-10C6-FD4A18ABA4D9}"/>
               </a:ext>
             </a:extLst>
           </p:cNvPr>
@@ -22717,8 +22714,8 @@
         </p:nvSpPr>
         <p:spPr>
           <a:xfrm>
-            <a:off x="2400300" y="228600"/>
-            <a:ext cx="7498019" cy="1261884"/>
+            <a:off x="3749090" y="228600"/>
+            <a:ext cx="4693818" cy="984885"/>
           </a:xfrm>
           <a:prstGeom prst="rect">
             <a:avLst/>
@@ -22734,11 +22731,8 @@
             <a:pPr algn="ctr"/>
             <a:r>
               <a:rPr lang="en-US" sz="4000" dirty="0"/>
-              <a:t>What is Artificial Intelligence? </a:t>
-            </a:r>
-            <a:br>
-              <a:rPr lang="en-US" dirty="0"/>
-            </a:br>
+              <a:t>The Proposed Plan</a:t>
+            </a:r>
             <a:br>
               <a:rPr lang="en-US" dirty="0"/>
             </a:br>
@@ -22748,91 +22742,38 @@
       </p:sp>
       <p:pic>
         <p:nvPicPr>
-          <p:cNvPr id="1026" name="Picture 2">
-            <a:extLst>
-              <a:ext uri="{FF2B5EF4-FFF2-40B4-BE49-F238E27FC236}">
-                <a16:creationId xmlns:a16="http://schemas.microsoft.com/office/drawing/2014/main" id="{E19610D1-490F-A8EA-4BD9-BDC5EB902CCA}"/>
+          <p:cNvPr id="4" name="Picture 3">
+            <a:extLst>
+              <a:ext uri="{FF2B5EF4-FFF2-40B4-BE49-F238E27FC236}">
+                <a16:creationId xmlns:a16="http://schemas.microsoft.com/office/drawing/2014/main" id="{E29CA630-BE4E-B22A-6D8D-E571B635D1BD}"/>
               </a:ext>
             </a:extLst>
           </p:cNvPr>
           <p:cNvPicPr>
-            <a:picLocks noChangeAspect="1" noChangeArrowheads="1"/>
+            <a:picLocks noChangeAspect="1"/>
           </p:cNvPicPr>
           <p:nvPr/>
         </p:nvPicPr>
         <p:blipFill>
-          <a:blip r:embed="rId4">
-            <a:extLst>
-              <a:ext uri="{28A0092B-C50C-407E-A947-70E740481C1C}">
-                <a14:useLocalDpi xmlns:a14="http://schemas.microsoft.com/office/drawing/2010/main" val="0"/>
-              </a:ext>
-            </a:extLst>
-          </a:blip>
-          <a:srcRect/>
+          <a:blip r:embed="rId3"/>
           <a:stretch>
             <a:fillRect/>
           </a:stretch>
         </p:blipFill>
-        <p:spPr bwMode="auto">
-          <a:xfrm>
-            <a:off x="9641144" y="2238375"/>
-            <a:ext cx="2381250" cy="3448050"/>
+        <p:spPr>
+          <a:xfrm>
+            <a:off x="1041146" y="986465"/>
+            <a:ext cx="10109705" cy="5843461"/>
           </a:xfrm>
           <a:prstGeom prst="rect">
             <a:avLst/>
           </a:prstGeom>
-          <a:noFill/>
-          <a:extLst>
-            <a:ext uri="{909E8E84-426E-40DD-AFC4-6F175D3DCCD1}">
-              <a14:hiddenFill xmlns:a14="http://schemas.microsoft.com/office/drawing/2010/main">
-                <a:solidFill>
-                  <a:srgbClr val="FFFFFF"/>
-                </a:solidFill>
-              </a14:hiddenFill>
-            </a:ext>
-          </a:extLst>
         </p:spPr>
       </p:pic>
-      <p:sp>
-        <p:nvSpPr>
-          <p:cNvPr id="6" name="TextBox 5">
-            <a:extLst>
-              <a:ext uri="{FF2B5EF4-FFF2-40B4-BE49-F238E27FC236}">
-                <a16:creationId xmlns:a16="http://schemas.microsoft.com/office/drawing/2014/main" id="{054A243C-AF36-90EA-60C3-0E94CF5326BF}"/>
-              </a:ext>
-            </a:extLst>
-          </p:cNvPr>
-          <p:cNvSpPr txBox="1"/>
-          <p:nvPr/>
-        </p:nvSpPr>
-        <p:spPr>
-          <a:xfrm>
-            <a:off x="9898319" y="5791200"/>
-            <a:ext cx="1866900" cy="369332"/>
-          </a:xfrm>
-          <a:prstGeom prst="rect">
-            <a:avLst/>
-          </a:prstGeom>
-          <a:noFill/>
-        </p:spPr>
-        <p:txBody>
-          <a:bodyPr wrap="square">
-            <a:spAutoFit/>
-          </a:bodyPr>
-          <a:lstStyle/>
-          <a:p>
-            <a:r>
-              <a:rPr lang="en-US" sz="1800" dirty="0"/>
-              <a:t>John McCarthy</a:t>
-            </a:r>
-            <a:endParaRPr lang="en-US" dirty="0"/>
-          </a:p>
-        </p:txBody>
-      </p:sp>
     </p:spTree>
     <p:extLst>
       <p:ext uri="{BB962C8B-B14F-4D97-AF65-F5344CB8AC3E}">
-        <p14:creationId xmlns:p14="http://schemas.microsoft.com/office/powerpoint/2010/main" val="650875217"/>
+        <p14:creationId xmlns:p14="http://schemas.microsoft.com/office/powerpoint/2010/main" val="571981106"/>
       </p:ext>
     </p:extLst>
   </p:cSld>
@@ -22859,6 +22800,316 @@
           <a:chExt cx="0" cy="0"/>
         </a:xfrm>
       </p:grpSpPr>
+      <p:sp>
+        <p:nvSpPr>
+          <p:cNvPr id="15" name="Title 1">
+            <a:extLst>
+              <a:ext uri="{FF2B5EF4-FFF2-40B4-BE49-F238E27FC236}">
+                <a16:creationId xmlns:a16="http://schemas.microsoft.com/office/drawing/2014/main" id="{C2047053-05A7-1928-D857-D87CA5F24DF6}"/>
+              </a:ext>
+            </a:extLst>
+          </p:cNvPr>
+          <p:cNvSpPr>
+            <a:spLocks noGrp="1"/>
+          </p:cNvSpPr>
+          <p:nvPr>
+            <p:ph type="ctrTitle"/>
+          </p:nvPr>
+        </p:nvSpPr>
+        <p:spPr>
+          <a:xfrm>
+            <a:off x="169606" y="1562100"/>
+            <a:ext cx="9296400" cy="4800600"/>
+          </a:xfrm>
+        </p:spPr>
+        <p:txBody>
+          <a:bodyPr>
+            <a:normAutofit fontScale="90000"/>
+          </a:bodyPr>
+          <a:lstStyle/>
+          <a:p>
+            <a:br>
+              <a:rPr lang="en-US" sz="1600" dirty="0"/>
+            </a:br>
+            <a:r>
+              <a:rPr lang="en-US" sz="1800" dirty="0"/>
+              <a:t>Q. w</a:t>
+            </a:r>
+            <a:r>
+              <a:rPr lang="en-US" sz="1800" cap="none" dirty="0"/>
+              <a:t>hat is artificial intelligence? </a:t>
+            </a:r>
+            <a:br>
+              <a:rPr lang="en-US" sz="1800" cap="none" dirty="0"/>
+            </a:br>
+            <a:br>
+              <a:rPr lang="en-US" sz="1800" cap="none" dirty="0"/>
+            </a:br>
+            <a:r>
+              <a:rPr lang="en-US" sz="1800" cap="none" dirty="0"/>
+              <a:t>A. It is the science and engineering of making intelligent machines, especially intelligent computer programs. It is related to the similar task of using computers to understand human intelligence, but AI does not have to confine itself to methods that are biologically observable. </a:t>
+            </a:r>
+            <a:br>
+              <a:rPr lang="en-US" sz="1800" cap="none" dirty="0"/>
+            </a:br>
+            <a:br>
+              <a:rPr lang="en-US" sz="1800" cap="none" dirty="0"/>
+            </a:br>
+            <a:r>
+              <a:rPr lang="en-US" sz="1800" cap="none" dirty="0"/>
+              <a:t>Q. What is intelligence? </a:t>
+            </a:r>
+            <a:br>
+              <a:rPr lang="en-US" sz="1800" cap="none" dirty="0"/>
+            </a:br>
+            <a:br>
+              <a:rPr lang="en-US" sz="1800" cap="none" dirty="0"/>
+            </a:br>
+            <a:r>
+              <a:rPr lang="en-US" sz="1800" cap="none" dirty="0"/>
+              <a:t>A. Intelligence is the computational part of the ability to achieve goals in the world. Varying kinds and degrees of intelligence occur in people, many animals and some machines. </a:t>
+            </a:r>
+            <a:br>
+              <a:rPr lang="en-US" sz="1800" cap="none" dirty="0"/>
+            </a:br>
+            <a:br>
+              <a:rPr lang="en-US" sz="1800" cap="none" dirty="0"/>
+            </a:br>
+            <a:r>
+              <a:rPr lang="en-US" sz="1800" cap="none" dirty="0"/>
+              <a:t>Q. Isn't there a solid definition of intelligence that doesn't depend on relating it to human intelligence? </a:t>
+            </a:r>
+            <a:br>
+              <a:rPr lang="en-US" sz="1800" cap="none" dirty="0"/>
+            </a:br>
+            <a:br>
+              <a:rPr lang="en-US" sz="1800" cap="none" dirty="0"/>
+            </a:br>
+            <a:r>
+              <a:rPr lang="en-US" sz="1800" cap="none" dirty="0"/>
+              <a:t>A. Not yet. The problem is that we cannot yet characterize in general what kinds of computational procedures we want to call intelligent. We understand some of the mechanisms of intelligence and not others. </a:t>
+            </a:r>
+            <a:br>
+              <a:rPr lang="en-US" sz="1600" cap="none" dirty="0"/>
+            </a:br>
+            <a:br>
+              <a:rPr lang="en-US" sz="1600" cap="none" dirty="0">
+                <a:solidFill>
+                  <a:schemeClr val="tx1"/>
+                </a:solidFill>
+              </a:rPr>
+            </a:br>
+            <a:r>
+              <a:rPr lang="en-US" sz="1600" i="1" cap="none" dirty="0">
+                <a:solidFill>
+                  <a:schemeClr val="tx1"/>
+                </a:solidFill>
+              </a:rPr>
+              <a:t>Reference: </a:t>
+            </a:r>
+            <a:r>
+              <a:rPr lang="en-US" sz="1600" cap="none" dirty="0">
+                <a:solidFill>
+                  <a:schemeClr val="tx1"/>
+                </a:solidFill>
+              </a:rPr>
+              <a:t>McCarthy, J. (2007, November 12). </a:t>
+            </a:r>
+            <a:r>
+              <a:rPr lang="en-US" sz="1600" i="1" cap="none" dirty="0">
+                <a:solidFill>
+                  <a:schemeClr val="tx1"/>
+                </a:solidFill>
+              </a:rPr>
+              <a:t>What is artificial intelligence? Basic questions</a:t>
+            </a:r>
+            <a:r>
+              <a:rPr lang="en-US" sz="1600" cap="none" dirty="0">
+                <a:solidFill>
+                  <a:schemeClr val="tx1"/>
+                </a:solidFill>
+              </a:rPr>
+              <a:t>. Formal Reasoning Group, Stanford University. </a:t>
+            </a:r>
+            <a:r>
+              <a:rPr lang="en-US" sz="1600" cap="none" dirty="0">
+                <a:solidFill>
+                  <a:schemeClr val="tx1"/>
+                </a:solidFill>
+                <a:hlinkClick r:id="rId3">
+                  <a:extLst>
+                    <a:ext uri="{A12FA001-AC4F-418D-AE19-62706E023703}">
+                      <ahyp:hlinkClr xmlns:ahyp="http://schemas.microsoft.com/office/drawing/2018/hyperlinkcolor" val="tx"/>
+                    </a:ext>
+                  </a:extLst>
+                </a:hlinkClick>
+              </a:rPr>
+              <a:t>http://www-formal.stanford.edu/jmc/whatisai/node1.html</a:t>
+            </a:r>
+            <a:endParaRPr lang="en-US" sz="1600" cap="none" dirty="0">
+              <a:solidFill>
+                <a:schemeClr val="tx1"/>
+              </a:solidFill>
+            </a:endParaRPr>
+          </a:p>
+        </p:txBody>
+      </p:sp>
+      <p:sp>
+        <p:nvSpPr>
+          <p:cNvPr id="4" name="TextBox 3">
+            <a:extLst>
+              <a:ext uri="{FF2B5EF4-FFF2-40B4-BE49-F238E27FC236}">
+                <a16:creationId xmlns:a16="http://schemas.microsoft.com/office/drawing/2014/main" id="{8EC45BDA-E5A1-6364-E6B8-5765B24FF469}"/>
+              </a:ext>
+            </a:extLst>
+          </p:cNvPr>
+          <p:cNvSpPr txBox="1"/>
+          <p:nvPr/>
+        </p:nvSpPr>
+        <p:spPr>
+          <a:xfrm>
+            <a:off x="2400300" y="228600"/>
+            <a:ext cx="7498019" cy="1261884"/>
+          </a:xfrm>
+          <a:prstGeom prst="rect">
+            <a:avLst/>
+          </a:prstGeom>
+          <a:noFill/>
+        </p:spPr>
+        <p:txBody>
+          <a:bodyPr wrap="square" rtlCol="0">
+            <a:spAutoFit/>
+          </a:bodyPr>
+          <a:lstStyle/>
+          <a:p>
+            <a:pPr algn="ctr"/>
+            <a:r>
+              <a:rPr lang="en-US" sz="4000" dirty="0"/>
+              <a:t>What is Artificial Intelligence? </a:t>
+            </a:r>
+            <a:br>
+              <a:rPr lang="en-US" dirty="0"/>
+            </a:br>
+            <a:br>
+              <a:rPr lang="en-US" dirty="0"/>
+            </a:br>
+            <a:endParaRPr lang="en-US" dirty="0"/>
+          </a:p>
+        </p:txBody>
+      </p:sp>
+      <p:pic>
+        <p:nvPicPr>
+          <p:cNvPr id="1026" name="Picture 2">
+            <a:extLst>
+              <a:ext uri="{FF2B5EF4-FFF2-40B4-BE49-F238E27FC236}">
+                <a16:creationId xmlns:a16="http://schemas.microsoft.com/office/drawing/2014/main" id="{E19610D1-490F-A8EA-4BD9-BDC5EB902CCA}"/>
+              </a:ext>
+            </a:extLst>
+          </p:cNvPr>
+          <p:cNvPicPr>
+            <a:picLocks noChangeAspect="1" noChangeArrowheads="1"/>
+          </p:cNvPicPr>
+          <p:nvPr/>
+        </p:nvPicPr>
+        <p:blipFill>
+          <a:blip r:embed="rId4">
+            <a:extLst>
+              <a:ext uri="{28A0092B-C50C-407E-A947-70E740481C1C}">
+                <a14:useLocalDpi xmlns:a14="http://schemas.microsoft.com/office/drawing/2010/main" val="0"/>
+              </a:ext>
+            </a:extLst>
+          </a:blip>
+          <a:srcRect/>
+          <a:stretch>
+            <a:fillRect/>
+          </a:stretch>
+        </p:blipFill>
+        <p:spPr bwMode="auto">
+          <a:xfrm>
+            <a:off x="9641144" y="2238375"/>
+            <a:ext cx="2381250" cy="3448050"/>
+          </a:xfrm>
+          <a:prstGeom prst="rect">
+            <a:avLst/>
+          </a:prstGeom>
+          <a:noFill/>
+          <a:extLst>
+            <a:ext uri="{909E8E84-426E-40DD-AFC4-6F175D3DCCD1}">
+              <a14:hiddenFill xmlns:a14="http://schemas.microsoft.com/office/drawing/2010/main">
+                <a:solidFill>
+                  <a:srgbClr val="FFFFFF"/>
+                </a:solidFill>
+              </a14:hiddenFill>
+            </a:ext>
+          </a:extLst>
+        </p:spPr>
+      </p:pic>
+      <p:sp>
+        <p:nvSpPr>
+          <p:cNvPr id="6" name="TextBox 5">
+            <a:extLst>
+              <a:ext uri="{FF2B5EF4-FFF2-40B4-BE49-F238E27FC236}">
+                <a16:creationId xmlns:a16="http://schemas.microsoft.com/office/drawing/2014/main" id="{054A243C-AF36-90EA-60C3-0E94CF5326BF}"/>
+              </a:ext>
+            </a:extLst>
+          </p:cNvPr>
+          <p:cNvSpPr txBox="1"/>
+          <p:nvPr/>
+        </p:nvSpPr>
+        <p:spPr>
+          <a:xfrm>
+            <a:off x="9898319" y="5791200"/>
+            <a:ext cx="1866900" cy="369332"/>
+          </a:xfrm>
+          <a:prstGeom prst="rect">
+            <a:avLst/>
+          </a:prstGeom>
+          <a:noFill/>
+        </p:spPr>
+        <p:txBody>
+          <a:bodyPr wrap="square">
+            <a:spAutoFit/>
+          </a:bodyPr>
+          <a:lstStyle/>
+          <a:p>
+            <a:r>
+              <a:rPr lang="en-US" sz="1800" dirty="0"/>
+              <a:t>John McCarthy</a:t>
+            </a:r>
+            <a:endParaRPr lang="en-US" dirty="0"/>
+          </a:p>
+        </p:txBody>
+      </p:sp>
+    </p:spTree>
+    <p:extLst>
+      <p:ext uri="{BB962C8B-B14F-4D97-AF65-F5344CB8AC3E}">
+        <p14:creationId xmlns:p14="http://schemas.microsoft.com/office/powerpoint/2010/main" val="650875217"/>
+      </p:ext>
+    </p:extLst>
+  </p:cSld>
+  <p:clrMapOvr>
+    <a:masterClrMapping/>
+  </p:clrMapOvr>
+</p:sld>
+</file>
+
+<file path=ppt/slides/slide4.xml><?xml version="1.0" encoding="utf-8"?>
+<p:sld xmlns:a="http://schemas.openxmlformats.org/drawingml/2006/main" xmlns:r="http://schemas.openxmlformats.org/officeDocument/2006/relationships" xmlns:p="http://schemas.openxmlformats.org/presentationml/2006/main">
+  <p:cSld>
+    <p:spTree>
+      <p:nvGrpSpPr>
+        <p:cNvPr id="1" name=""/>
+        <p:cNvGrpSpPr/>
+        <p:nvPr/>
+      </p:nvGrpSpPr>
+      <p:grpSpPr>
+        <a:xfrm>
+          <a:off x="0" y="0"/>
+          <a:ext cx="0" cy="0"/>
+          <a:chOff x="0" y="0"/>
+          <a:chExt cx="0" cy="0"/>
+        </a:xfrm>
+      </p:grpSpPr>
       <p:pic>
         <p:nvPicPr>
           <p:cNvPr id="5" name="Picture 4">
@@ -22908,7 +23159,7 @@
 </p:sld>
 </file>
 
-<file path=ppt/slides/slide4.xml><?xml version="1.0" encoding="utf-8"?>
+<file path=ppt/slides/slide5.xml><?xml version="1.0" encoding="utf-8"?>
 <p:sld xmlns:a="http://schemas.openxmlformats.org/drawingml/2006/main" xmlns:r="http://schemas.openxmlformats.org/officeDocument/2006/relationships" xmlns:p="http://schemas.openxmlformats.org/presentationml/2006/main">
   <p:cSld>
     <p:spTree>
@@ -23161,7 +23412,7 @@
 </p:sld>
 </file>
 
-<file path=ppt/slides/slide5.xml><?xml version="1.0" encoding="utf-8"?>
+<file path=ppt/slides/slide6.xml><?xml version="1.0" encoding="utf-8"?>
 <p:sld xmlns:a="http://schemas.openxmlformats.org/drawingml/2006/main" xmlns:r="http://schemas.openxmlformats.org/officeDocument/2006/relationships" xmlns:p="http://schemas.openxmlformats.org/presentationml/2006/main">
   <p:cSld>
     <p:spTree>
@@ -23464,106 +23715,6 @@
     <p:extLst>
       <p:ext uri="{BB962C8B-B14F-4D97-AF65-F5344CB8AC3E}">
         <p14:creationId xmlns:p14="http://schemas.microsoft.com/office/powerpoint/2010/main" val="190093375"/>
-      </p:ext>
-    </p:extLst>
-  </p:cSld>
-  <p:clrMapOvr>
-    <a:masterClrMapping/>
-  </p:clrMapOvr>
-</p:sld>
-</file>
-
-<file path=ppt/slides/slide6.xml><?xml version="1.0" encoding="utf-8"?>
-<p:sld xmlns:a="http://schemas.openxmlformats.org/drawingml/2006/main" xmlns:r="http://schemas.openxmlformats.org/officeDocument/2006/relationships" xmlns:p="http://schemas.openxmlformats.org/presentationml/2006/main">
-  <p:cSld>
-    <p:spTree>
-      <p:nvGrpSpPr>
-        <p:cNvPr id="1" name=""/>
-        <p:cNvGrpSpPr/>
-        <p:nvPr/>
-      </p:nvGrpSpPr>
-      <p:grpSpPr>
-        <a:xfrm>
-          <a:off x="0" y="0"/>
-          <a:ext cx="0" cy="0"/>
-          <a:chOff x="0" y="0"/>
-          <a:chExt cx="0" cy="0"/>
-        </a:xfrm>
-      </p:grpSpPr>
-      <p:pic>
-        <p:nvPicPr>
-          <p:cNvPr id="5" name="Picture 4">
-            <a:extLst>
-              <a:ext uri="{FF2B5EF4-FFF2-40B4-BE49-F238E27FC236}">
-                <a16:creationId xmlns:a16="http://schemas.microsoft.com/office/drawing/2014/main" id="{62BB8720-AB20-CD67-1554-683E8F256094}"/>
-              </a:ext>
-            </a:extLst>
-          </p:cNvPr>
-          <p:cNvPicPr>
-            <a:picLocks noChangeAspect="1"/>
-          </p:cNvPicPr>
-          <p:nvPr/>
-        </p:nvPicPr>
-        <p:blipFill>
-          <a:blip r:embed="rId3"/>
-          <a:stretch>
-            <a:fillRect/>
-          </a:stretch>
-        </p:blipFill>
-        <p:spPr>
-          <a:xfrm>
-            <a:off x="2338847" y="1000927"/>
-            <a:ext cx="7514303" cy="5625231"/>
-          </a:xfrm>
-          <a:prstGeom prst="rect">
-            <a:avLst/>
-          </a:prstGeom>
-        </p:spPr>
-      </p:pic>
-      <p:sp>
-        <p:nvSpPr>
-          <p:cNvPr id="7" name="TextBox 6">
-            <a:extLst>
-              <a:ext uri="{FF2B5EF4-FFF2-40B4-BE49-F238E27FC236}">
-                <a16:creationId xmlns:a16="http://schemas.microsoft.com/office/drawing/2014/main" id="{E56FB7F3-9BE8-E619-FAD9-3852312D03F1}"/>
-              </a:ext>
-            </a:extLst>
-          </p:cNvPr>
-          <p:cNvSpPr txBox="1"/>
-          <p:nvPr/>
-        </p:nvSpPr>
-        <p:spPr>
-          <a:xfrm>
-            <a:off x="1943099" y="231842"/>
-            <a:ext cx="8305801" cy="984885"/>
-          </a:xfrm>
-          <a:prstGeom prst="rect">
-            <a:avLst/>
-          </a:prstGeom>
-          <a:noFill/>
-        </p:spPr>
-        <p:txBody>
-          <a:bodyPr wrap="square" rtlCol="0">
-            <a:spAutoFit/>
-          </a:bodyPr>
-          <a:lstStyle/>
-          <a:p>
-            <a:pPr algn="ctr"/>
-            <a:r>
-              <a:rPr lang="en-US" sz="4000" dirty="0"/>
-              <a:t>Approaches to Intelligent Behavior</a:t>
-            </a:r>
-            <a:br>
-              <a:rPr lang="en-US" dirty="0"/>
-            </a:br>
-            <a:endParaRPr lang="en-US" dirty="0"/>
-          </a:p>
-        </p:txBody>
-      </p:sp>
-    </p:spTree>
-    <p:extLst>
-      <p:ext uri="{BB962C8B-B14F-4D97-AF65-F5344CB8AC3E}">
-        <p14:creationId xmlns:p14="http://schemas.microsoft.com/office/powerpoint/2010/main" val="1375888620"/>
       </p:ext>
     </p:extLst>
   </p:cSld>
@@ -23595,7 +23746,7 @@
           <p:cNvPr id="5" name="Picture 4">
             <a:extLst>
               <a:ext uri="{FF2B5EF4-FFF2-40B4-BE49-F238E27FC236}">
-                <a16:creationId xmlns:a16="http://schemas.microsoft.com/office/drawing/2014/main" id="{B8AAF2C3-A201-F047-8758-3869961C6F67}"/>
+                <a16:creationId xmlns:a16="http://schemas.microsoft.com/office/drawing/2014/main" id="{62BB8720-AB20-CD67-1554-683E8F256094}"/>
               </a:ext>
             </a:extLst>
           </p:cNvPr>
@@ -23612,8 +23763,8 @@
         </p:blipFill>
         <p:spPr>
           <a:xfrm>
-            <a:off x="1600198" y="1212716"/>
-            <a:ext cx="8991600" cy="5614710"/>
+            <a:off x="2338847" y="1000927"/>
+            <a:ext cx="7514303" cy="5625231"/>
           </a:xfrm>
           <a:prstGeom prst="rect">
             <a:avLst/>
@@ -23625,7 +23776,7 @@
           <p:cNvPr id="7" name="TextBox 6">
             <a:extLst>
               <a:ext uri="{FF2B5EF4-FFF2-40B4-BE49-F238E27FC236}">
-                <a16:creationId xmlns:a16="http://schemas.microsoft.com/office/drawing/2014/main" id="{1F4E59B7-8E14-71FF-16E4-9280583C7663}"/>
+                <a16:creationId xmlns:a16="http://schemas.microsoft.com/office/drawing/2014/main" id="{E56FB7F3-9BE8-E619-FAD9-3852312D03F1}"/>
               </a:ext>
             </a:extLst>
           </p:cNvPr>
@@ -23634,8 +23785,8 @@
         </p:nvSpPr>
         <p:spPr>
           <a:xfrm>
-            <a:off x="2076448" y="227831"/>
-            <a:ext cx="8039101" cy="984885"/>
+            <a:off x="1943099" y="231842"/>
+            <a:ext cx="8305801" cy="984885"/>
           </a:xfrm>
           <a:prstGeom prst="rect">
             <a:avLst/>
@@ -23651,7 +23802,7 @@
             <a:pPr algn="ctr"/>
             <a:r>
               <a:rPr lang="en-US" sz="4000" dirty="0"/>
-              <a:t>Intelligent Behavior in the Market</a:t>
+              <a:t>Approaches to Intelligent Behavior</a:t>
             </a:r>
             <a:br>
               <a:rPr lang="en-US" dirty="0"/>
@@ -23663,7 +23814,7 @@
     </p:spTree>
     <p:extLst>
       <p:ext uri="{BB962C8B-B14F-4D97-AF65-F5344CB8AC3E}">
-        <p14:creationId xmlns:p14="http://schemas.microsoft.com/office/powerpoint/2010/main" val="2620153804"/>
+        <p14:creationId xmlns:p14="http://schemas.microsoft.com/office/powerpoint/2010/main" val="1375888620"/>
       </p:ext>
     </p:extLst>
   </p:cSld>
@@ -23690,59 +23841,12 @@
           <a:chExt cx="0" cy="0"/>
         </a:xfrm>
       </p:grpSpPr>
-      <p:sp>
-        <p:nvSpPr>
-          <p:cNvPr id="5" name="TextBox 4">
-            <a:extLst>
-              <a:ext uri="{FF2B5EF4-FFF2-40B4-BE49-F238E27FC236}">
-                <a16:creationId xmlns:a16="http://schemas.microsoft.com/office/drawing/2014/main" id="{E8027731-A65C-59BA-C3D7-B288099E29D0}"/>
-              </a:ext>
-            </a:extLst>
-          </p:cNvPr>
-          <p:cNvSpPr txBox="1"/>
-          <p:nvPr/>
-        </p:nvSpPr>
-        <p:spPr>
-          <a:xfrm>
-            <a:off x="1062037" y="228600"/>
-            <a:ext cx="10067926" cy="1600438"/>
-          </a:xfrm>
-          <a:prstGeom prst="rect">
-            <a:avLst/>
-          </a:prstGeom>
-          <a:noFill/>
-        </p:spPr>
-        <p:txBody>
-          <a:bodyPr wrap="square" rtlCol="0">
-            <a:spAutoFit/>
-          </a:bodyPr>
-          <a:lstStyle/>
-          <a:p>
-            <a:pPr algn="ctr"/>
-            <a:r>
-              <a:rPr lang="en-US" sz="4000" dirty="0"/>
-              <a:t>Identifying Intelligent Behavior</a:t>
-            </a:r>
-          </a:p>
-          <a:p>
-            <a:pPr algn="ctr"/>
-            <a:r>
-              <a:rPr lang="en-US" sz="4000" dirty="0"/>
-              <a:t>The Imitation Game</a:t>
-            </a:r>
-            <a:br>
-              <a:rPr lang="en-US" dirty="0"/>
-            </a:br>
-            <a:endParaRPr lang="en-US" dirty="0"/>
-          </a:p>
-        </p:txBody>
-      </p:sp>
       <p:pic>
         <p:nvPicPr>
-          <p:cNvPr id="7" name="Picture 6">
-            <a:extLst>
-              <a:ext uri="{FF2B5EF4-FFF2-40B4-BE49-F238E27FC236}">
-                <a16:creationId xmlns:a16="http://schemas.microsoft.com/office/drawing/2014/main" id="{1DE76031-A7FD-67A2-AE4E-6B6D58F11A6A}"/>
+          <p:cNvPr id="5" name="Picture 4">
+            <a:extLst>
+              <a:ext uri="{FF2B5EF4-FFF2-40B4-BE49-F238E27FC236}">
+                <a16:creationId xmlns:a16="http://schemas.microsoft.com/office/drawing/2014/main" id="{B8AAF2C3-A201-F047-8758-3869961C6F67}"/>
               </a:ext>
             </a:extLst>
           </p:cNvPr>
@@ -23759,237 +23863,58 @@
         </p:blipFill>
         <p:spPr>
           <a:xfrm>
-            <a:off x="676605" y="2514600"/>
-            <a:ext cx="6675698" cy="2331922"/>
+            <a:off x="1600198" y="1212716"/>
+            <a:ext cx="8991600" cy="5614710"/>
           </a:xfrm>
           <a:prstGeom prst="rect">
             <a:avLst/>
           </a:prstGeom>
         </p:spPr>
       </p:pic>
-      <p:pic>
-        <p:nvPicPr>
-          <p:cNvPr id="4098" name="Picture 2">
-            <a:extLst>
-              <a:ext uri="{FF2B5EF4-FFF2-40B4-BE49-F238E27FC236}">
-                <a16:creationId xmlns:a16="http://schemas.microsoft.com/office/drawing/2014/main" id="{7EDE4F11-1792-EBF2-F1CB-389D73E1E0CD}"/>
-              </a:ext>
-            </a:extLst>
-          </p:cNvPr>
-          <p:cNvPicPr>
-            <a:picLocks noChangeAspect="1" noChangeArrowheads="1"/>
-          </p:cNvPicPr>
+      <p:sp>
+        <p:nvSpPr>
+          <p:cNvPr id="7" name="TextBox 6">
+            <a:extLst>
+              <a:ext uri="{FF2B5EF4-FFF2-40B4-BE49-F238E27FC236}">
+                <a16:creationId xmlns:a16="http://schemas.microsoft.com/office/drawing/2014/main" id="{1F4E59B7-8E14-71FF-16E4-9280583C7663}"/>
+              </a:ext>
+            </a:extLst>
+          </p:cNvPr>
+          <p:cNvSpPr txBox="1"/>
           <p:nvPr/>
-        </p:nvPicPr>
-        <p:blipFill>
-          <a:blip r:embed="rId4">
-            <a:extLst>
-              <a:ext uri="{28A0092B-C50C-407E-A947-70E740481C1C}">
-                <a14:useLocalDpi xmlns:a14="http://schemas.microsoft.com/office/drawing/2010/main" val="0"/>
-              </a:ext>
-            </a:extLst>
-          </a:blip>
-          <a:srcRect/>
-          <a:stretch>
-            <a:fillRect/>
-          </a:stretch>
-        </p:blipFill>
-        <p:spPr bwMode="auto">
-          <a:xfrm>
-            <a:off x="9433129" y="1943222"/>
-            <a:ext cx="2381250" cy="3171825"/>
+        </p:nvSpPr>
+        <p:spPr>
+          <a:xfrm>
+            <a:off x="2076448" y="227831"/>
+            <a:ext cx="8039101" cy="984885"/>
           </a:xfrm>
           <a:prstGeom prst="rect">
             <a:avLst/>
           </a:prstGeom>
           <a:noFill/>
-          <a:extLst>
-            <a:ext uri="{909E8E84-426E-40DD-AFC4-6F175D3DCCD1}">
-              <a14:hiddenFill xmlns:a14="http://schemas.microsoft.com/office/drawing/2010/main">
-                <a:solidFill>
-                  <a:srgbClr val="FFFFFF"/>
-                </a:solidFill>
-              </a14:hiddenFill>
-            </a:ext>
-          </a:extLst>
-        </p:spPr>
-      </p:pic>
-      <p:sp>
-        <p:nvSpPr>
-          <p:cNvPr id="9" name="TextBox 8">
-            <a:extLst>
-              <a:ext uri="{FF2B5EF4-FFF2-40B4-BE49-F238E27FC236}">
-                <a16:creationId xmlns:a16="http://schemas.microsoft.com/office/drawing/2014/main" id="{791494A2-60EE-07FB-080F-6824B76E8F0B}"/>
-              </a:ext>
-            </a:extLst>
-          </p:cNvPr>
-          <p:cNvSpPr txBox="1"/>
-          <p:nvPr/>
-        </p:nvSpPr>
-        <p:spPr>
-          <a:xfrm>
-            <a:off x="9915831" y="5146473"/>
-            <a:ext cx="1415846" cy="381000"/>
-          </a:xfrm>
-          <a:prstGeom prst="rect">
-            <a:avLst/>
-          </a:prstGeom>
-          <a:noFill/>
-        </p:spPr>
-        <p:txBody>
-          <a:bodyPr wrap="square">
+        </p:spPr>
+        <p:txBody>
+          <a:bodyPr wrap="square" rtlCol="0">
             <a:spAutoFit/>
           </a:bodyPr>
           <a:lstStyle/>
           <a:p>
-            <a:r>
+            <a:pPr algn="ctr"/>
+            <a:r>
+              <a:rPr lang="en-US" sz="4000" dirty="0"/>
+              <a:t>Intelligent Behavior in the Market</a:t>
+            </a:r>
+            <a:br>
               <a:rPr lang="en-US" dirty="0"/>
-              <a:t>Alan Turing</a:t>
-            </a:r>
-          </a:p>
-        </p:txBody>
-      </p:sp>
-      <p:sp>
-        <p:nvSpPr>
-          <p:cNvPr id="11" name="TextBox 10">
-            <a:extLst>
-              <a:ext uri="{FF2B5EF4-FFF2-40B4-BE49-F238E27FC236}">
-                <a16:creationId xmlns:a16="http://schemas.microsoft.com/office/drawing/2014/main" id="{06FADD12-022D-BF63-E6D8-E8A4B86992B0}"/>
-              </a:ext>
-            </a:extLst>
-          </p:cNvPr>
-          <p:cNvSpPr txBox="1"/>
-          <p:nvPr/>
-        </p:nvSpPr>
-        <p:spPr>
-          <a:xfrm>
-            <a:off x="164433" y="5103674"/>
-            <a:ext cx="3850021" cy="1754326"/>
-          </a:xfrm>
-          <a:prstGeom prst="rect">
-            <a:avLst/>
-          </a:prstGeom>
-          <a:noFill/>
-        </p:spPr>
-        <p:txBody>
-          <a:bodyPr wrap="square">
-            <a:spAutoFit/>
-          </a:bodyPr>
-          <a:lstStyle/>
-          <a:p>
-            <a:r>
-              <a:rPr lang="en-US" dirty="0"/>
-              <a:t> </a:t>
-            </a:r>
-            <a:r>
-              <a:rPr lang="en-US" b="1" dirty="0"/>
-              <a:t>Strengths</a:t>
-            </a:r>
-          </a:p>
-          <a:p>
-            <a:pPr marL="285750" indent="-285750">
-              <a:buFont typeface="Arial" panose="020B0604020202020204" pitchFamily="34" charset="0"/>
-              <a:buChar char="•"/>
-            </a:pPr>
-            <a:r>
-              <a:rPr lang="en-US" dirty="0"/>
-              <a:t>Simplicity</a:t>
-            </a:r>
-          </a:p>
-          <a:p>
-            <a:pPr marL="285750" indent="-285750">
-              <a:buFont typeface="Arial" panose="020B0604020202020204" pitchFamily="34" charset="0"/>
-              <a:buChar char="•"/>
-            </a:pPr>
-            <a:r>
-              <a:rPr lang="en-US" dirty="0"/>
-              <a:t>Breadth of subject matter</a:t>
-            </a:r>
-          </a:p>
-          <a:p>
-            <a:pPr marL="285750" indent="-285750">
-              <a:buFont typeface="Arial" panose="020B0604020202020204" pitchFamily="34" charset="0"/>
-              <a:buChar char="•"/>
-            </a:pPr>
-            <a:r>
-              <a:rPr lang="en-US" dirty="0"/>
-              <a:t>Include emotional and aesthetic intelligence</a:t>
-            </a:r>
-          </a:p>
-          <a:p>
+            </a:br>
             <a:endParaRPr lang="en-US" dirty="0"/>
-          </a:p>
-        </p:txBody>
-      </p:sp>
-      <p:sp>
-        <p:nvSpPr>
-          <p:cNvPr id="13" name="TextBox 12">
-            <a:extLst>
-              <a:ext uri="{FF2B5EF4-FFF2-40B4-BE49-F238E27FC236}">
-                <a16:creationId xmlns:a16="http://schemas.microsoft.com/office/drawing/2014/main" id="{2609057B-69EF-1F9C-7041-8CC349AD23E7}"/>
-              </a:ext>
-            </a:extLst>
-          </p:cNvPr>
-          <p:cNvSpPr txBox="1"/>
-          <p:nvPr/>
-        </p:nvSpPr>
-        <p:spPr>
-          <a:xfrm>
-            <a:off x="4014454" y="5028963"/>
-            <a:ext cx="4576800" cy="1200329"/>
-          </a:xfrm>
-          <a:prstGeom prst="rect">
-            <a:avLst/>
-          </a:prstGeom>
-          <a:noFill/>
-        </p:spPr>
-        <p:txBody>
-          <a:bodyPr wrap="square">
-            <a:spAutoFit/>
-          </a:bodyPr>
-          <a:lstStyle/>
-          <a:p>
-            <a:r>
-              <a:rPr lang="en-US" b="1" dirty="0"/>
-              <a:t>Weaknesses</a:t>
-            </a:r>
-          </a:p>
-          <a:p>
-            <a:pPr marL="285750" indent="-285750">
-              <a:buFont typeface="Arial" panose="020B0604020202020204" pitchFamily="34" charset="0"/>
-              <a:buChar char="•"/>
-            </a:pPr>
-            <a:r>
-              <a:rPr lang="en-US" dirty="0"/>
-              <a:t>Some human behavior is unintelligent</a:t>
-            </a:r>
-          </a:p>
-          <a:p>
-            <a:pPr marL="285750" indent="-285750">
-              <a:buFont typeface="Arial" panose="020B0604020202020204" pitchFamily="34" charset="0"/>
-              <a:buChar char="•"/>
-            </a:pPr>
-            <a:r>
-              <a:rPr lang="en-US" dirty="0"/>
-              <a:t>Some intelligent behavior is inhuman</a:t>
-            </a:r>
-          </a:p>
-          <a:p>
-            <a:pPr marL="285750" indent="-285750">
-              <a:buFont typeface="Arial" panose="020B0604020202020204" pitchFamily="34" charset="0"/>
-              <a:buChar char="•"/>
-            </a:pPr>
-            <a:r>
-              <a:rPr lang="en-US" dirty="0"/>
-              <a:t>Searle’s Chinese room</a:t>
-            </a:r>
           </a:p>
         </p:txBody>
       </p:sp>
     </p:spTree>
     <p:extLst>
       <p:ext uri="{BB962C8B-B14F-4D97-AF65-F5344CB8AC3E}">
-        <p14:creationId xmlns:p14="http://schemas.microsoft.com/office/powerpoint/2010/main" val="496310068"/>
+        <p14:creationId xmlns:p14="http://schemas.microsoft.com/office/powerpoint/2010/main" val="2620153804"/>
       </p:ext>
     </p:extLst>
   </p:cSld>
@@ -24004,13 +23929,7 @@
   <p:cSld>
     <p:spTree>
       <p:nvGrpSpPr>
-        <p:cNvPr id="1" name="">
-          <a:extLst>
-            <a:ext uri="{FF2B5EF4-FFF2-40B4-BE49-F238E27FC236}">
-              <a16:creationId xmlns:a16="http://schemas.microsoft.com/office/drawing/2014/main" id="{E7773EAD-3AFA-9B70-8C05-AC647EF05AA7}"/>
-            </a:ext>
-          </a:extLst>
-        </p:cNvPr>
+        <p:cNvPr id="1" name=""/>
         <p:cNvGrpSpPr/>
         <p:nvPr/>
       </p:nvGrpSpPr>
@@ -24027,7 +23946,7 @@
           <p:cNvPr id="5" name="TextBox 4">
             <a:extLst>
               <a:ext uri="{FF2B5EF4-FFF2-40B4-BE49-F238E27FC236}">
-                <a16:creationId xmlns:a16="http://schemas.microsoft.com/office/drawing/2014/main" id="{9B8B78FF-72F1-DBB8-91DD-E133A00152F9}"/>
+                <a16:creationId xmlns:a16="http://schemas.microsoft.com/office/drawing/2014/main" id="{E8027731-A65C-59BA-C3D7-B288099E29D0}"/>
               </a:ext>
             </a:extLst>
           </p:cNvPr>
@@ -24053,14 +23972,14 @@
             <a:pPr algn="ctr"/>
             <a:r>
               <a:rPr lang="en-US" sz="4000" dirty="0"/>
-              <a:t>An Attack on Intelligent Behavior</a:t>
+              <a:t>Identifying Intelligent Behavior</a:t>
             </a:r>
           </a:p>
           <a:p>
             <a:pPr algn="ctr"/>
             <a:r>
               <a:rPr lang="en-US" sz="4000" dirty="0"/>
-              <a:t>The Chinese Room</a:t>
+              <a:t>The Imitation Game</a:t>
             </a:r>
             <a:br>
               <a:rPr lang="en-US" dirty="0"/>
@@ -24071,10 +23990,40 @@
       </p:sp>
       <p:pic>
         <p:nvPicPr>
-          <p:cNvPr id="5122" name="Picture 2" descr="A Chinese Speaker's take on the Chinese Room | by Alan Tan | TDS Archive |  Medium">
-            <a:extLst>
-              <a:ext uri="{FF2B5EF4-FFF2-40B4-BE49-F238E27FC236}">
-                <a16:creationId xmlns:a16="http://schemas.microsoft.com/office/drawing/2014/main" id="{74B692B4-0DC0-7407-5E4F-663A1BC06792}"/>
+          <p:cNvPr id="7" name="Picture 6">
+            <a:extLst>
+              <a:ext uri="{FF2B5EF4-FFF2-40B4-BE49-F238E27FC236}">
+                <a16:creationId xmlns:a16="http://schemas.microsoft.com/office/drawing/2014/main" id="{1DE76031-A7FD-67A2-AE4E-6B6D58F11A6A}"/>
+              </a:ext>
+            </a:extLst>
+          </p:cNvPr>
+          <p:cNvPicPr>
+            <a:picLocks noChangeAspect="1"/>
+          </p:cNvPicPr>
+          <p:nvPr/>
+        </p:nvPicPr>
+        <p:blipFill>
+          <a:blip r:embed="rId3"/>
+          <a:stretch>
+            <a:fillRect/>
+          </a:stretch>
+        </p:blipFill>
+        <p:spPr>
+          <a:xfrm>
+            <a:off x="676605" y="2514600"/>
+            <a:ext cx="6675698" cy="2331922"/>
+          </a:xfrm>
+          <a:prstGeom prst="rect">
+            <a:avLst/>
+          </a:prstGeom>
+        </p:spPr>
+      </p:pic>
+      <p:pic>
+        <p:nvPicPr>
+          <p:cNvPr id="4098" name="Picture 2">
+            <a:extLst>
+              <a:ext uri="{FF2B5EF4-FFF2-40B4-BE49-F238E27FC236}">
+                <a16:creationId xmlns:a16="http://schemas.microsoft.com/office/drawing/2014/main" id="{7EDE4F11-1792-EBF2-F1CB-389D73E1E0CD}"/>
               </a:ext>
             </a:extLst>
           </p:cNvPr>
@@ -24084,7 +24033,7 @@
           <p:nvPr/>
         </p:nvPicPr>
         <p:blipFill>
-          <a:blip r:embed="rId3">
+          <a:blip r:embed="rId4">
             <a:extLst>
               <a:ext uri="{28A0092B-C50C-407E-A947-70E740481C1C}">
                 <a14:useLocalDpi xmlns:a14="http://schemas.microsoft.com/office/drawing/2010/main" val="0"/>
@@ -24098,8 +24047,8 @@
         </p:blipFill>
         <p:spPr bwMode="auto">
           <a:xfrm>
-            <a:off x="685800" y="1665397"/>
-            <a:ext cx="6096000" cy="3781425"/>
+            <a:off x="9433129" y="1943222"/>
+            <a:ext cx="2381250" cy="3171825"/>
           </a:xfrm>
           <a:prstGeom prst="rect">
             <a:avLst/>
@@ -24116,59 +24065,47 @@
           </a:extLst>
         </p:spPr>
       </p:pic>
-      <p:pic>
-        <p:nvPicPr>
-          <p:cNvPr id="5124" name="Picture 4">
-            <a:extLst>
-              <a:ext uri="{FF2B5EF4-FFF2-40B4-BE49-F238E27FC236}">
-                <a16:creationId xmlns:a16="http://schemas.microsoft.com/office/drawing/2014/main" id="{80B13551-E15E-DF10-B70F-494BBDCD6160}"/>
-              </a:ext>
-            </a:extLst>
-          </p:cNvPr>
-          <p:cNvPicPr>
-            <a:picLocks noChangeAspect="1" noChangeArrowheads="1"/>
-          </p:cNvPicPr>
+      <p:sp>
+        <p:nvSpPr>
+          <p:cNvPr id="9" name="TextBox 8">
+            <a:extLst>
+              <a:ext uri="{FF2B5EF4-FFF2-40B4-BE49-F238E27FC236}">
+                <a16:creationId xmlns:a16="http://schemas.microsoft.com/office/drawing/2014/main" id="{791494A2-60EE-07FB-080F-6824B76E8F0B}"/>
+              </a:ext>
+            </a:extLst>
+          </p:cNvPr>
+          <p:cNvSpPr txBox="1"/>
           <p:nvPr/>
-        </p:nvPicPr>
-        <p:blipFill>
-          <a:blip r:embed="rId4">
-            <a:extLst>
-              <a:ext uri="{28A0092B-C50C-407E-A947-70E740481C1C}">
-                <a14:useLocalDpi xmlns:a14="http://schemas.microsoft.com/office/drawing/2010/main" val="0"/>
-              </a:ext>
-            </a:extLst>
-          </a:blip>
-          <a:srcRect/>
-          <a:stretch>
-            <a:fillRect/>
-          </a:stretch>
-        </p:blipFill>
-        <p:spPr bwMode="auto">
-          <a:xfrm>
-            <a:off x="8712618" y="1798747"/>
-            <a:ext cx="2381250" cy="3571875"/>
+        </p:nvSpPr>
+        <p:spPr>
+          <a:xfrm>
+            <a:off x="9915831" y="5146473"/>
+            <a:ext cx="1415846" cy="381000"/>
           </a:xfrm>
           <a:prstGeom prst="rect">
             <a:avLst/>
           </a:prstGeom>
           <a:noFill/>
-          <a:extLst>
-            <a:ext uri="{909E8E84-426E-40DD-AFC4-6F175D3DCCD1}">
-              <a14:hiddenFill xmlns:a14="http://schemas.microsoft.com/office/drawing/2010/main">
-                <a:solidFill>
-                  <a:srgbClr val="FFFFFF"/>
-                </a:solidFill>
-              </a14:hiddenFill>
-            </a:ext>
-          </a:extLst>
-        </p:spPr>
-      </p:pic>
-      <p:sp>
-        <p:nvSpPr>
-          <p:cNvPr id="7" name="TextBox 6">
-            <a:extLst>
-              <a:ext uri="{FF2B5EF4-FFF2-40B4-BE49-F238E27FC236}">
-                <a16:creationId xmlns:a16="http://schemas.microsoft.com/office/drawing/2014/main" id="{DE3DFAF6-ED0D-36CD-2B7C-2D37A81BFE39}"/>
+        </p:spPr>
+        <p:txBody>
+          <a:bodyPr wrap="square">
+            <a:spAutoFit/>
+          </a:bodyPr>
+          <a:lstStyle/>
+          <a:p>
+            <a:r>
+              <a:rPr lang="en-US" dirty="0"/>
+              <a:t>Alan Turing</a:t>
+            </a:r>
+          </a:p>
+        </p:txBody>
+      </p:sp>
+      <p:sp>
+        <p:nvSpPr>
+          <p:cNvPr id="11" name="TextBox 10">
+            <a:extLst>
+              <a:ext uri="{FF2B5EF4-FFF2-40B4-BE49-F238E27FC236}">
+                <a16:creationId xmlns:a16="http://schemas.microsoft.com/office/drawing/2014/main" id="{06FADD12-022D-BF63-E6D8-E8A4B86992B0}"/>
               </a:ext>
             </a:extLst>
           </p:cNvPr>
@@ -24177,8 +24114,8 @@
         </p:nvSpPr>
         <p:spPr>
           <a:xfrm>
-            <a:off x="9195320" y="5370622"/>
-            <a:ext cx="1472680" cy="369332"/>
+            <a:off x="164433" y="5103674"/>
+            <a:ext cx="3850021" cy="1754326"/>
           </a:xfrm>
           <a:prstGeom prst="rect">
             <a:avLst/>
@@ -24193,7 +24130,109 @@
           <a:p>
             <a:r>
               <a:rPr lang="en-US" dirty="0"/>
-              <a:t>John Searle</a:t>
+              <a:t> </a:t>
+            </a:r>
+            <a:r>
+              <a:rPr lang="en-US" b="1" dirty="0"/>
+              <a:t>Strengths</a:t>
+            </a:r>
+          </a:p>
+          <a:p>
+            <a:pPr marL="285750" indent="-285750">
+              <a:buFont typeface="Arial" panose="020B0604020202020204" pitchFamily="34" charset="0"/>
+              <a:buChar char="•"/>
+            </a:pPr>
+            <a:r>
+              <a:rPr lang="en-US" dirty="0"/>
+              <a:t>Simplicity</a:t>
+            </a:r>
+          </a:p>
+          <a:p>
+            <a:pPr marL="285750" indent="-285750">
+              <a:buFont typeface="Arial" panose="020B0604020202020204" pitchFamily="34" charset="0"/>
+              <a:buChar char="•"/>
+            </a:pPr>
+            <a:r>
+              <a:rPr lang="en-US" dirty="0"/>
+              <a:t>Breadth of subject matter</a:t>
+            </a:r>
+          </a:p>
+          <a:p>
+            <a:pPr marL="285750" indent="-285750">
+              <a:buFont typeface="Arial" panose="020B0604020202020204" pitchFamily="34" charset="0"/>
+              <a:buChar char="•"/>
+            </a:pPr>
+            <a:r>
+              <a:rPr lang="en-US" dirty="0"/>
+              <a:t>Include emotional and aesthetic intelligence</a:t>
+            </a:r>
+          </a:p>
+          <a:p>
+            <a:endParaRPr lang="en-US" dirty="0"/>
+          </a:p>
+        </p:txBody>
+      </p:sp>
+      <p:sp>
+        <p:nvSpPr>
+          <p:cNvPr id="13" name="TextBox 12">
+            <a:extLst>
+              <a:ext uri="{FF2B5EF4-FFF2-40B4-BE49-F238E27FC236}">
+                <a16:creationId xmlns:a16="http://schemas.microsoft.com/office/drawing/2014/main" id="{2609057B-69EF-1F9C-7041-8CC349AD23E7}"/>
+              </a:ext>
+            </a:extLst>
+          </p:cNvPr>
+          <p:cNvSpPr txBox="1"/>
+          <p:nvPr/>
+        </p:nvSpPr>
+        <p:spPr>
+          <a:xfrm>
+            <a:off x="4014454" y="5028963"/>
+            <a:ext cx="4576800" cy="1200329"/>
+          </a:xfrm>
+          <a:prstGeom prst="rect">
+            <a:avLst/>
+          </a:prstGeom>
+          <a:noFill/>
+        </p:spPr>
+        <p:txBody>
+          <a:bodyPr wrap="square">
+            <a:spAutoFit/>
+          </a:bodyPr>
+          <a:lstStyle/>
+          <a:p>
+            <a:r>
+              <a:rPr lang="en-US" b="1" dirty="0"/>
+              <a:t>Weaknesses</a:t>
+            </a:r>
+          </a:p>
+          <a:p>
+            <a:pPr marL="285750" indent="-285750">
+              <a:buFont typeface="Arial" panose="020B0604020202020204" pitchFamily="34" charset="0"/>
+              <a:buChar char="•"/>
+            </a:pPr>
+            <a:r>
+              <a:rPr lang="en-US" dirty="0"/>
+              <a:t>Some human behavior is unintelligent</a:t>
+            </a:r>
+          </a:p>
+          <a:p>
+            <a:pPr marL="285750" indent="-285750">
+              <a:buFont typeface="Arial" panose="020B0604020202020204" pitchFamily="34" charset="0"/>
+              <a:buChar char="•"/>
+            </a:pPr>
+            <a:r>
+              <a:rPr lang="en-US" dirty="0"/>
+              <a:t>Some intelligent behavior is inhuman</a:t>
+            </a:r>
+          </a:p>
+          <a:p>
+            <a:pPr marL="285750" indent="-285750">
+              <a:buFont typeface="Arial" panose="020B0604020202020204" pitchFamily="34" charset="0"/>
+              <a:buChar char="•"/>
+            </a:pPr>
+            <a:r>
+              <a:rPr lang="en-US" dirty="0"/>
+              <a:t>Searle’s Chinese room</a:t>
             </a:r>
           </a:p>
         </p:txBody>
@@ -24201,7 +24240,7 @@
     </p:spTree>
     <p:extLst>
       <p:ext uri="{BB962C8B-B14F-4D97-AF65-F5344CB8AC3E}">
-        <p14:creationId xmlns:p14="http://schemas.microsoft.com/office/powerpoint/2010/main" val="3664725273"/>
+        <p14:creationId xmlns:p14="http://schemas.microsoft.com/office/powerpoint/2010/main" val="496310068"/>
       </p:ext>
     </p:extLst>
   </p:cSld>
@@ -24728,6 +24767,15 @@
 </file>
 
 <file path=customXml/item1.xml><?xml version="1.0" encoding="utf-8"?>
+<?mso-contentType ?>
+<FormTemplates xmlns="http://schemas.microsoft.com/sharepoint/v3/contenttype/forms">
+  <Display>DocumentLibraryForm</Display>
+  <Edit>DocumentLibraryForm</Edit>
+  <New>DocumentLibraryForm</New>
+</FormTemplates>
+</file>
+
+<file path=customXml/item2.xml><?xml version="1.0" encoding="utf-8"?>
 <p:properties xmlns:p="http://schemas.microsoft.com/office/2006/metadata/properties" xmlns:xsi="http://www.w3.org/2001/XMLSchema-instance" xmlns:pc="http://schemas.microsoft.com/office/infopath/2007/PartnerControls">
   <documentManagement>
     <_ip_UnifiedCompliancePolicyUIAction xmlns="http://schemas.microsoft.com/sharepoint/v3" xsi:nil="true"/>
@@ -24747,7 +24795,7 @@
 </p:properties>
 </file>
 
-<file path=customXml/item2.xml><?xml version="1.0" encoding="utf-8"?>
+<file path=customXml/item3.xml><?xml version="1.0" encoding="utf-8"?>
 <ct:contentTypeSchema xmlns:ct="http://schemas.microsoft.com/office/2006/metadata/contentType" xmlns:ma="http://schemas.microsoft.com/office/2006/metadata/properties/metaAttributes" ct:_="" ma:_="" ma:contentTypeName="Document" ma:contentTypeID="0x01010079F111ED35F8CC479449609E8A0923A6" ma:contentTypeVersion="30" ma:contentTypeDescription="Create a new document." ma:contentTypeScope="" ma:versionID="cec0622158e8f13124e9e8fd4de31bd1">
   <xsd:schema xmlns:xsd="http://www.w3.org/2001/XMLSchema" xmlns:xs="http://www.w3.org/2001/XMLSchema" xmlns:p="http://schemas.microsoft.com/office/2006/metadata/properties" xmlns:ns1="http://schemas.microsoft.com/sharepoint/v3" xmlns:ns2="71af3243-3dd4-4a8d-8c0d-dd76da1f02a5" xmlns:ns3="16c05727-aa75-4e4a-9b5f-8a80a1165891" xmlns:ns4="230e9df3-be65-4c73-a93b-d1236ebd677e" targetNamespace="http://schemas.microsoft.com/office/2006/metadata/properties" ma:root="true" ma:fieldsID="3b52f30ab005d15df08657af532e6e38" ns1:_="" ns2:_="" ns3:_="" ns4:_="">
     <xsd:import namespace="http://schemas.microsoft.com/sharepoint/v3"/>
@@ -25065,16 +25113,15 @@
 </ct:contentTypeSchema>
 </file>
 
-<file path=customXml/item3.xml><?xml version="1.0" encoding="utf-8"?>
-<?mso-contentType ?>
-<FormTemplates xmlns="http://schemas.microsoft.com/sharepoint/v3/contenttype/forms">
-  <Display>DocumentLibraryForm</Display>
-  <Edit>DocumentLibraryForm</Edit>
-  <New>DocumentLibraryForm</New>
-</FormTemplates>
+<file path=customXml/itemProps1.xml><?xml version="1.0" encoding="utf-8"?>
+<ds:datastoreItem xmlns:ds="http://schemas.openxmlformats.org/officeDocument/2006/customXml" ds:itemID="{A533346F-C811-4404-B626-0E7631B21215}">
+  <ds:schemaRefs>
+    <ds:schemaRef ds:uri="http://schemas.microsoft.com/sharepoint/v3/contenttype/forms"/>
+  </ds:schemaRefs>
+</ds:datastoreItem>
 </file>
 
-<file path=customXml/itemProps1.xml><?xml version="1.0" encoding="utf-8"?>
+<file path=customXml/itemProps2.xml><?xml version="1.0" encoding="utf-8"?>
 <ds:datastoreItem xmlns:ds="http://schemas.openxmlformats.org/officeDocument/2006/customXml" ds:itemID="{0DA384A2-DC2C-4578-B8CE-512657D68B32}">
   <ds:schemaRefs>
     <ds:schemaRef ds:uri="http://schemas.microsoft.com/office/2006/metadata/properties"/>
@@ -25086,7 +25133,7 @@
 </ds:datastoreItem>
 </file>
 
-<file path=customXml/itemProps2.xml><?xml version="1.0" encoding="utf-8"?>
+<file path=customXml/itemProps3.xml><?xml version="1.0" encoding="utf-8"?>
 <ds:datastoreItem xmlns:ds="http://schemas.openxmlformats.org/officeDocument/2006/customXml" ds:itemID="{E2E911A2-2017-41E4-8340-9C55208FC246}">
   <ds:schemaRefs>
     <ds:schemaRef ds:uri="http://schemas.microsoft.com/office/2006/metadata/contentType"/>
@@ -25107,14 +25154,6 @@
 </ds:datastoreItem>
 </file>
 
-<file path=customXml/itemProps3.xml><?xml version="1.0" encoding="utf-8"?>
-<ds:datastoreItem xmlns:ds="http://schemas.openxmlformats.org/officeDocument/2006/customXml" ds:itemID="{A533346F-C811-4404-B626-0E7631B21215}">
-  <ds:schemaRefs>
-    <ds:schemaRef ds:uri="http://schemas.microsoft.com/sharepoint/v3/contenttype/forms"/>
-  </ds:schemaRefs>
-</ds:datastoreItem>
-</file>
-
 <file path=docMetadata/LabelInfo.xml><?xml version="1.0" encoding="utf-8"?>
 <clbl:labelList xmlns:clbl="http://schemas.microsoft.com/office/2020/mipLabelMetadata"/>
 </file>
</xml_diff>